<commit_message>
reviewed slide and app
</commit_message>
<xml_diff>
--- a/decks/09-self-correcting-agent.pptx
+++ b/decks/09-self-correcting-agent.pptx
@@ -2,23 +2,23 @@
 <file path=ppt/presentation.xml><?xml version="1.0" encoding="utf-8"?>
 <p:presentation xmlns:p="http://schemas.openxmlformats.org/presentationml/2006/main">
   <p:sldMasterIdLst>
-    <p:sldMasterId xmlns:r="http://schemas.openxmlformats.org/officeDocument/2006/relationships" id="2147483648" r:id="Ra06adb1fe6134127"/>
+    <p:sldMasterId xmlns:r="http://schemas.openxmlformats.org/officeDocument/2006/relationships" id="2147483648" r:id="Rf9e9b8d960544c61"/>
   </p:sldMasterIdLst>
   <p:notesMasterIdLst>
-    <p:notesMasterId xmlns:r="http://schemas.openxmlformats.org/officeDocument/2006/relationships" r:id="R3f3ae3361ca54954"/>
+    <p:notesMasterId xmlns:r="http://schemas.openxmlformats.org/officeDocument/2006/relationships" r:id="Rb0dd9ba9d1414cfe"/>
   </p:notesMasterIdLst>
   <p:sldIdLst>
-    <p:sldId xmlns:r="http://schemas.openxmlformats.org/officeDocument/2006/relationships" id="256" r:id="R45ea45e637474974"/>
-    <p:sldId xmlns:r="http://schemas.openxmlformats.org/officeDocument/2006/relationships" id="257" r:id="Rb56daa6b9f2a4a00"/>
-    <p:sldId xmlns:r="http://schemas.openxmlformats.org/officeDocument/2006/relationships" id="258" r:id="R7836dbd982c6468c"/>
-    <p:sldId xmlns:r="http://schemas.openxmlformats.org/officeDocument/2006/relationships" id="259" r:id="R60ea5daa30214f8b"/>
-    <p:sldId xmlns:r="http://schemas.openxmlformats.org/officeDocument/2006/relationships" id="260" r:id="R76692f2291294c63"/>
-    <p:sldId xmlns:r="http://schemas.openxmlformats.org/officeDocument/2006/relationships" id="261" r:id="R26f3e33a79274cbd"/>
-    <p:sldId xmlns:r="http://schemas.openxmlformats.org/officeDocument/2006/relationships" id="262" r:id="R8d201aceae8443e8"/>
-    <p:sldId xmlns:r="http://schemas.openxmlformats.org/officeDocument/2006/relationships" id="263" r:id="Re6ecdcd60d094e37"/>
-    <p:sldId xmlns:r="http://schemas.openxmlformats.org/officeDocument/2006/relationships" id="264" r:id="R8439cfdcc9ae43a0"/>
-    <p:sldId xmlns:r="http://schemas.openxmlformats.org/officeDocument/2006/relationships" id="265" r:id="R32a97381eeae45a5"/>
-    <p:sldId xmlns:r="http://schemas.openxmlformats.org/officeDocument/2006/relationships" id="266" r:id="Rc685ad48cdb74639"/>
+    <p:sldId xmlns:r="http://schemas.openxmlformats.org/officeDocument/2006/relationships" id="256" r:id="Rfb38f375b61344a0"/>
+    <p:sldId xmlns:r="http://schemas.openxmlformats.org/officeDocument/2006/relationships" id="257" r:id="R3b59f95898844af7"/>
+    <p:sldId xmlns:r="http://schemas.openxmlformats.org/officeDocument/2006/relationships" id="258" r:id="R951808d9aae64e04"/>
+    <p:sldId xmlns:r="http://schemas.openxmlformats.org/officeDocument/2006/relationships" id="259" r:id="R8880034b1bc54b5a"/>
+    <p:sldId xmlns:r="http://schemas.openxmlformats.org/officeDocument/2006/relationships" id="260" r:id="R9aa21953ccb34bd0"/>
+    <p:sldId xmlns:r="http://schemas.openxmlformats.org/officeDocument/2006/relationships" id="261" r:id="Reaba1a98cd1a43af"/>
+    <p:sldId xmlns:r="http://schemas.openxmlformats.org/officeDocument/2006/relationships" id="262" r:id="Rff7e396cb5ae44c5"/>
+    <p:sldId xmlns:r="http://schemas.openxmlformats.org/officeDocument/2006/relationships" id="263" r:id="R733389b0e6704a1f"/>
+    <p:sldId xmlns:r="http://schemas.openxmlformats.org/officeDocument/2006/relationships" id="264" r:id="R632a3c0237dd43fa"/>
+    <p:sldId xmlns:r="http://schemas.openxmlformats.org/officeDocument/2006/relationships" id="265" r:id="R7ea733255e3d469b"/>
+    <p:sldId xmlns:r="http://schemas.openxmlformats.org/officeDocument/2006/relationships" id="266" r:id="Rc065c62d477646a0"/>
   </p:sldIdLst>
   <p:sldSz cx="15240000" cy="8572500"/>
   <p:notesSz cx="6858000" cy="9144000"/>
@@ -452,7 +452,7 @@
           <a:lstStyle xmlns:a="http://schemas.openxmlformats.org/drawingml/2006/main"/>
           <a:p xmlns:a="http://schemas.openxmlformats.org/drawingml/2006/main">
             <a:r>
-              <a:t>Lesson 09 adds explicit state and recovery routing to the bounded agent from Lesson 08.</a:t>
+              <a:t>Opening: a tool error can be transformed into structured feedback, but the application owns the permission to retry.</a:t>
             </a:r>
           </a:p>
           <a:p xmlns:a="http://schemas.openxmlformats.org/drawingml/2006/main">
@@ -467,12 +467,12 @@
           </a:p>
           <a:p xmlns:a="http://schemas.openxmlformats.org/drawingml/2006/main">
             <a:r>
-              <a:t>- Course chapter: chapters/09-self-correcting-agent.md</a:t>
-            </a:r>
-          </a:p>
-          <a:p xmlns:a="http://schemas.openxmlformats.org/drawingml/2006/main">
-            <a:r>
-              <a:t>- Course notebook: notebooks/09_self_correcting_agent.ipynb</a:t>
+              <a:t>- chapters/09-self-correcting-agent.md</a:t>
+            </a:r>
+          </a:p>
+          <a:p xmlns:a="http://schemas.openxmlformats.org/drawingml/2006/main">
+            <a:r>
+              <a:t>- https://developers.openai.com/api/docs/guides/structured-outputs</a:t>
             </a:r>
           </a:p>
           <a:p xmlns:a="http://schemas.openxmlformats.org/drawingml/2006/main">
@@ -547,17 +547,12 @@
           <a:lstStyle xmlns:a="http://schemas.openxmlformats.org/drawingml/2006/main"/>
           <a:p xmlns:a="http://schemas.openxmlformats.org/drawingml/2006/main">
             <a:r>
-              <a:t>Instructor purpose: Check the three core decisions before the lesson closes.</a:t>
-            </a:r>
-          </a:p>
-          <a:p xmlns:a="http://schemas.openxmlformats.org/drawingml/2006/main">
-            <a:r>
-              <a:t>Planned timing: 3 minutes.</a:t>
-            </a:r>
-          </a:p>
-          <a:p xmlns:a="http://schemas.openxmlformats.org/drawingml/2006/main">
-            <a:r>
-              <a:t>Facilitation: ask for one letter per question.</a:t>
+              <a:t>Instructor purpose: classify errors and distinguish model recovery from system retry.</a:t>
+            </a:r>
+          </a:p>
+          <a:p xmlns:a="http://schemas.openxmlformats.org/drawingml/2006/main">
+            <a:r>
+              <a:t/>
             </a:r>
           </a:p>
           <a:p xmlns:a="http://schemas.openxmlformats.org/drawingml/2006/main">
@@ -568,6 +563,11 @@
           <a:p xmlns:a="http://schemas.openxmlformats.org/drawingml/2006/main">
             <a:r>
               <a:t>- chapters/09-self-correcting-agent.md</a:t>
+            </a:r>
+          </a:p>
+          <a:p xmlns:a="http://schemas.openxmlformats.org/drawingml/2006/main">
+            <a:r>
+              <a:t>- https://docs.langchain.com/oss/python/langgraph/thinking-in-langgraph#handle-errors-appropriately</a:t>
             </a:r>
           </a:p>
           <a:p xmlns:a="http://schemas.openxmlformats.org/drawingml/2006/main">
@@ -642,17 +642,12 @@
           <a:lstStyle xmlns:a="http://schemas.openxmlformats.org/drawingml/2006/main"/>
           <a:p xmlns:a="http://schemas.openxmlformats.org/drawingml/2006/main">
             <a:r>
-              <a:t>Instructor purpose: Correct the quiz and restate the practical rule behind each answer.</a:t>
-            </a:r>
-          </a:p>
-          <a:p xmlns:a="http://schemas.openxmlformats.org/drawingml/2006/main">
-            <a:r>
-              <a:t>Planned timing: 3 minutes.</a:t>
-            </a:r>
-          </a:p>
-          <a:p xmlns:a="http://schemas.openxmlformats.org/drawingml/2006/main">
-            <a:r>
-              <a:t>Facilitation: ask learners to explain each rule in their own words.</a:t>
+              <a:t>Instructor purpose: correct the quiz and restate the boundary of retry budgets.</a:t>
+            </a:r>
+          </a:p>
+          <a:p xmlns:a="http://schemas.openxmlformats.org/drawingml/2006/main">
+            <a:r>
+              <a:t/>
             </a:r>
           </a:p>
           <a:p xmlns:a="http://schemas.openxmlformats.org/drawingml/2006/main">
@@ -737,7 +732,7 @@
           <a:lstStyle xmlns:a="http://schemas.openxmlformats.org/drawingml/2006/main"/>
           <a:p xmlns:a="http://schemas.openxmlformats.org/drawingml/2006/main">
             <a:r>
-              <a:t>An unhandled validation error ends the application path. Recovery requires a useful observation, not only a try-and-catch block.</a:t>
+              <a:t>The baseline fails because the error terminates execution instead of becoming an observation.</a:t>
             </a:r>
           </a:p>
           <a:p xmlns:a="http://schemas.openxmlformats.org/drawingml/2006/main">
@@ -752,12 +747,12 @@
           </a:p>
           <a:p xmlns:a="http://schemas.openxmlformats.org/drawingml/2006/main">
             <a:r>
-              <a:t>- https://www.mlexpert.io/academy/v1/ai-agents/self-correcting-agent</a:t>
-            </a:r>
-          </a:p>
-          <a:p xmlns:a="http://schemas.openxmlformats.org/drawingml/2006/main">
-            <a:r>
-              <a:t>- Course chapter: chapters/09-self-correcting-agent.md</a:t>
+              <a:t>- notebooks/09_self_correcting_agent.ipynb</a:t>
+            </a:r>
+          </a:p>
+          <a:p xmlns:a="http://schemas.openxmlformats.org/drawingml/2006/main">
+            <a:r>
+              <a:t>- src/finai_academy/self_correcting_agent.py</a:t>
             </a:r>
           </a:p>
           <a:p xmlns:a="http://schemas.openxmlformats.org/drawingml/2006/main">
@@ -832,7 +827,7 @@
           <a:lstStyle xmlns:a="http://schemas.openxmlformats.org/drawingml/2006/main"/>
           <a:p xmlns:a="http://schemas.openxmlformats.org/drawingml/2006/main">
             <a:r>
-              <a:t>The graph separates the model decision node, deterministic tool node, finish node, and guardrail routes. State remains visible and serializable.</a:t>
+              <a:t>LangGraph distinguishes transient, LLM-recoverable, user-fixable, and unexpected failures. The course uses the label model-correctable for LLM-recoverable tool requests.</a:t>
             </a:r>
           </a:p>
           <a:p xmlns:a="http://schemas.openxmlformats.org/drawingml/2006/main">
@@ -847,12 +842,12 @@
           </a:p>
           <a:p xmlns:a="http://schemas.openxmlformats.org/drawingml/2006/main">
             <a:r>
-              <a:t>- https://docs.langchain.com/oss/python/langgraph/graph-api</a:t>
-            </a:r>
-          </a:p>
-          <a:p xmlns:a="http://schemas.openxmlformats.org/drawingml/2006/main">
-            <a:r>
-              <a:t>- src/finai_academy/self_correcting_agent.py</a:t>
+              <a:t>- https://docs.langchain.com/oss/python/langgraph/thinking-in-langgraph#handle-errors-appropriately</a:t>
+            </a:r>
+          </a:p>
+          <a:p xmlns:a="http://schemas.openxmlformats.org/drawingml/2006/main">
+            <a:r>
+              <a:t>- assets/lesson-09/langgraph-error-strategies.png</a:t>
             </a:r>
           </a:p>
           <a:p xmlns:a="http://schemas.openxmlformats.org/drawingml/2006/main">
@@ -927,7 +922,7 @@
           <a:lstStyle xmlns:a="http://schemas.openxmlformats.org/drawingml/2006/main"/>
           <a:p xmlns:a="http://schemas.openxmlformats.org/drawingml/2006/main">
             <a:r>
-              <a:t>The tool returns a typed error with the rejected metric and valid alternatives. This observation becomes context for the next model action.</a:t>
+              <a:t>Anthropic's evaluator-optimizer depicts generated output, evaluator feedback, and a revised attempt. In this lesson, feedback comes from an external tool contract rather than the model judging its own answer.</a:t>
             </a:r>
           </a:p>
           <a:p xmlns:a="http://schemas.openxmlformats.org/drawingml/2006/main">
@@ -942,12 +937,17 @@
           </a:p>
           <a:p xmlns:a="http://schemas.openxmlformats.org/drawingml/2006/main">
             <a:r>
-              <a:t>- https://www.mlexpert.io/academy/v1/ai-agents/self-correcting-agent</a:t>
-            </a:r>
-          </a:p>
-          <a:p xmlns:a="http://schemas.openxmlformats.org/drawingml/2006/main">
-            <a:r>
-              <a:t>- src/finai_academy/self_correcting_agent.py</a:t>
+              <a:t>- https://www.anthropic.com/engineering/building-effective-agents#workflow-evaluator-optimizer</a:t>
+            </a:r>
+          </a:p>
+          <a:p xmlns:a="http://schemas.openxmlformats.org/drawingml/2006/main">
+            <a:r>
+              <a:t>- assets/lesson-09/anthropic-evaluator-optimizer-crop.png</a:t>
+            </a:r>
+          </a:p>
+          <a:p xmlns:a="http://schemas.openxmlformats.org/drawingml/2006/main">
+            <a:r>
+              <a:t>- https://arxiv.org/abs/2310.01798</a:t>
             </a:r>
           </a:p>
           <a:p xmlns:a="http://schemas.openxmlformats.org/drawingml/2006/main">
@@ -1022,7 +1022,7 @@
           <a:lstStyle xmlns:a="http://schemas.openxmlformats.org/drawingml/2006/main"/>
           <a:p xmlns:a="http://schemas.openxmlformats.org/drawingml/2006/main">
             <a:r>
-              <a:t>Conditional edges route from the agent to tools, finish, or a guardrail. The model does not own these stop conditions.</a:t>
+              <a:t>LangGraph makes the recovery route explicit in state and conditional edges. The host validates actions and owns stop conditions.</a:t>
             </a:r>
           </a:p>
           <a:p xmlns:a="http://schemas.openxmlformats.org/drawingml/2006/main">
@@ -1042,7 +1042,7 @@
           </a:p>
           <a:p xmlns:a="http://schemas.openxmlformats.org/drawingml/2006/main">
             <a:r>
-              <a:t>- Course notebook: notebooks/09_self_correcting_agent.ipynb</a:t>
+              <a:t>- src/finai_academy/self_correcting_agent.py</a:t>
             </a:r>
           </a:p>
           <a:p xmlns:a="http://schemas.openxmlformats.org/drawingml/2006/main">
@@ -1117,7 +1117,7 @@
           <a:lstStyle xmlns:a="http://schemas.openxmlformats.org/drawingml/2006/main"/>
           <a:p xmlns:a="http://schemas.openxmlformats.org/drawingml/2006/main">
             <a:r>
-              <a:t>The first request deliberately uses PE so every classroom run exposes the structured recovery path. The fixture is controlled and not live market data.</a:t>
+              <a:t>The tool returns a typed unsupported_metric observation with the rejected value, valid alternatives, and retryability.</a:t>
             </a:r>
           </a:p>
           <a:p xmlns:a="http://schemas.openxmlformats.org/drawingml/2006/main">
@@ -1132,12 +1132,17 @@
           </a:p>
           <a:p xmlns:a="http://schemas.openxmlformats.org/drawingml/2006/main">
             <a:r>
-              <a:t>- assets/course-data/market/lesson09_metrics_snapshot_v1.json</a:t>
-            </a:r>
-          </a:p>
-          <a:p xmlns:a="http://schemas.openxmlformats.org/drawingml/2006/main">
-            <a:r>
-              <a:t>- Course notebook: notebooks/09_self_correcting_agent.ipynb</a:t>
+              <a:t>- notebooks/09_self_correcting_agent.ipynb</a:t>
+            </a:r>
+          </a:p>
+          <a:p xmlns:a="http://schemas.openxmlformats.org/drawingml/2006/main">
+            <a:r>
+              <a:t>- src/finai_academy/self_correcting_agent.py</a:t>
+            </a:r>
+          </a:p>
+          <a:p xmlns:a="http://schemas.openxmlformats.org/drawingml/2006/main">
+            <a:r>
+              <a:t>- https://developers.openai.com/api/docs/guides/function-calling</a:t>
             </a:r>
           </a:p>
           <a:p xmlns:a="http://schemas.openxmlformats.org/drawingml/2006/main">
@@ -1212,7 +1217,7 @@
           <a:lstStyle xmlns:a="http://schemas.openxmlformats.org/drawingml/2006/main"/>
           <a:p xmlns:a="http://schemas.openxmlformats.org/drawingml/2006/main">
             <a:r>
-              <a:t>The corrected trace obtains successful P/E observations for NVIDIA and Schneider Electric before finishing.</a:t>
+              <a:t>The observable correction is PE to P/E. Successful evidence for both companies is required before finish. The values are controlled course data.</a:t>
             </a:r>
           </a:p>
           <a:p xmlns:a="http://schemas.openxmlformats.org/drawingml/2006/main">
@@ -1227,12 +1232,12 @@
           </a:p>
           <a:p xmlns:a="http://schemas.openxmlformats.org/drawingml/2006/main">
             <a:r>
-              <a:t>- src/finai_academy/self_correcting_agent.py</a:t>
-            </a:r>
-          </a:p>
-          <a:p xmlns:a="http://schemas.openxmlformats.org/drawingml/2006/main">
-            <a:r>
               <a:t>- assets/course-data/market/lesson09_metrics_snapshot_v1.json</a:t>
+            </a:r>
+          </a:p>
+          <a:p xmlns:a="http://schemas.openxmlformats.org/drawingml/2006/main">
+            <a:r>
+              <a:t>- notebooks/09_self_correcting_agent.ipynb</a:t>
             </a:r>
           </a:p>
           <a:p xmlns:a="http://schemas.openxmlformats.org/drawingml/2006/main">
@@ -1307,7 +1312,7 @@
           <a:lstStyle xmlns:a="http://schemas.openxmlformats.org/drawingml/2006/main"/>
           <a:p xmlns:a="http://schemas.openxmlformats.org/drawingml/2006/main">
             <a:r>
-              <a:t>MAX_RETRIES counts model-caused validation failures. MAX_TOOL_CALLS bounds every tool execution. Neither budget guarantees answer quality.</a:t>
+              <a:t>The notebook demonstrates both a completed recovery and retry_budget_exhausted. Budgets bound execution rather than answer quality.</a:t>
             </a:r>
           </a:p>
           <a:p xmlns:a="http://schemas.openxmlformats.org/drawingml/2006/main">
@@ -1322,12 +1327,12 @@
           </a:p>
           <a:p xmlns:a="http://schemas.openxmlformats.org/drawingml/2006/main">
             <a:r>
+              <a:t>- notebooks/09_self_correcting_agent.ipynb</a:t>
+            </a:r>
+          </a:p>
+          <a:p xmlns:a="http://schemas.openxmlformats.org/drawingml/2006/main">
+            <a:r>
               <a:t>- src/finai_academy/self_correcting_agent.py</a:t>
-            </a:r>
-          </a:p>
-          <a:p xmlns:a="http://schemas.openxmlformats.org/drawingml/2006/main">
-            <a:r>
-              <a:t>- https://docs.langchain.com/oss/python/langgraph/thinking-in-langgraph</a:t>
             </a:r>
           </a:p>
           <a:p xmlns:a="http://schemas.openxmlformats.org/drawingml/2006/main">
@@ -1402,7 +1407,7 @@
           <a:lstStyle xmlns:a="http://schemas.openxmlformats.org/drawingml/2006/main"/>
           <a:p xmlns:a="http://schemas.openxmlformats.org/drawingml/2006/main">
             <a:r>
-              <a:t>Production self-correction requires precise feedback, explicit state, and hard limits. Lesson 10 exposes the same typed capabilities through MCP.</a:t>
+              <a:t>External feedback can improve the next action, but intrinsic self-correction is not a general truth guarantee. Lesson 10 moves to MCP-discovered tools.</a:t>
             </a:r>
           </a:p>
           <a:p xmlns:a="http://schemas.openxmlformats.org/drawingml/2006/main">
@@ -1417,12 +1422,12 @@
           </a:p>
           <a:p xmlns:a="http://schemas.openxmlformats.org/drawingml/2006/main">
             <a:r>
-              <a:t>- Course chapter: chapters/09-self-correcting-agent.md</a:t>
-            </a:r>
-          </a:p>
-          <a:p xmlns:a="http://schemas.openxmlformats.org/drawingml/2006/main">
-            <a:r>
-              <a:t>- Course notebook: notebooks/09_self_correcting_agent.ipynb</a:t>
+              <a:t>- https://arxiv.org/abs/2310.01798</a:t>
+            </a:r>
+          </a:p>
+          <a:p xmlns:a="http://schemas.openxmlformats.org/drawingml/2006/main">
+            <a:r>
+              <a:t>- chapters/09-self-correcting-agent.md</a:t>
             </a:r>
           </a:p>
           <a:p xmlns:a="http://schemas.openxmlformats.org/drawingml/2006/main">
@@ -1495,7 +1500,7 @@
   </p:cSld>
   <p:clrMap bg1="lt1" tx1="dk1" bg2="lt2" tx2="dk2" accent1="accent1" accent2="accent2" accent3="accent3" accent4="accent4" accent5="accent5" accent6="accent6" hlink="hlink" folHlink="folHlink"/>
   <p:sldLayoutIdLst>
-    <p:sldLayoutId xmlns:r="http://schemas.openxmlformats.org/officeDocument/2006/relationships" id="2147483649" r:id="R84bb1870d34941d1"/>
+    <p:sldLayoutId xmlns:r="http://schemas.openxmlformats.org/officeDocument/2006/relationships" id="2147483649" r:id="R60ab1c4f01164014"/>
   </p:sldLayoutIdLst>
   <p:txStyles>
     <p:titleStyle>
@@ -2193,7 +2198,7 @@
                 <a:ea typeface="Calibri"/>
                 <a:cs typeface="Calibri"/>
               </a:rPr>
-              <a:t>Self-Correcting Financial Agent</a:t>
+              <a:t>A Tool Error Can Become the Next Input</a:t>
             </a:r>
           </a:p>
         </p:txBody>
@@ -2228,7 +2233,7 @@
         </p:spPr>
         <p:txBody>
           <a:bodyPr xmlns:a="http://schemas.openxmlformats.org/drawingml/2006/main" wrap="square" lIns="0" tIns="0" rIns="0" bIns="0" anchor="ctr">
-            <a:normAutofit fontScale="100000"/>
+            <a:normAutofit fontScale="80067"/>
           </a:bodyPr>
           <a:lstStyle xmlns:a="http://schemas.openxmlformats.org/drawingml/2006/main"/>
           <a:p xmlns:a="http://schemas.openxmlformats.org/drawingml/2006/main">
@@ -2255,7 +2260,7 @@
                 <a:ea typeface="Calibri"/>
                 <a:cs typeface="Calibri"/>
               </a:rPr>
-              <a:t>Use tool errors to correct the next action</a:t>
+              <a:t>External feedback can correct an action. Application code decides whether another attempt is allowed.</a:t>
             </a:r>
           </a:p>
         </p:txBody>
@@ -2789,6 +2794,7 @@
           <a:lstStyle xmlns:a="http://schemas.openxmlformats.org/drawingml/2006/main"/>
           <a:p xmlns:a="http://schemas.openxmlformats.org/drawingml/2006/main">
             <a:pPr>
+              <a:buNone/>
               <a:defRPr sz="1500" b="1">
                 <a:solidFill>
                   <a:srgbClr val="001B2E"/>
@@ -2801,7 +2807,7 @@
                   <a:srgbClr val="001B2E"/>
                 </a:solidFill>
               </a:rPr>
-              <a:t>1. Why is a typed tool error useful?</a:t>
+              <a:t>1. Which error should loop back to the model?</a:t>
             </a:r>
           </a:p>
         </p:txBody>
@@ -2839,6 +2845,7 @@
           <a:lstStyle xmlns:a="http://schemas.openxmlformats.org/drawingml/2006/main"/>
           <a:p xmlns:a="http://schemas.openxmlformats.org/drawingml/2006/main">
             <a:pPr>
+              <a:buNone/>
               <a:defRPr sz="1200" b="0">
                 <a:solidFill>
                   <a:srgbClr val="334155"/>
@@ -2851,7 +2858,7 @@
                   <a:srgbClr val="334155"/>
                 </a:solidFill>
               </a:rPr>
-              <a:t>A  It gives correction context     |     B  It hides failure     |     C  It removes limits</a:t>
+              <a:t>A  Model-correctable     |     B  Every timeout     |     C  Unknown bug</a:t>
             </a:r>
           </a:p>
         </p:txBody>
@@ -2889,6 +2896,7 @@
           <a:lstStyle xmlns:a="http://schemas.openxmlformats.org/drawingml/2006/main"/>
           <a:p xmlns:a="http://schemas.openxmlformats.org/drawingml/2006/main">
             <a:pPr>
+              <a:buNone/>
               <a:defRPr sz="1500" b="1">
                 <a:solidFill>
                   <a:srgbClr val="001B2E"/>
@@ -2901,7 +2909,7 @@
                   <a:srgbClr val="001B2E"/>
                 </a:solidFill>
               </a:rPr>
-              <a:t>2. What does a retry budget prevent?</a:t>
+              <a:t>2. What should handle a transient timeout?</a:t>
             </a:r>
           </a:p>
         </p:txBody>
@@ -2939,6 +2947,7 @@
           <a:lstStyle xmlns:a="http://schemas.openxmlformats.org/drawingml/2006/main"/>
           <a:p xmlns:a="http://schemas.openxmlformats.org/drawingml/2006/main">
             <a:pPr>
+              <a:buNone/>
               <a:defRPr sz="1200" b="0">
                 <a:solidFill>
                   <a:srgbClr val="334155"/>
@@ -2951,7 +2960,7 @@
                   <a:srgbClr val="334155"/>
                 </a:solidFill>
               </a:rPr>
-              <a:t>A  Endless loops     |     B  Every wrong answer     |     C  Slow networks</a:t>
+              <a:t>A  System retry with backoff     |     B  Agent self-critique     |     C  Ignore it</a:t>
             </a:r>
           </a:p>
         </p:txBody>
@@ -2989,6 +2998,7 @@
           <a:lstStyle xmlns:a="http://schemas.openxmlformats.org/drawingml/2006/main"/>
           <a:p xmlns:a="http://schemas.openxmlformats.org/drawingml/2006/main">
             <a:pPr>
+              <a:buNone/>
               <a:defRPr sz="1500" b="1">
                 <a:solidFill>
                   <a:srgbClr val="001B2E"/>
@@ -3001,7 +3011,7 @@
                   <a:srgbClr val="001B2E"/>
                 </a:solidFill>
               </a:rPr>
-              <a:t>3. What is required before the agent can finish the comparison?</a:t>
+              <a:t>3. What do budgets guarantee?</a:t>
             </a:r>
           </a:p>
         </p:txBody>
@@ -3039,6 +3049,7 @@
           <a:lstStyle xmlns:a="http://schemas.openxmlformats.org/drawingml/2006/main"/>
           <a:p xmlns:a="http://schemas.openxmlformats.org/drawingml/2006/main">
             <a:pPr>
+              <a:buNone/>
               <a:defRPr sz="1200" b="0">
                 <a:solidFill>
                   <a:srgbClr val="334155"/>
@@ -3051,7 +3062,7 @@
                   <a:srgbClr val="334155"/>
                 </a:solidFill>
               </a:rPr>
-              <a:t>A  Evidence for both companies     |     B  One tool error     |     C  A longer prompt</a:t>
+              <a:t>A  Bounded behavior     |     B  Correct answers     |     C  Live data</a:t>
             </a:r>
           </a:p>
         </p:txBody>
@@ -3461,6 +3472,7 @@
           <a:lstStyle xmlns:a="http://schemas.openxmlformats.org/drawingml/2006/main"/>
           <a:p xmlns:a="http://schemas.openxmlformats.org/drawingml/2006/main">
             <a:pPr>
+              <a:buNone/>
               <a:defRPr sz="1500" b="1">
                 <a:solidFill>
                   <a:srgbClr val="1F40CB"/>
@@ -3473,7 +3485,7 @@
                   <a:srgbClr val="1F40CB"/>
                 </a:solidFill>
               </a:rPr>
-              <a:t>1. A. It gives correction context</a:t>
+              <a:t>1. A. Model-correctable</a:t>
             </a:r>
           </a:p>
         </p:txBody>
@@ -3511,6 +3523,7 @@
           <a:lstStyle xmlns:a="http://schemas.openxmlformats.org/drawingml/2006/main"/>
           <a:p xmlns:a="http://schemas.openxmlformats.org/drawingml/2006/main">
             <a:pPr>
+              <a:buNone/>
               <a:defRPr sz="1200" b="0">
                 <a:solidFill>
                   <a:srgbClr val="334155"/>
@@ -3523,7 +3536,7 @@
                   <a:srgbClr val="334155"/>
                 </a:solidFill>
               </a:rPr>
-              <a:t>The agent can change a rejected request instead of repeating it.</a:t>
+              <a:t>Return a precise observation so the model can propose a valid action.</a:t>
             </a:r>
           </a:p>
         </p:txBody>
@@ -3561,6 +3574,7 @@
           <a:lstStyle xmlns:a="http://schemas.openxmlformats.org/drawingml/2006/main"/>
           <a:p xmlns:a="http://schemas.openxmlformats.org/drawingml/2006/main">
             <a:pPr>
+              <a:buNone/>
               <a:defRPr sz="1500" b="1">
                 <a:solidFill>
                   <a:srgbClr val="1F40CB"/>
@@ -3573,7 +3587,7 @@
                   <a:srgbClr val="1F40CB"/>
                 </a:solidFill>
               </a:rPr>
-              <a:t>2. A. Endless loops</a:t>
+              <a:t>2. A. System retry with backoff</a:t>
             </a:r>
           </a:p>
         </p:txBody>
@@ -3611,6 +3625,7 @@
           <a:lstStyle xmlns:a="http://schemas.openxmlformats.org/drawingml/2006/main"/>
           <a:p xmlns:a="http://schemas.openxmlformats.org/drawingml/2006/main">
             <a:pPr>
+              <a:buNone/>
               <a:defRPr sz="1200" b="0">
                 <a:solidFill>
                   <a:srgbClr val="334155"/>
@@ -3623,7 +3638,7 @@
                   <a:srgbClr val="334155"/>
                 </a:solidFill>
               </a:rPr>
-              <a:t>A retry limit bounds behaviour but does not guarantee answer quality.</a:t>
+              <a:t>Transient infrastructure failures should not consume model reasoning retries.</a:t>
             </a:r>
           </a:p>
         </p:txBody>
@@ -3661,6 +3676,7 @@
           <a:lstStyle xmlns:a="http://schemas.openxmlformats.org/drawingml/2006/main"/>
           <a:p xmlns:a="http://schemas.openxmlformats.org/drawingml/2006/main">
             <a:pPr>
+              <a:buNone/>
               <a:defRPr sz="1500" b="1">
                 <a:solidFill>
                   <a:srgbClr val="1F40CB"/>
@@ -3673,7 +3689,7 @@
                   <a:srgbClr val="1F40CB"/>
                 </a:solidFill>
               </a:rPr>
-              <a:t>3. A. Evidence for both companies</a:t>
+              <a:t>3. A. Bounded behavior</a:t>
             </a:r>
           </a:p>
         </p:txBody>
@@ -3711,6 +3727,7 @@
           <a:lstStyle xmlns:a="http://schemas.openxmlformats.org/drawingml/2006/main"/>
           <a:p xmlns:a="http://schemas.openxmlformats.org/drawingml/2006/main">
             <a:pPr>
+              <a:buNone/>
               <a:defRPr sz="1200" b="0">
                 <a:solidFill>
                   <a:srgbClr val="334155"/>
@@ -3723,7 +3740,7 @@
                   <a:srgbClr val="334155"/>
                 </a:solidFill>
               </a:rPr>
-              <a:t>The final comparison must be supported by successful observations.</a:t>
+              <a:t>Budgets stop loops; they do not prove the final answer is true.</a:t>
             </a:r>
           </a:p>
         </p:txBody>
@@ -3876,7 +3893,7 @@
                 <a:ea typeface="Calibri"/>
                 <a:cs typeface="Calibri"/>
               </a:rPr>
-              <a:t>An unhandled tool error ends the task</a:t>
+              <a:t>An unhandled error ends the task</a:t>
             </a:r>
           </a:p>
         </p:txBody>
@@ -4035,7 +4052,7 @@
                 <a:ea typeface="Calibri"/>
                 <a:cs typeface="Calibri"/>
               </a:rPr>
-              <a:t>User question</a:t>
+              <a:t>Question</a:t>
             </a:r>
           </a:p>
         </p:txBody>
@@ -4256,7 +4273,7 @@
                 <a:ea typeface="Calibri"/>
                 <a:cs typeface="Calibri"/>
               </a:rPr>
-              <a:t>Agent request</a:t>
+              <a:t>Agent</a:t>
             </a:r>
           </a:p>
         </p:txBody>
@@ -4477,7 +4494,7 @@
                 <a:ea typeface="Calibri"/>
                 <a:cs typeface="Calibri"/>
               </a:rPr>
-              <a:t>Validation</a:t>
+              <a:t>Tool</a:t>
             </a:r>
           </a:p>
         </p:txBody>
@@ -4988,7 +5005,7 @@
       </p:sp>
       <p:cxnSp>
         <p:nvCxnSpPr>
-          <p:cNvPr id="577" name=""/>
+          <p:cNvPr id="629" name=""/>
           <p:cNvCxnSpPr>
             <a:stCxn xmlns:a="http://schemas.openxmlformats.org/drawingml/2006/main" id="3" idx="3"/>
             <a:endCxn xmlns:a="http://schemas.openxmlformats.org/drawingml/2006/main" id="7" idx="1"/>
@@ -5014,7 +5031,7 @@
       </p:cxnSp>
       <p:cxnSp>
         <p:nvCxnSpPr>
-          <p:cNvPr id="578" name=""/>
+          <p:cNvPr id="630" name=""/>
           <p:cNvCxnSpPr>
             <a:stCxn xmlns:a="http://schemas.openxmlformats.org/drawingml/2006/main" id="7" idx="3"/>
             <a:endCxn xmlns:a="http://schemas.openxmlformats.org/drawingml/2006/main" id="11" idx="1"/>
@@ -5040,7 +5057,7 @@
       </p:cxnSp>
       <p:cxnSp>
         <p:nvCxnSpPr>
-          <p:cNvPr id="579" name=""/>
+          <p:cNvPr id="631" name=""/>
           <p:cNvCxnSpPr>
             <a:stCxn xmlns:a="http://schemas.openxmlformats.org/drawingml/2006/main" id="11" idx="3"/>
             <a:endCxn xmlns:a="http://schemas.openxmlformats.org/drawingml/2006/main" id="15" idx="1"/>
@@ -5066,7 +5083,7 @@
       </p:cxnSp>
       <p:cxnSp>
         <p:nvCxnSpPr>
-          <p:cNvPr id="580" name=""/>
+          <p:cNvPr id="632" name=""/>
           <p:cNvCxnSpPr>
             <a:stCxn xmlns:a="http://schemas.openxmlformats.org/drawingml/2006/main" id="15" idx="3"/>
             <a:endCxn xmlns:a="http://schemas.openxmlformats.org/drawingml/2006/main" id="19" idx="1"/>
@@ -5147,7 +5164,7 @@
                 <a:ea typeface="Calibri"/>
                 <a:cs typeface="Calibri"/>
               </a:rPr>
-              <a:t>Catching the error is not enough. The model needs useful feedback.</a:t>
+              <a:t>Catching the error is not enough. The next action needs useful feedback.</a:t>
             </a:r>
           </a:p>
         </p:txBody>
@@ -5614,7 +5631,7 @@
                 <a:ea typeface="Calibri"/>
                 <a:cs typeface="Calibri"/>
               </a:rPr>
-              <a:t>EXPLICIT GRAPH STATE</a:t>
+              <a:t>OFFICIAL ERROR STRATEGIES</a:t>
             </a:r>
           </a:p>
         </p:txBody>
@@ -5676,39 +5693,161 @@
                 <a:ea typeface="Calibri"/>
                 <a:cs typeface="Calibri"/>
               </a:rPr>
-              <a:t>LangGraph makes every route visible</a:t>
-            </a:r>
-          </a:p>
-        </p:txBody>
-      </p:sp>
-      <p:sp>
-        <p:nvSpPr>
-          <p:cNvPr id="3" name="decision-source">
-            <a:extLst xmlns:a="http://schemas.openxmlformats.org/drawingml/2006/main">
-              <a:ext uri="{FF2B5EF4-FFF2-40B4-BE49-F238E27FC236}">
-                <a16:creationId xmlns:a16="http://schemas.microsoft.com/office/drawing/2014/main" id="{F0F1628B-25FC-4A7D-9ACB-11ED41518DD3}"/>
-              </a:ext>
-            </a:extLst>
-          </p:cNvPr>
-          <p:cNvSpPr>
-            <a:spLocks xmlns:a="http://schemas.openxmlformats.org/drawingml/2006/main" noGrp="1"/>
-          </p:cNvSpPr>
-          <p:nvPr/>
-        </p:nvSpPr>
-        <p:spPr>
-          <a:xfrm xmlns:a="http://schemas.openxmlformats.org/drawingml/2006/main">
-            <a:off x="1028700" y="2990850"/>
-            <a:ext cx="2724150" cy="1562100"/>
-          </a:xfrm>
-          <a:prstGeom xmlns:a="http://schemas.openxmlformats.org/drawingml/2006/main" prst="roundRect">
-            <a:avLst>
-              <a:gd name="adj" fmla="val 7317"/>
-            </a:avLst>
+              <a:t>Errors need different recovery strategies</a:t>
+            </a:r>
+          </a:p>
+        </p:txBody>
+      </p:sp>
+      <p:sp>
+        <p:nvSpPr>
+          <p:cNvPr id="21" name="">
+            <a:extLst xmlns:a="http://schemas.openxmlformats.org/drawingml/2006/main">
+              <a:ext uri="{FF2B5EF4-FFF2-40B4-BE49-F238E27FC236}">
+                <a16:creationId xmlns:a16="http://schemas.microsoft.com/office/drawing/2014/main" id="{BCAA4B4E-BD27-48A6-A4E1-ACF33C620C4D}"/>
+              </a:ext>
+            </a:extLst>
+          </p:cNvPr>
+          <p:cNvSpPr>
+            <a:spLocks xmlns:a="http://schemas.openxmlformats.org/drawingml/2006/main" noGrp="1"/>
+          </p:cNvSpPr>
+          <p:nvPr/>
+        </p:nvSpPr>
+        <p:spPr>
+          <a:xfrm xmlns:a="http://schemas.openxmlformats.org/drawingml/2006/main">
+            <a:off x="1028700" y="7086600"/>
+            <a:ext cx="1524000" cy="323850"/>
+          </a:xfrm>
+          <a:prstGeom xmlns:a="http://schemas.openxmlformats.org/drawingml/2006/main" prst="rect">
+            <a:avLst/>
+          </a:prstGeom>
+          <a:noFill xmlns:a="http://schemas.openxmlformats.org/drawingml/2006/main"/>
+          <a:ln xmlns:a="http://schemas.openxmlformats.org/drawingml/2006/main" w="0">
+            <a:noFill/>
+            <a:prstDash val="solid"/>
+          </a:ln>
+        </p:spPr>
+        <p:txBody>
+          <a:bodyPr xmlns:a="http://schemas.openxmlformats.org/drawingml/2006/main" wrap="square" lIns="0" tIns="0" rIns="0" bIns="0" anchor="ctr">
+            <a:noAutofit/>
+          </a:bodyPr>
+          <a:lstStyle xmlns:a="http://schemas.openxmlformats.org/drawingml/2006/main"/>
+          <a:p xmlns:a="http://schemas.openxmlformats.org/drawingml/2006/main">
+            <a:pPr algn="l">
+              <a:lnSpc>
+                <a:spcPct val="100000"/>
+              </a:lnSpc>
+              <a:buNone/>
+              <a:defRPr sz="1350" b="1">
+                <a:solidFill>
+                  <a:srgbClr val="F07D00"/>
+                </a:solidFill>
+                <a:latin typeface="Calibri"/>
+                <a:ea typeface="Calibri"/>
+                <a:cs typeface="Calibri"/>
+              </a:defRPr>
+            </a:pPr>
+            <a:r>
+              <a:rPr sz="1800" b="1">
+                <a:solidFill>
+                  <a:srgbClr val="F07D00"/>
+                </a:solidFill>
+                <a:latin typeface="Calibri"/>
+                <a:ea typeface="Calibri"/>
+                <a:cs typeface="Calibri"/>
+              </a:rPr>
+              <a:t>LANGGRAPH</a:t>
+            </a:r>
+          </a:p>
+        </p:txBody>
+      </p:sp>
+      <p:sp>
+        <p:nvSpPr>
+          <p:cNvPr id="22" name="">
+            <a:extLst xmlns:a="http://schemas.openxmlformats.org/drawingml/2006/main">
+              <a:ext uri="{FF2B5EF4-FFF2-40B4-BE49-F238E27FC236}">
+                <a16:creationId xmlns:a16="http://schemas.microsoft.com/office/drawing/2014/main" id="{539B97AA-C4C9-4A8D-997E-C7AD0F311AD6}"/>
+              </a:ext>
+            </a:extLst>
+          </p:cNvPr>
+          <p:cNvSpPr>
+            <a:spLocks xmlns:a="http://schemas.openxmlformats.org/drawingml/2006/main" noGrp="1"/>
+          </p:cNvSpPr>
+          <p:nvPr/>
+        </p:nvSpPr>
+        <p:spPr>
+          <a:xfrm xmlns:a="http://schemas.openxmlformats.org/drawingml/2006/main">
+            <a:off x="2705100" y="6991350"/>
+            <a:ext cx="11410950" cy="476250"/>
+          </a:xfrm>
+          <a:prstGeom xmlns:a="http://schemas.openxmlformats.org/drawingml/2006/main" prst="rect">
+            <a:avLst/>
+          </a:prstGeom>
+          <a:noFill xmlns:a="http://schemas.openxmlformats.org/drawingml/2006/main"/>
+          <a:ln xmlns:a="http://schemas.openxmlformats.org/drawingml/2006/main" w="0">
+            <a:noFill/>
+            <a:prstDash val="solid"/>
+          </a:ln>
+        </p:spPr>
+        <p:txBody>
+          <a:bodyPr xmlns:a="http://schemas.openxmlformats.org/drawingml/2006/main" wrap="square" lIns="0" tIns="0" rIns="0" bIns="0" anchor="ctr">
+            <a:normAutofit fontScale="100000"/>
+          </a:bodyPr>
+          <a:lstStyle xmlns:a="http://schemas.openxmlformats.org/drawingml/2006/main"/>
+          <a:p xmlns:a="http://schemas.openxmlformats.org/drawingml/2006/main">
+            <a:pPr algn="l">
+              <a:lnSpc>
+                <a:spcPct val="100000"/>
+              </a:lnSpc>
+              <a:buNone/>
+              <a:defRPr sz="1875" b="1">
+                <a:solidFill>
+                  <a:srgbClr val="1F40CB"/>
+                </a:solidFill>
+                <a:latin typeface="Calibri"/>
+                <a:ea typeface="Calibri"/>
+                <a:cs typeface="Calibri"/>
+              </a:defRPr>
+            </a:pPr>
+            <a:r>
+              <a:rPr sz="1875" b="1">
+                <a:solidFill>
+                  <a:srgbClr val="1F40CB"/>
+                </a:solidFill>
+                <a:latin typeface="Calibri"/>
+                <a:ea typeface="Calibri"/>
+                <a:cs typeface="Calibri"/>
+              </a:rPr>
+              <a:t>TRANSIENT · MODEL-CORRECTABLE · USER-FIXABLE · UNEXPECTED</a:t>
+            </a:r>
+          </a:p>
+        </p:txBody>
+      </p:sp>
+      <p:sp>
+        <p:nvSpPr>
+          <p:cNvPr id="23" name="">
+            <a:extLst xmlns:a="http://schemas.openxmlformats.org/drawingml/2006/main">
+              <a:ext uri="{FF2B5EF4-FFF2-40B4-BE49-F238E27FC236}">
+                <a16:creationId xmlns:a16="http://schemas.microsoft.com/office/drawing/2014/main" id="{3CA8D079-E333-430B-9198-F3840FF42229}"/>
+              </a:ext>
+            </a:extLst>
+          </p:cNvPr>
+          <p:cNvSpPr>
+            <a:spLocks xmlns:a="http://schemas.openxmlformats.org/drawingml/2006/main" noGrp="1"/>
+          </p:cNvSpPr>
+          <p:nvPr/>
+        </p:nvSpPr>
+        <p:spPr>
+          <a:xfrm xmlns:a="http://schemas.openxmlformats.org/drawingml/2006/main">
+            <a:off x="857250" y="7896225"/>
+            <a:ext cx="13525500" cy="28575"/>
+          </a:xfrm>
+          <a:prstGeom xmlns:a="http://schemas.openxmlformats.org/drawingml/2006/main" prst="rect">
+            <a:avLst/>
           </a:prstGeom>
           <a:solidFill xmlns:a="http://schemas.openxmlformats.org/drawingml/2006/main">
-            <a:srgbClr val="FFFFFF"/>
+            <a:srgbClr val="E4E7E9"/>
           </a:solidFill>
-          <a:ln xmlns:a="http://schemas.openxmlformats.org/drawingml/2006/main" w="9525">
+          <a:ln xmlns:a="http://schemas.openxmlformats.org/drawingml/2006/main" w="0">
             <a:solidFill>
               <a:srgbClr val="E4E7E9"/>
             </a:solidFill>
@@ -5718,183 +5857,30 @@
       </p:sp>
       <p:sp>
         <p:nvSpPr>
-          <p:cNvPr id="4" name="">
-            <a:extLst xmlns:a="http://schemas.openxmlformats.org/drawingml/2006/main">
-              <a:ext uri="{FF2B5EF4-FFF2-40B4-BE49-F238E27FC236}">
-                <a16:creationId xmlns:a16="http://schemas.microsoft.com/office/drawing/2014/main" id="{62CDE4FD-810A-4BB6-A9E2-9D453E2B432E}"/>
-              </a:ext>
-            </a:extLst>
-          </p:cNvPr>
-          <p:cNvSpPr>
-            <a:spLocks xmlns:a="http://schemas.openxmlformats.org/drawingml/2006/main" noGrp="1"/>
-          </p:cNvSpPr>
-          <p:nvPr/>
-        </p:nvSpPr>
-        <p:spPr>
-          <a:xfrm xmlns:a="http://schemas.openxmlformats.org/drawingml/2006/main">
-            <a:off x="1295400" y="3181350"/>
-            <a:ext cx="2190750" cy="323850"/>
-          </a:xfrm>
-          <a:prstGeom xmlns:a="http://schemas.openxmlformats.org/drawingml/2006/main" prst="rect">
-            <a:avLst/>
-          </a:prstGeom>
-          <a:noFill xmlns:a="http://schemas.openxmlformats.org/drawingml/2006/main"/>
-          <a:ln xmlns:a="http://schemas.openxmlformats.org/drawingml/2006/main" w="0">
-            <a:noFill/>
-            <a:prstDash val="solid"/>
-          </a:ln>
-        </p:spPr>
-        <p:txBody>
-          <a:bodyPr xmlns:a="http://schemas.openxmlformats.org/drawingml/2006/main" wrap="square" lIns="0" tIns="0" rIns="0" bIns="0" anchor="ctr">
-            <a:noAutofit/>
-          </a:bodyPr>
-          <a:lstStyle xmlns:a="http://schemas.openxmlformats.org/drawingml/2006/main"/>
-          <a:p xmlns:a="http://schemas.openxmlformats.org/drawingml/2006/main">
-            <a:pPr algn="ctr">
-              <a:lnSpc>
-                <a:spcPct val="100000"/>
-              </a:lnSpc>
-              <a:buNone/>
-              <a:defRPr sz="1350" b="1">
-                <a:solidFill>
-                  <a:srgbClr val="1F40CB"/>
-                </a:solidFill>
-                <a:latin typeface="Calibri"/>
-                <a:ea typeface="Calibri"/>
-                <a:cs typeface="Calibri"/>
-              </a:defRPr>
-            </a:pPr>
-            <a:r>
-              <a:rPr sz="1800" b="1">
-                <a:solidFill>
-                  <a:srgbClr val="1F40CB"/>
-                </a:solidFill>
-                <a:latin typeface="Calibri"/>
-                <a:ea typeface="Calibri"/>
-                <a:cs typeface="Calibri"/>
-              </a:rPr>
-              <a:t>AGENT</a:t>
-            </a:r>
-          </a:p>
-        </p:txBody>
-      </p:sp>
-      <p:sp>
-        <p:nvSpPr>
-          <p:cNvPr id="5" name="">
-            <a:extLst xmlns:a="http://schemas.openxmlformats.org/drawingml/2006/main">
-              <a:ext uri="{FF2B5EF4-FFF2-40B4-BE49-F238E27FC236}">
-                <a16:creationId xmlns:a16="http://schemas.microsoft.com/office/drawing/2014/main" id="{25AA52CC-262C-4723-8C2E-E43262748B6A}"/>
-              </a:ext>
-            </a:extLst>
-          </p:cNvPr>
-          <p:cNvSpPr>
-            <a:spLocks xmlns:a="http://schemas.openxmlformats.org/drawingml/2006/main" noGrp="1"/>
-          </p:cNvSpPr>
-          <p:nvPr/>
-        </p:nvSpPr>
-        <p:spPr>
-          <a:xfrm xmlns:a="http://schemas.openxmlformats.org/drawingml/2006/main">
-            <a:off x="1295400" y="3657600"/>
-            <a:ext cx="2190750" cy="647700"/>
-          </a:xfrm>
-          <a:prstGeom xmlns:a="http://schemas.openxmlformats.org/drawingml/2006/main" prst="rect">
-            <a:avLst/>
-          </a:prstGeom>
-          <a:noFill xmlns:a="http://schemas.openxmlformats.org/drawingml/2006/main"/>
-          <a:ln xmlns:a="http://schemas.openxmlformats.org/drawingml/2006/main" w="0">
-            <a:noFill/>
-            <a:prstDash val="solid"/>
-          </a:ln>
-        </p:spPr>
-        <p:txBody>
-          <a:bodyPr xmlns:a="http://schemas.openxmlformats.org/drawingml/2006/main" wrap="square" lIns="0" tIns="0" rIns="0" bIns="0" anchor="ctr">
-            <a:normAutofit fontScale="100000"/>
-          </a:bodyPr>
-          <a:lstStyle xmlns:a="http://schemas.openxmlformats.org/drawingml/2006/main"/>
-          <a:p xmlns:a="http://schemas.openxmlformats.org/drawingml/2006/main">
-            <a:pPr algn="ctr">
-              <a:lnSpc>
-                <a:spcPct val="100000"/>
-              </a:lnSpc>
-              <a:buNone/>
-              <a:defRPr sz="1650" b="1">
-                <a:solidFill>
-                  <a:srgbClr val="051C2A"/>
-                </a:solidFill>
-                <a:latin typeface="Calibri"/>
-                <a:ea typeface="Calibri"/>
-                <a:cs typeface="Calibri"/>
-              </a:defRPr>
-            </a:pPr>
-            <a:r>
-              <a:rPr sz="1650" b="1">
-                <a:solidFill>
-                  <a:srgbClr val="051C2A"/>
-                </a:solidFill>
-                <a:latin typeface="Calibri"/>
-                <a:ea typeface="Calibri"/>
-                <a:cs typeface="Calibri"/>
-              </a:rPr>
-              <a:t>reads state</a:t>
-            </a:r>
-          </a:p>
-          <a:p xmlns:a="http://schemas.openxmlformats.org/drawingml/2006/main">
-            <a:pPr algn="ctr">
-              <a:lnSpc>
-                <a:spcPct val="100000"/>
-              </a:lnSpc>
-              <a:buNone/>
-              <a:defRPr sz="1650" b="1">
-                <a:solidFill>
-                  <a:srgbClr val="051C2A"/>
-                </a:solidFill>
-                <a:latin typeface="Calibri"/>
-                <a:ea typeface="Calibri"/>
-                <a:cs typeface="Calibri"/>
-              </a:defRPr>
-            </a:pPr>
-            <a:r>
-              <a:rPr sz="1650" b="1">
-                <a:solidFill>
-                  <a:srgbClr val="051C2A"/>
-                </a:solidFill>
-                <a:latin typeface="Calibri"/>
-                <a:ea typeface="Calibri"/>
-                <a:cs typeface="Calibri"/>
-              </a:rPr>
-              <a:t>chooses action</a:t>
-            </a:r>
-          </a:p>
-        </p:txBody>
-      </p:sp>
-      <p:sp>
-        <p:nvSpPr>
-          <p:cNvPr id="6" name="decision-child">
-            <a:extLst xmlns:a="http://schemas.openxmlformats.org/drawingml/2006/main">
-              <a:ext uri="{FF2B5EF4-FFF2-40B4-BE49-F238E27FC236}">
-                <a16:creationId xmlns:a16="http://schemas.microsoft.com/office/drawing/2014/main" id="{E359D7F5-9555-4867-8587-2F8EC5254E07}"/>
-              </a:ext>
-            </a:extLst>
-          </p:cNvPr>
-          <p:cNvSpPr>
-            <a:spLocks xmlns:a="http://schemas.openxmlformats.org/drawingml/2006/main" noGrp="1"/>
-          </p:cNvSpPr>
-          <p:nvPr/>
-        </p:nvSpPr>
-        <p:spPr>
-          <a:xfrm xmlns:a="http://schemas.openxmlformats.org/drawingml/2006/main">
-            <a:off x="5162550" y="2857500"/>
-            <a:ext cx="3257550" cy="1828800"/>
-          </a:xfrm>
-          <a:prstGeom xmlns:a="http://schemas.openxmlformats.org/drawingml/2006/main" prst="roundRect">
-            <a:avLst>
-              <a:gd name="adj" fmla="val 6250"/>
-            </a:avLst>
+          <p:cNvPr id="24" name="">
+            <a:extLst xmlns:a="http://schemas.openxmlformats.org/drawingml/2006/main">
+              <a:ext uri="{FF2B5EF4-FFF2-40B4-BE49-F238E27FC236}">
+                <a16:creationId xmlns:a16="http://schemas.microsoft.com/office/drawing/2014/main" id="{56B1FA6E-7D19-4BD4-95AB-A7A96F2D9D4D}"/>
+              </a:ext>
+            </a:extLst>
+          </p:cNvPr>
+          <p:cNvSpPr>
+            <a:spLocks xmlns:a="http://schemas.openxmlformats.org/drawingml/2006/main" noGrp="1"/>
+          </p:cNvSpPr>
+          <p:nvPr/>
+        </p:nvSpPr>
+        <p:spPr>
+          <a:xfrm xmlns:a="http://schemas.openxmlformats.org/drawingml/2006/main">
+            <a:off x="857250" y="7896225"/>
+            <a:ext cx="8001000" cy="38100"/>
+          </a:xfrm>
+          <a:prstGeom xmlns:a="http://schemas.openxmlformats.org/drawingml/2006/main" prst="rect">
+            <a:avLst/>
           </a:prstGeom>
           <a:solidFill xmlns:a="http://schemas.openxmlformats.org/drawingml/2006/main">
-            <a:srgbClr val="E8F6FB"/>
+            <a:srgbClr val="00A2EB"/>
           </a:solidFill>
-          <a:ln xmlns:a="http://schemas.openxmlformats.org/drawingml/2006/main" w="19050">
+          <a:ln xmlns:a="http://schemas.openxmlformats.org/drawingml/2006/main" w="0">
             <a:solidFill>
               <a:srgbClr val="00A2EB"/>
             </a:solidFill>
@@ -5904,398 +5890,22 @@
       </p:sp>
       <p:sp>
         <p:nvSpPr>
-          <p:cNvPr id="7" name="">
-            <a:extLst xmlns:a="http://schemas.openxmlformats.org/drawingml/2006/main">
-              <a:ext uri="{FF2B5EF4-FFF2-40B4-BE49-F238E27FC236}">
-                <a16:creationId xmlns:a16="http://schemas.microsoft.com/office/drawing/2014/main" id="{14C45E62-2BDC-4F11-8E8E-92ACD6B6E61D}"/>
-              </a:ext>
-            </a:extLst>
-          </p:cNvPr>
-          <p:cNvSpPr>
-            <a:spLocks xmlns:a="http://schemas.openxmlformats.org/drawingml/2006/main" noGrp="1"/>
-          </p:cNvSpPr>
-          <p:nvPr/>
-        </p:nvSpPr>
-        <p:spPr>
-          <a:xfrm xmlns:a="http://schemas.openxmlformats.org/drawingml/2006/main">
-            <a:off x="5467350" y="2914650"/>
-            <a:ext cx="2647950" cy="476250"/>
-          </a:xfrm>
-          <a:prstGeom xmlns:a="http://schemas.openxmlformats.org/drawingml/2006/main" prst="rect">
-            <a:avLst/>
-          </a:prstGeom>
-          <a:noFill xmlns:a="http://schemas.openxmlformats.org/drawingml/2006/main"/>
-          <a:ln xmlns:a="http://schemas.openxmlformats.org/drawingml/2006/main" w="0">
-            <a:noFill/>
-            <a:prstDash val="solid"/>
-          </a:ln>
-        </p:spPr>
-        <p:txBody>
-          <a:bodyPr xmlns:a="http://schemas.openxmlformats.org/drawingml/2006/main" wrap="square" lIns="0" tIns="0" rIns="0" bIns="0" anchor="ctr">
-            <a:noAutofit/>
-          </a:bodyPr>
-          <a:lstStyle xmlns:a="http://schemas.openxmlformats.org/drawingml/2006/main"/>
-          <a:p xmlns:a="http://schemas.openxmlformats.org/drawingml/2006/main">
-            <a:pPr algn="ctr">
-              <a:lnSpc>
-                <a:spcPct val="100000"/>
-              </a:lnSpc>
-              <a:buNone/>
-              <a:defRPr sz="1275" b="1">
-                <a:solidFill>
-                  <a:srgbClr val="00A2EB"/>
-                </a:solidFill>
-                <a:latin typeface="Calibri"/>
-                <a:ea typeface="Calibri"/>
-                <a:cs typeface="Calibri"/>
-              </a:defRPr>
-            </a:pPr>
-            <a:r>
-              <a:rPr sz="1800" b="1">
-                <a:solidFill>
-                  <a:srgbClr val="00A2EB"/>
-                </a:solidFill>
-                <a:latin typeface="Calibri"/>
-                <a:ea typeface="Calibri"/>
-                <a:cs typeface="Calibri"/>
-              </a:rPr>
-              <a:t>TOOL</a:t>
-            </a:r>
-            <a:br/>
-            <a:r>
-              <a:rPr sz="1800" b="1">
-                <a:solidFill>
-                  <a:srgbClr val="00A2EB"/>
-                </a:solidFill>
-                <a:latin typeface="Calibri"/>
-                <a:ea typeface="Calibri"/>
-                <a:cs typeface="Calibri"/>
-              </a:rPr>
-              <a:t>NODE</a:t>
-            </a:r>
-          </a:p>
-        </p:txBody>
-      </p:sp>
-      <p:sp>
-        <p:nvSpPr>
-          <p:cNvPr id="8" name="">
-            <a:extLst xmlns:a="http://schemas.openxmlformats.org/drawingml/2006/main">
-              <a:ext uri="{FF2B5EF4-FFF2-40B4-BE49-F238E27FC236}">
-                <a16:creationId xmlns:a16="http://schemas.microsoft.com/office/drawing/2014/main" id="{9FF2A998-C21C-458F-BEED-486513923D87}"/>
-              </a:ext>
-            </a:extLst>
-          </p:cNvPr>
-          <p:cNvSpPr>
-            <a:spLocks xmlns:a="http://schemas.openxmlformats.org/drawingml/2006/main" noGrp="1"/>
-          </p:cNvSpPr>
-          <p:nvPr/>
-        </p:nvSpPr>
-        <p:spPr>
-          <a:xfrm xmlns:a="http://schemas.openxmlformats.org/drawingml/2006/main">
-            <a:off x="5467350" y="3390900"/>
-            <a:ext cx="2647950" cy="800100"/>
-          </a:xfrm>
-          <a:prstGeom xmlns:a="http://schemas.openxmlformats.org/drawingml/2006/main" prst="rect">
-            <a:avLst/>
-          </a:prstGeom>
-          <a:noFill xmlns:a="http://schemas.openxmlformats.org/drawingml/2006/main"/>
-          <a:ln xmlns:a="http://schemas.openxmlformats.org/drawingml/2006/main" w="0">
-            <a:noFill/>
-            <a:prstDash val="solid"/>
-          </a:ln>
-        </p:spPr>
-        <p:txBody>
-          <a:bodyPr xmlns:a="http://schemas.openxmlformats.org/drawingml/2006/main" wrap="square" lIns="0" tIns="0" rIns="0" bIns="0" anchor="ctr">
-            <a:noAutofit/>
-          </a:bodyPr>
-          <a:lstStyle xmlns:a="http://schemas.openxmlformats.org/drawingml/2006/main"/>
-          <a:p xmlns:a="http://schemas.openxmlformats.org/drawingml/2006/main">
-            <a:pPr algn="ctr">
-              <a:lnSpc>
-                <a:spcPct val="80000"/>
-              </a:lnSpc>
-              <a:buNone/>
-              <a:defRPr sz="2175" b="1">
-                <a:solidFill>
-                  <a:srgbClr val="051C2A"/>
-                </a:solidFill>
-                <a:latin typeface="Calibri"/>
-                <a:ea typeface="Calibri"/>
-                <a:cs typeface="Calibri"/>
-              </a:defRPr>
-            </a:pPr>
-            <a:r>
-              <a:rPr sz="1800" b="1">
-                <a:solidFill>
-                  <a:srgbClr val="051C2A"/>
-                </a:solidFill>
-                <a:latin typeface="Calibri"/>
-                <a:ea typeface="Calibri"/>
-                <a:cs typeface="Calibri"/>
-              </a:rPr>
-              <a:t>validate request</a:t>
-            </a:r>
-          </a:p>
-          <a:p xmlns:a="http://schemas.openxmlformats.org/drawingml/2006/main">
-            <a:pPr algn="ctr">
-              <a:lnSpc>
-                <a:spcPct val="80000"/>
-              </a:lnSpc>
-              <a:buNone/>
-              <a:defRPr sz="2175" b="1">
-                <a:solidFill>
-                  <a:srgbClr val="051C2A"/>
-                </a:solidFill>
-                <a:latin typeface="Calibri"/>
-                <a:ea typeface="Calibri"/>
-                <a:cs typeface="Calibri"/>
-              </a:defRPr>
-            </a:pPr>
-            <a:r>
-              <a:rPr sz="1800" b="1">
-                <a:solidFill>
-                  <a:srgbClr val="051C2A"/>
-                </a:solidFill>
-                <a:latin typeface="Calibri"/>
-                <a:ea typeface="Calibri"/>
-                <a:cs typeface="Calibri"/>
-              </a:rPr>
-              <a:t>result or error</a:t>
-            </a:r>
-          </a:p>
-          <a:p xmlns:a="http://schemas.openxmlformats.org/drawingml/2006/main">
-            <a:pPr algn="ctr">
-              <a:lnSpc>
-                <a:spcPct val="80000"/>
-              </a:lnSpc>
-              <a:buNone/>
-              <a:defRPr sz="2175" b="1">
-                <a:solidFill>
-                  <a:srgbClr val="051C2A"/>
-                </a:solidFill>
-                <a:latin typeface="Calibri"/>
-                <a:ea typeface="Calibri"/>
-                <a:cs typeface="Calibri"/>
-              </a:defRPr>
-            </a:pPr>
-            <a:r>
-              <a:rPr sz="1800" b="1">
-                <a:solidFill>
-                  <a:srgbClr val="051C2A"/>
-                </a:solidFill>
-                <a:latin typeface="Calibri"/>
-                <a:ea typeface="Calibri"/>
-                <a:cs typeface="Calibri"/>
-              </a:rPr>
-              <a:t>error_count</a:t>
-            </a:r>
-          </a:p>
-        </p:txBody>
-      </p:sp>
-      <p:sp>
-        <p:nvSpPr>
-          <p:cNvPr id="9" name="">
-            <a:extLst xmlns:a="http://schemas.openxmlformats.org/drawingml/2006/main">
-              <a:ext uri="{FF2B5EF4-FFF2-40B4-BE49-F238E27FC236}">
-                <a16:creationId xmlns:a16="http://schemas.microsoft.com/office/drawing/2014/main" id="{EE8A313B-A32E-4318-B50D-32C786561C84}"/>
-              </a:ext>
-            </a:extLst>
-          </p:cNvPr>
-          <p:cNvSpPr>
-            <a:spLocks xmlns:a="http://schemas.openxmlformats.org/drawingml/2006/main" noGrp="1"/>
-          </p:cNvSpPr>
-          <p:nvPr/>
-        </p:nvSpPr>
-        <p:spPr>
-          <a:xfrm xmlns:a="http://schemas.openxmlformats.org/drawingml/2006/main">
-            <a:off x="5467350" y="4191000"/>
-            <a:ext cx="2647950" cy="476250"/>
-          </a:xfrm>
-          <a:prstGeom xmlns:a="http://schemas.openxmlformats.org/drawingml/2006/main" prst="rect">
-            <a:avLst/>
-          </a:prstGeom>
-          <a:noFill xmlns:a="http://schemas.openxmlformats.org/drawingml/2006/main"/>
-          <a:ln xmlns:a="http://schemas.openxmlformats.org/drawingml/2006/main" w="0">
-            <a:noFill/>
-            <a:prstDash val="solid"/>
-          </a:ln>
-        </p:spPr>
-        <p:txBody>
-          <a:bodyPr xmlns:a="http://schemas.openxmlformats.org/drawingml/2006/main" wrap="square" lIns="0" tIns="0" rIns="0" bIns="0" anchor="ctr">
-            <a:noAutofit/>
-          </a:bodyPr>
-          <a:lstStyle xmlns:a="http://schemas.openxmlformats.org/drawingml/2006/main"/>
-          <a:p xmlns:a="http://schemas.openxmlformats.org/drawingml/2006/main">
-            <a:pPr algn="ctr">
-              <a:lnSpc>
-                <a:spcPct val="70000"/>
-              </a:lnSpc>
-              <a:buNone/>
-              <a:defRPr sz="1275" b="0">
-                <a:solidFill>
-                  <a:srgbClr val="1F40CB"/>
-                </a:solidFill>
-                <a:latin typeface="Calibri"/>
-                <a:ea typeface="Calibri"/>
-                <a:cs typeface="Calibri"/>
-              </a:defRPr>
-            </a:pPr>
-            <a:r>
-              <a:rPr sz="1800" b="0">
-                <a:solidFill>
-                  <a:srgbClr val="1F40CB"/>
-                </a:solidFill>
-                <a:latin typeface="Calibri"/>
-                <a:ea typeface="Calibri"/>
-                <a:cs typeface="Calibri"/>
-              </a:rPr>
-              <a:t>tool_calls · trace</a:t>
-            </a:r>
-          </a:p>
-          <a:p xmlns:a="http://schemas.openxmlformats.org/drawingml/2006/main">
-            <a:pPr algn="ctr">
-              <a:lnSpc>
-                <a:spcPct val="70000"/>
-              </a:lnSpc>
-              <a:buNone/>
-              <a:defRPr sz="1275" b="0">
-                <a:solidFill>
-                  <a:srgbClr val="1F40CB"/>
-                </a:solidFill>
-                <a:latin typeface="Calibri"/>
-                <a:ea typeface="Calibri"/>
-                <a:cs typeface="Calibri"/>
-              </a:defRPr>
-            </a:pPr>
-            <a:r>
-              <a:rPr sz="1800" b="0">
-                <a:solidFill>
-                  <a:srgbClr val="1F40CB"/>
-                </a:solidFill>
-                <a:latin typeface="Calibri"/>
-                <a:ea typeface="Calibri"/>
-                <a:cs typeface="Calibri"/>
-              </a:rPr>
-              <a:t>state update</a:t>
-            </a:r>
-          </a:p>
-        </p:txBody>
-      </p:sp>
-      <p:sp>
-        <p:nvSpPr>
-          <p:cNvPr id="10" name="decision-parent">
-            <a:extLst xmlns:a="http://schemas.openxmlformats.org/drawingml/2006/main">
-              <a:ext uri="{FF2B5EF4-FFF2-40B4-BE49-F238E27FC236}">
-                <a16:creationId xmlns:a16="http://schemas.microsoft.com/office/drawing/2014/main" id="{7E8CC043-3F7C-4B5E-B01A-E942C33D8740}"/>
-              </a:ext>
-            </a:extLst>
-          </p:cNvPr>
-          <p:cNvSpPr>
-            <a:spLocks xmlns:a="http://schemas.openxmlformats.org/drawingml/2006/main" noGrp="1"/>
-          </p:cNvSpPr>
-          <p:nvPr/>
-        </p:nvSpPr>
-        <p:spPr>
-          <a:xfrm xmlns:a="http://schemas.openxmlformats.org/drawingml/2006/main">
-            <a:off x="9829800" y="2990850"/>
-            <a:ext cx="3543300" cy="1562100"/>
-          </a:xfrm>
-          <a:prstGeom xmlns:a="http://schemas.openxmlformats.org/drawingml/2006/main" prst="roundRect">
-            <a:avLst>
-              <a:gd name="adj" fmla="val 7317"/>
-            </a:avLst>
-          </a:prstGeom>
-          <a:solidFill xmlns:a="http://schemas.openxmlformats.org/drawingml/2006/main">
-            <a:srgbClr val="062433"/>
-          </a:solidFill>
-          <a:ln xmlns:a="http://schemas.openxmlformats.org/drawingml/2006/main" w="9525">
-            <a:solidFill>
-              <a:srgbClr val="062433"/>
-            </a:solidFill>
-            <a:prstDash val="solid"/>
-          </a:ln>
-        </p:spPr>
-      </p:sp>
-      <p:sp>
-        <p:nvSpPr>
-          <p:cNvPr id="11" name="">
-            <a:extLst xmlns:a="http://schemas.openxmlformats.org/drawingml/2006/main">
-              <a:ext uri="{FF2B5EF4-FFF2-40B4-BE49-F238E27FC236}">
-                <a16:creationId xmlns:a16="http://schemas.microsoft.com/office/drawing/2014/main" id="{0595FD15-7156-4E52-87B2-404D626063B5}"/>
-              </a:ext>
-            </a:extLst>
-          </p:cNvPr>
-          <p:cNvSpPr>
-            <a:spLocks xmlns:a="http://schemas.openxmlformats.org/drawingml/2006/main" noGrp="1"/>
-          </p:cNvSpPr>
-          <p:nvPr/>
-        </p:nvSpPr>
-        <p:spPr>
-          <a:xfrm xmlns:a="http://schemas.openxmlformats.org/drawingml/2006/main">
-            <a:off x="10134600" y="3181350"/>
-            <a:ext cx="2933700" cy="323850"/>
-          </a:xfrm>
-          <a:prstGeom xmlns:a="http://schemas.openxmlformats.org/drawingml/2006/main" prst="rect">
-            <a:avLst/>
-          </a:prstGeom>
-          <a:noFill xmlns:a="http://schemas.openxmlformats.org/drawingml/2006/main"/>
-          <a:ln xmlns:a="http://schemas.openxmlformats.org/drawingml/2006/main" w="0">
-            <a:noFill/>
-            <a:prstDash val="solid"/>
-          </a:ln>
-        </p:spPr>
-        <p:txBody>
-          <a:bodyPr xmlns:a="http://schemas.openxmlformats.org/drawingml/2006/main" wrap="square" lIns="0" tIns="0" rIns="0" bIns="0" anchor="ctr">
-            <a:noAutofit/>
-          </a:bodyPr>
-          <a:lstStyle xmlns:a="http://schemas.openxmlformats.org/drawingml/2006/main"/>
-          <a:p xmlns:a="http://schemas.openxmlformats.org/drawingml/2006/main">
-            <a:pPr algn="ctr">
-              <a:lnSpc>
-                <a:spcPct val="100000"/>
-              </a:lnSpc>
-              <a:buNone/>
-              <a:defRPr sz="1350" b="1">
-                <a:solidFill>
-                  <a:srgbClr val="00A2EB"/>
-                </a:solidFill>
-                <a:latin typeface="Calibri"/>
-                <a:ea typeface="Calibri"/>
-                <a:cs typeface="Calibri"/>
-              </a:defRPr>
-            </a:pPr>
-            <a:r>
-              <a:rPr sz="1800" b="1">
-                <a:solidFill>
-                  <a:srgbClr val="00A2EB"/>
-                </a:solidFill>
-                <a:latin typeface="Calibri"/>
-                <a:ea typeface="Calibri"/>
-                <a:cs typeface="Calibri"/>
-              </a:rPr>
-              <a:t>FINISH</a:t>
-            </a:r>
-          </a:p>
-        </p:txBody>
-      </p:sp>
-      <p:sp>
-        <p:nvSpPr>
-          <p:cNvPr id="12" name="">
-            <a:extLst xmlns:a="http://schemas.openxmlformats.org/drawingml/2006/main">
-              <a:ext uri="{FF2B5EF4-FFF2-40B4-BE49-F238E27FC236}">
-                <a16:creationId xmlns:a16="http://schemas.microsoft.com/office/drawing/2014/main" id="{39CEFAC4-B99C-4E5B-B744-4D0EEDB15B0B}"/>
-              </a:ext>
-            </a:extLst>
-          </p:cNvPr>
-          <p:cNvSpPr>
-            <a:spLocks xmlns:a="http://schemas.openxmlformats.org/drawingml/2006/main" noGrp="1"/>
-          </p:cNvSpPr>
-          <p:nvPr/>
-        </p:nvSpPr>
-        <p:spPr>
-          <a:xfrm xmlns:a="http://schemas.openxmlformats.org/drawingml/2006/main">
-            <a:off x="10134600" y="3638550"/>
-            <a:ext cx="2933700" cy="685800"/>
+          <p:cNvPr id="25" name="">
+            <a:extLst xmlns:a="http://schemas.openxmlformats.org/drawingml/2006/main">
+              <a:ext uri="{FF2B5EF4-FFF2-40B4-BE49-F238E27FC236}">
+                <a16:creationId xmlns:a16="http://schemas.microsoft.com/office/drawing/2014/main" id="{C621D69C-B05C-4F0B-A6BD-0B4E43C7FA72}"/>
+              </a:ext>
+            </a:extLst>
+          </p:cNvPr>
+          <p:cNvSpPr>
+            <a:spLocks xmlns:a="http://schemas.openxmlformats.org/drawingml/2006/main" noGrp="1"/>
+          </p:cNvSpPr>
+          <p:nvPr/>
+        </p:nvSpPr>
+        <p:spPr>
+          <a:xfrm xmlns:a="http://schemas.openxmlformats.org/drawingml/2006/main">
+            <a:off x="971550" y="8058150"/>
+            <a:ext cx="3714750" cy="323850"/>
           </a:xfrm>
           <a:prstGeom xmlns:a="http://schemas.openxmlformats.org/drawingml/2006/main" prst="rect">
             <a:avLst/>
@@ -6312,228 +5922,52 @@
           </a:bodyPr>
           <a:lstStyle xmlns:a="http://schemas.openxmlformats.org/drawingml/2006/main"/>
           <a:p xmlns:a="http://schemas.openxmlformats.org/drawingml/2006/main">
-            <a:pPr algn="ctr">
-              <a:lnSpc>
-                <a:spcPct val="100000"/>
-              </a:lnSpc>
-              <a:buNone/>
-              <a:defRPr sz="2100" b="1">
-                <a:solidFill>
-                  <a:srgbClr val="FFFFFF"/>
-                </a:solidFill>
-                <a:latin typeface="Calibri"/>
-                <a:ea typeface="Calibri"/>
-                <a:cs typeface="Calibri"/>
-              </a:defRPr>
-            </a:pPr>
-            <a:r>
-              <a:rPr sz="2100" b="1">
-                <a:solidFill>
-                  <a:srgbClr val="FFFFFF"/>
-                </a:solidFill>
-                <a:latin typeface="Calibri"/>
-                <a:ea typeface="Calibri"/>
-                <a:cs typeface="Calibri"/>
-              </a:rPr>
-              <a:t>answer from</a:t>
-            </a:r>
-          </a:p>
-          <a:p xmlns:a="http://schemas.openxmlformats.org/drawingml/2006/main">
-            <a:pPr algn="ctr">
-              <a:lnSpc>
-                <a:spcPct val="100000"/>
-              </a:lnSpc>
-              <a:buNone/>
-              <a:defRPr sz="2100" b="1">
-                <a:solidFill>
-                  <a:srgbClr val="FFFFFF"/>
-                </a:solidFill>
-                <a:latin typeface="Calibri"/>
-                <a:ea typeface="Calibri"/>
-                <a:cs typeface="Calibri"/>
-              </a:defRPr>
-            </a:pPr>
-            <a:r>
-              <a:rPr sz="2100" b="1">
-                <a:solidFill>
-                  <a:srgbClr val="FFFFFF"/>
-                </a:solidFill>
-                <a:latin typeface="Calibri"/>
-                <a:ea typeface="Calibri"/>
-                <a:cs typeface="Calibri"/>
-              </a:rPr>
-              <a:t>successful data</a:t>
-            </a:r>
-          </a:p>
-        </p:txBody>
-      </p:sp>
-      <p:cxnSp>
-        <p:nvCxnSpPr>
-          <p:cNvPr id="320" name=""/>
-          <p:cNvCxnSpPr>
-            <a:stCxn xmlns:a="http://schemas.openxmlformats.org/drawingml/2006/main" id="3" idx="3"/>
-            <a:endCxn xmlns:a="http://schemas.openxmlformats.org/drawingml/2006/main" id="6" idx="1"/>
-          </p:cNvCxnSpPr>
-          <p:nvPr/>
-        </p:nvCxnSpPr>
-        <p:spPr>
-          <a:xfrm xmlns:a="http://schemas.openxmlformats.org/drawingml/2006/main">
-            <a:off x="3752850" y="3771900"/>
-            <a:ext cx="1409700" cy="0"/>
-          </a:xfrm>
-          <a:prstGeom xmlns:a="http://schemas.openxmlformats.org/drawingml/2006/main" prst="straightConnector1">
-            <a:avLst/>
-          </a:prstGeom>
-          <a:ln xmlns:a="http://schemas.openxmlformats.org/drawingml/2006/main" w="28575">
-            <a:solidFill>
-              <a:srgbClr val="F07D00"/>
-            </a:solidFill>
-            <a:prstDash val="solid"/>
-            <a:tailEnd type="triangle" w="med" len="med"/>
-          </a:ln>
-        </p:spPr>
-      </p:cxnSp>
-      <p:cxnSp>
-        <p:nvCxnSpPr>
-          <p:cNvPr id="321" name=""/>
-          <p:cNvCxnSpPr>
-            <a:stCxn xmlns:a="http://schemas.openxmlformats.org/drawingml/2006/main" id="6" idx="3"/>
-            <a:endCxn xmlns:a="http://schemas.openxmlformats.org/drawingml/2006/main" id="10" idx="1"/>
-          </p:cNvCxnSpPr>
-          <p:nvPr/>
-        </p:nvCxnSpPr>
-        <p:spPr>
-          <a:xfrm xmlns:a="http://schemas.openxmlformats.org/drawingml/2006/main" flipV="0">
-            <a:off x="8420100" y="3771900"/>
-            <a:ext cx="1409700" cy="0"/>
-          </a:xfrm>
-          <a:prstGeom xmlns:a="http://schemas.openxmlformats.org/drawingml/2006/main" prst="straightConnector1">
-            <a:avLst/>
-          </a:prstGeom>
-          <a:ln xmlns:a="http://schemas.openxmlformats.org/drawingml/2006/main" w="28575">
-            <a:solidFill>
-              <a:srgbClr val="F07D00"/>
-            </a:solidFill>
-            <a:prstDash val="solid"/>
-            <a:tailEnd type="triangle" w="med" len="med"/>
-          </a:ln>
-        </p:spPr>
-      </p:cxnSp>
-      <p:sp>
-        <p:nvSpPr>
-          <p:cNvPr id="15" name="">
-            <a:extLst xmlns:a="http://schemas.openxmlformats.org/drawingml/2006/main">
-              <a:ext uri="{FF2B5EF4-FFF2-40B4-BE49-F238E27FC236}">
-                <a16:creationId xmlns:a16="http://schemas.microsoft.com/office/drawing/2014/main" id="{FE1BEF3A-6A25-4B3F-8E60-6108148E5582}"/>
-              </a:ext>
-            </a:extLst>
-          </p:cNvPr>
-          <p:cNvSpPr>
-            <a:spLocks xmlns:a="http://schemas.openxmlformats.org/drawingml/2006/main" noGrp="1"/>
-          </p:cNvSpPr>
-          <p:nvPr/>
-        </p:nvSpPr>
-        <p:spPr>
-          <a:xfrm xmlns:a="http://schemas.openxmlformats.org/drawingml/2006/main">
-            <a:off x="1600200" y="5467350"/>
-            <a:ext cx="12039600" cy="1123950"/>
-          </a:xfrm>
-          <a:prstGeom xmlns:a="http://schemas.openxmlformats.org/drawingml/2006/main" prst="roundRect">
-            <a:avLst>
-              <a:gd name="adj" fmla="val 8475"/>
-            </a:avLst>
-          </a:prstGeom>
-          <a:solidFill xmlns:a="http://schemas.openxmlformats.org/drawingml/2006/main">
-            <a:srgbClr val="FFFFFF"/>
-          </a:solidFill>
-          <a:ln xmlns:a="http://schemas.openxmlformats.org/drawingml/2006/main" w="9525">
-            <a:solidFill>
-              <a:srgbClr val="E4E7E9"/>
-            </a:solidFill>
-            <a:prstDash val="solid"/>
-          </a:ln>
-        </p:spPr>
-      </p:sp>
-      <p:sp>
-        <p:nvSpPr>
-          <p:cNvPr id="16" name="">
-            <a:extLst xmlns:a="http://schemas.openxmlformats.org/drawingml/2006/main">
-              <a:ext uri="{FF2B5EF4-FFF2-40B4-BE49-F238E27FC236}">
-                <a16:creationId xmlns:a16="http://schemas.microsoft.com/office/drawing/2014/main" id="{DFE4947E-2E2C-4D5A-B088-DFED206E71BC}"/>
-              </a:ext>
-            </a:extLst>
-          </p:cNvPr>
-          <p:cNvSpPr>
-            <a:spLocks xmlns:a="http://schemas.openxmlformats.org/drawingml/2006/main" noGrp="1"/>
-          </p:cNvSpPr>
-          <p:nvPr/>
-        </p:nvSpPr>
-        <p:spPr>
-          <a:xfrm xmlns:a="http://schemas.openxmlformats.org/drawingml/2006/main">
-            <a:off x="1943100" y="5638800"/>
-            <a:ext cx="2476500" cy="285750"/>
-          </a:xfrm>
-          <a:prstGeom xmlns:a="http://schemas.openxmlformats.org/drawingml/2006/main" prst="rect">
-            <a:avLst/>
-          </a:prstGeom>
-          <a:noFill xmlns:a="http://schemas.openxmlformats.org/drawingml/2006/main"/>
-          <a:ln xmlns:a="http://schemas.openxmlformats.org/drawingml/2006/main" w="0">
-            <a:noFill/>
-            <a:prstDash val="solid"/>
-          </a:ln>
-        </p:spPr>
-        <p:txBody>
-          <a:bodyPr xmlns:a="http://schemas.openxmlformats.org/drawingml/2006/main" wrap="square" lIns="0" tIns="0" rIns="0" bIns="0" anchor="ctr">
-            <a:noAutofit/>
-          </a:bodyPr>
-          <a:lstStyle xmlns:a="http://schemas.openxmlformats.org/drawingml/2006/main"/>
-          <a:p xmlns:a="http://schemas.openxmlformats.org/drawingml/2006/main">
             <a:pPr algn="l">
               <a:lnSpc>
                 <a:spcPct val="100000"/>
               </a:lnSpc>
               <a:buNone/>
-              <a:defRPr sz="1275" b="1">
-                <a:solidFill>
-                  <a:srgbClr val="F07D00"/>
-                </a:solidFill>
-                <a:latin typeface="Calibri"/>
-                <a:ea typeface="Calibri"/>
-                <a:cs typeface="Calibri"/>
-              </a:defRPr>
-            </a:pPr>
-            <a:r>
-              <a:rPr sz="1800" b="1">
-                <a:solidFill>
-                  <a:srgbClr val="F07D00"/>
-                </a:solidFill>
-                <a:latin typeface="Calibri"/>
-                <a:ea typeface="Calibri"/>
-                <a:cs typeface="Calibri"/>
-              </a:rPr>
-              <a:t>CONDITIONAL ROUTES</a:t>
-            </a:r>
-          </a:p>
-        </p:txBody>
-      </p:sp>
-      <p:sp>
-        <p:nvSpPr>
-          <p:cNvPr id="17" name="">
-            <a:extLst xmlns:a="http://schemas.openxmlformats.org/drawingml/2006/main">
-              <a:ext uri="{FF2B5EF4-FFF2-40B4-BE49-F238E27FC236}">
-                <a16:creationId xmlns:a16="http://schemas.microsoft.com/office/drawing/2014/main" id="{DC1A217F-7E45-4462-994A-E1A7947A47FC}"/>
-              </a:ext>
-            </a:extLst>
-          </p:cNvPr>
-          <p:cNvSpPr>
-            <a:spLocks xmlns:a="http://schemas.openxmlformats.org/drawingml/2006/main" noGrp="1"/>
-          </p:cNvSpPr>
-          <p:nvPr/>
-        </p:nvSpPr>
-        <p:spPr>
-          <a:xfrm xmlns:a="http://schemas.openxmlformats.org/drawingml/2006/main">
-            <a:off x="1943100" y="5962650"/>
-            <a:ext cx="4953000" cy="400050"/>
+              <a:defRPr sz="1200" b="0">
+                <a:solidFill>
+                  <a:srgbClr val="9A9A9F"/>
+                </a:solidFill>
+                <a:latin typeface="Calibri"/>
+                <a:ea typeface="Calibri"/>
+                <a:cs typeface="Calibri"/>
+              </a:defRPr>
+            </a:pPr>
+            <a:r>
+              <a:rPr sz="1200" b="0">
+                <a:solidFill>
+                  <a:srgbClr val="9A9A9F"/>
+                </a:solidFill>
+                <a:latin typeface="Calibri"/>
+                <a:ea typeface="Calibri"/>
+                <a:cs typeface="Calibri"/>
+              </a:rPr>
+              <a:t>First Finance - Arnaud Demes</a:t>
+            </a:r>
+          </a:p>
+        </p:txBody>
+      </p:sp>
+      <p:sp>
+        <p:nvSpPr>
+          <p:cNvPr id="26" name="">
+            <a:extLst xmlns:a="http://schemas.openxmlformats.org/drawingml/2006/main">
+              <a:ext uri="{FF2B5EF4-FFF2-40B4-BE49-F238E27FC236}">
+                <a16:creationId xmlns:a16="http://schemas.microsoft.com/office/drawing/2014/main" id="{84A9C6EC-5AC1-4AD4-9D79-D0462CD01225}"/>
+              </a:ext>
+            </a:extLst>
+          </p:cNvPr>
+          <p:cNvSpPr>
+            <a:spLocks xmlns:a="http://schemas.openxmlformats.org/drawingml/2006/main" noGrp="1"/>
+          </p:cNvSpPr>
+          <p:nvPr/>
+        </p:nvSpPr>
+        <p:spPr>
+          <a:xfrm xmlns:a="http://schemas.openxmlformats.org/drawingml/2006/main">
+            <a:off x="12192000" y="8058150"/>
+            <a:ext cx="1809750" cy="323850"/>
           </a:xfrm>
           <a:prstGeom xmlns:a="http://schemas.openxmlformats.org/drawingml/2006/main" prst="rect">
             <a:avLst/>
@@ -6550,147 +5984,52 @@
           </a:bodyPr>
           <a:lstStyle xmlns:a="http://schemas.openxmlformats.org/drawingml/2006/main"/>
           <a:p xmlns:a="http://schemas.openxmlformats.org/drawingml/2006/main">
-            <a:pPr algn="l">
-              <a:lnSpc>
-                <a:spcPct val="100000"/>
-              </a:lnSpc>
-              <a:buNone/>
-              <a:defRPr sz="1650" b="1">
-                <a:solidFill>
-                  <a:srgbClr val="051C2A"/>
-                </a:solidFill>
-                <a:latin typeface="Calibri"/>
-                <a:ea typeface="Calibri"/>
-                <a:cs typeface="Calibri"/>
-              </a:defRPr>
-            </a:pPr>
-            <a:r>
-              <a:rPr sz="1650" b="1">
-                <a:solidFill>
-                  <a:srgbClr val="051C2A"/>
-                </a:solidFill>
-                <a:latin typeface="Calibri"/>
-                <a:ea typeface="Calibri"/>
-                <a:cs typeface="Calibri"/>
-              </a:rPr>
-              <a:t>tools · finish · guards</a:t>
-            </a:r>
-          </a:p>
-        </p:txBody>
-      </p:sp>
-      <p:sp>
-        <p:nvSpPr>
-          <p:cNvPr id="18" name="">
-            <a:extLst xmlns:a="http://schemas.openxmlformats.org/drawingml/2006/main">
-              <a:ext uri="{FF2B5EF4-FFF2-40B4-BE49-F238E27FC236}">
-                <a16:creationId xmlns:a16="http://schemas.microsoft.com/office/drawing/2014/main" id="{4B74CAF0-D3F9-408B-B959-2864FA7108BD}"/>
-              </a:ext>
-            </a:extLst>
-          </p:cNvPr>
-          <p:cNvSpPr>
-            <a:spLocks xmlns:a="http://schemas.openxmlformats.org/drawingml/2006/main" noGrp="1"/>
-          </p:cNvSpPr>
-          <p:nvPr/>
-        </p:nvSpPr>
-        <p:spPr>
-          <a:xfrm xmlns:a="http://schemas.openxmlformats.org/drawingml/2006/main">
-            <a:off x="7486650" y="5638800"/>
-            <a:ext cx="28575" cy="742950"/>
-          </a:xfrm>
-          <a:prstGeom xmlns:a="http://schemas.openxmlformats.org/drawingml/2006/main" prst="rect">
-            <a:avLst/>
-          </a:prstGeom>
-          <a:solidFill xmlns:a="http://schemas.openxmlformats.org/drawingml/2006/main">
-            <a:srgbClr val="E4E7E9"/>
-          </a:solidFill>
-          <a:ln xmlns:a="http://schemas.openxmlformats.org/drawingml/2006/main" w="0">
-            <a:solidFill>
-              <a:srgbClr val="E4E7E9"/>
-            </a:solidFill>
-            <a:prstDash val="solid"/>
-          </a:ln>
-        </p:spPr>
-      </p:sp>
-      <p:sp>
-        <p:nvSpPr>
-          <p:cNvPr id="19" name="">
-            <a:extLst xmlns:a="http://schemas.openxmlformats.org/drawingml/2006/main">
-              <a:ext uri="{FF2B5EF4-FFF2-40B4-BE49-F238E27FC236}">
-                <a16:creationId xmlns:a16="http://schemas.microsoft.com/office/drawing/2014/main" id="{F6C058E3-0326-4715-852F-1F8B32F61FB5}"/>
-              </a:ext>
-            </a:extLst>
-          </p:cNvPr>
-          <p:cNvSpPr>
-            <a:spLocks xmlns:a="http://schemas.openxmlformats.org/drawingml/2006/main" noGrp="1"/>
-          </p:cNvSpPr>
-          <p:nvPr/>
-        </p:nvSpPr>
-        <p:spPr>
-          <a:xfrm xmlns:a="http://schemas.openxmlformats.org/drawingml/2006/main">
-            <a:off x="7867650" y="5638800"/>
-            <a:ext cx="3143250" cy="285750"/>
-          </a:xfrm>
-          <a:prstGeom xmlns:a="http://schemas.openxmlformats.org/drawingml/2006/main" prst="rect">
-            <a:avLst/>
-          </a:prstGeom>
-          <a:noFill xmlns:a="http://schemas.openxmlformats.org/drawingml/2006/main"/>
-          <a:ln xmlns:a="http://schemas.openxmlformats.org/drawingml/2006/main" w="0">
-            <a:noFill/>
-            <a:prstDash val="solid"/>
-          </a:ln>
-        </p:spPr>
-        <p:txBody>
-          <a:bodyPr xmlns:a="http://schemas.openxmlformats.org/drawingml/2006/main" wrap="square" lIns="0" tIns="0" rIns="0" bIns="0" anchor="ctr">
-            <a:noAutofit/>
-          </a:bodyPr>
-          <a:lstStyle xmlns:a="http://schemas.openxmlformats.org/drawingml/2006/main"/>
-          <a:p xmlns:a="http://schemas.openxmlformats.org/drawingml/2006/main">
-            <a:pPr algn="l">
-              <a:lnSpc>
-                <a:spcPct val="100000"/>
-              </a:lnSpc>
-              <a:buNone/>
-              <a:defRPr sz="1275" b="1">
-                <a:solidFill>
-                  <a:srgbClr val="00A2EB"/>
-                </a:solidFill>
-                <a:latin typeface="Calibri"/>
-                <a:ea typeface="Calibri"/>
-                <a:cs typeface="Calibri"/>
-              </a:defRPr>
-            </a:pPr>
-            <a:r>
-              <a:rPr sz="1800" b="1">
-                <a:solidFill>
-                  <a:srgbClr val="00A2EB"/>
-                </a:solidFill>
-                <a:latin typeface="Calibri"/>
-                <a:ea typeface="Calibri"/>
-                <a:cs typeface="Calibri"/>
-              </a:rPr>
-              <a:t>STATE CONTRACT</a:t>
-            </a:r>
-          </a:p>
-        </p:txBody>
-      </p:sp>
-      <p:sp>
-        <p:nvSpPr>
-          <p:cNvPr id="20" name="">
-            <a:extLst xmlns:a="http://schemas.openxmlformats.org/drawingml/2006/main">
-              <a:ext uri="{FF2B5EF4-FFF2-40B4-BE49-F238E27FC236}">
-                <a16:creationId xmlns:a16="http://schemas.microsoft.com/office/drawing/2014/main" id="{0AA9B25E-ADFB-4067-BF4C-46A5AE9FE838}"/>
-              </a:ext>
-            </a:extLst>
-          </p:cNvPr>
-          <p:cNvSpPr>
-            <a:spLocks xmlns:a="http://schemas.openxmlformats.org/drawingml/2006/main" noGrp="1"/>
-          </p:cNvSpPr>
-          <p:nvPr/>
-        </p:nvSpPr>
-        <p:spPr>
-          <a:xfrm xmlns:a="http://schemas.openxmlformats.org/drawingml/2006/main">
-            <a:off x="7867650" y="5962650"/>
-            <a:ext cx="5143500" cy="400050"/>
+            <a:pPr algn="r">
+              <a:lnSpc>
+                <a:spcPct val="100000"/>
+              </a:lnSpc>
+              <a:buNone/>
+              <a:defRPr sz="1200" b="1">
+                <a:solidFill>
+                  <a:srgbClr val="9A9A9F"/>
+                </a:solidFill>
+                <a:latin typeface="Calibri"/>
+                <a:ea typeface="Calibri"/>
+                <a:cs typeface="Calibri"/>
+              </a:defRPr>
+            </a:pPr>
+            <a:r>
+              <a:rPr sz="1200" b="1">
+                <a:solidFill>
+                  <a:srgbClr val="9A9A9F"/>
+                </a:solidFill>
+                <a:latin typeface="Calibri"/>
+                <a:ea typeface="Calibri"/>
+                <a:cs typeface="Calibri"/>
+              </a:rPr>
+              <a:t>GRAPH</a:t>
+            </a:r>
+          </a:p>
+        </p:txBody>
+      </p:sp>
+      <p:sp>
+        <p:nvSpPr>
+          <p:cNvPr id="27" name="">
+            <a:extLst xmlns:a="http://schemas.openxmlformats.org/drawingml/2006/main">
+              <a:ext uri="{FF2B5EF4-FFF2-40B4-BE49-F238E27FC236}">
+                <a16:creationId xmlns:a16="http://schemas.microsoft.com/office/drawing/2014/main" id="{E30F561A-2997-41E1-8361-56739584F871}"/>
+              </a:ext>
+            </a:extLst>
+          </p:cNvPr>
+          <p:cNvSpPr>
+            <a:spLocks xmlns:a="http://schemas.openxmlformats.org/drawingml/2006/main" noGrp="1"/>
+          </p:cNvSpPr>
+          <p:nvPr/>
+        </p:nvSpPr>
+        <p:spPr>
+          <a:xfrm xmlns:a="http://schemas.openxmlformats.org/drawingml/2006/main">
+            <a:off x="14135100" y="8058150"/>
+            <a:ext cx="266700" cy="323850"/>
           </a:xfrm>
           <a:prstGeom xmlns:a="http://schemas.openxmlformats.org/drawingml/2006/main" prst="rect">
             <a:avLst/>
@@ -6707,264 +6046,12 @@
           </a:bodyPr>
           <a:lstStyle xmlns:a="http://schemas.openxmlformats.org/drawingml/2006/main"/>
           <a:p xmlns:a="http://schemas.openxmlformats.org/drawingml/2006/main">
-            <a:pPr algn="l">
-              <a:lnSpc>
-                <a:spcPct val="100000"/>
-              </a:lnSpc>
-              <a:buNone/>
-              <a:defRPr sz="1650" b="1">
-                <a:solidFill>
-                  <a:srgbClr val="051C2A"/>
-                </a:solidFill>
-                <a:latin typeface="Calibri"/>
-                <a:ea typeface="Calibri"/>
-                <a:cs typeface="Calibri"/>
-              </a:defRPr>
-            </a:pPr>
-            <a:r>
-              <a:rPr sz="1650" b="1">
-                <a:solidFill>
-                  <a:srgbClr val="051C2A"/>
-                </a:solidFill>
-                <a:latin typeface="Calibri"/>
-                <a:ea typeface="Calibri"/>
-                <a:cs typeface="Calibri"/>
-              </a:rPr>
-              <a:t>question · decision · observation · budgets</a:t>
-            </a:r>
-          </a:p>
-        </p:txBody>
-      </p:sp>
-      <p:sp>
-        <p:nvSpPr>
-          <p:cNvPr id="21" name="">
-            <a:extLst xmlns:a="http://schemas.openxmlformats.org/drawingml/2006/main">
-              <a:ext uri="{FF2B5EF4-FFF2-40B4-BE49-F238E27FC236}">
-                <a16:creationId xmlns:a16="http://schemas.microsoft.com/office/drawing/2014/main" id="{BCAA4B4E-BD27-48A6-A4E1-ACF33C620C4D}"/>
-              </a:ext>
-            </a:extLst>
-          </p:cNvPr>
-          <p:cNvSpPr>
-            <a:spLocks xmlns:a="http://schemas.openxmlformats.org/drawingml/2006/main" noGrp="1"/>
-          </p:cNvSpPr>
-          <p:nvPr/>
-        </p:nvSpPr>
-        <p:spPr>
-          <a:xfrm xmlns:a="http://schemas.openxmlformats.org/drawingml/2006/main">
-            <a:off x="1028700" y="7086600"/>
-            <a:ext cx="1524000" cy="323850"/>
-          </a:xfrm>
-          <a:prstGeom xmlns:a="http://schemas.openxmlformats.org/drawingml/2006/main" prst="rect">
-            <a:avLst/>
-          </a:prstGeom>
-          <a:noFill xmlns:a="http://schemas.openxmlformats.org/drawingml/2006/main"/>
-          <a:ln xmlns:a="http://schemas.openxmlformats.org/drawingml/2006/main" w="0">
-            <a:noFill/>
-            <a:prstDash val="solid"/>
-          </a:ln>
-        </p:spPr>
-        <p:txBody>
-          <a:bodyPr xmlns:a="http://schemas.openxmlformats.org/drawingml/2006/main" wrap="square" lIns="0" tIns="0" rIns="0" bIns="0" anchor="ctr">
-            <a:noAutofit/>
-          </a:bodyPr>
-          <a:lstStyle xmlns:a="http://schemas.openxmlformats.org/drawingml/2006/main"/>
-          <a:p xmlns:a="http://schemas.openxmlformats.org/drawingml/2006/main">
-            <a:pPr algn="l">
-              <a:lnSpc>
-                <a:spcPct val="100000"/>
-              </a:lnSpc>
-              <a:buNone/>
-              <a:defRPr sz="1350" b="1">
-                <a:solidFill>
-                  <a:srgbClr val="F07D00"/>
-                </a:solidFill>
-                <a:latin typeface="Calibri"/>
-                <a:ea typeface="Calibri"/>
-                <a:cs typeface="Calibri"/>
-              </a:defRPr>
-            </a:pPr>
-            <a:r>
-              <a:rPr sz="1800" b="1">
-                <a:solidFill>
-                  <a:srgbClr val="F07D00"/>
-                </a:solidFill>
-                <a:latin typeface="Calibri"/>
-                <a:ea typeface="Calibri"/>
-                <a:cs typeface="Calibri"/>
-              </a:rPr>
-              <a:t>DAY 2</a:t>
-            </a:r>
-          </a:p>
-        </p:txBody>
-      </p:sp>
-      <p:sp>
-        <p:nvSpPr>
-          <p:cNvPr id="22" name="">
-            <a:extLst xmlns:a="http://schemas.openxmlformats.org/drawingml/2006/main">
-              <a:ext uri="{FF2B5EF4-FFF2-40B4-BE49-F238E27FC236}">
-                <a16:creationId xmlns:a16="http://schemas.microsoft.com/office/drawing/2014/main" id="{539B97AA-C4C9-4A8D-997E-C7AD0F311AD6}"/>
-              </a:ext>
-            </a:extLst>
-          </p:cNvPr>
-          <p:cNvSpPr>
-            <a:spLocks xmlns:a="http://schemas.openxmlformats.org/drawingml/2006/main" noGrp="1"/>
-          </p:cNvSpPr>
-          <p:nvPr/>
-        </p:nvSpPr>
-        <p:spPr>
-          <a:xfrm xmlns:a="http://schemas.openxmlformats.org/drawingml/2006/main">
-            <a:off x="2705100" y="6991350"/>
-            <a:ext cx="11410950" cy="476250"/>
-          </a:xfrm>
-          <a:prstGeom xmlns:a="http://schemas.openxmlformats.org/drawingml/2006/main" prst="rect">
-            <a:avLst/>
-          </a:prstGeom>
-          <a:noFill xmlns:a="http://schemas.openxmlformats.org/drawingml/2006/main"/>
-          <a:ln xmlns:a="http://schemas.openxmlformats.org/drawingml/2006/main" w="0">
-            <a:noFill/>
-            <a:prstDash val="solid"/>
-          </a:ln>
-        </p:spPr>
-        <p:txBody>
-          <a:bodyPr xmlns:a="http://schemas.openxmlformats.org/drawingml/2006/main" wrap="square" lIns="0" tIns="0" rIns="0" bIns="0" anchor="ctr">
-            <a:normAutofit fontScale="100000"/>
-          </a:bodyPr>
-          <a:lstStyle xmlns:a="http://schemas.openxmlformats.org/drawingml/2006/main"/>
-          <a:p xmlns:a="http://schemas.openxmlformats.org/drawingml/2006/main">
-            <a:pPr algn="l">
-              <a:lnSpc>
-                <a:spcPct val="100000"/>
-              </a:lnSpc>
-              <a:buNone/>
-              <a:defRPr sz="1875" b="1">
-                <a:solidFill>
-                  <a:srgbClr val="1F40CB"/>
-                </a:solidFill>
-                <a:latin typeface="Calibri"/>
-                <a:ea typeface="Calibri"/>
-                <a:cs typeface="Calibri"/>
-              </a:defRPr>
-            </a:pPr>
-            <a:r>
-              <a:rPr sz="1875" b="1">
-                <a:solidFill>
-                  <a:srgbClr val="1F40CB"/>
-                </a:solidFill>
-                <a:latin typeface="Calibri"/>
-                <a:ea typeface="Calibri"/>
-                <a:cs typeface="Calibri"/>
-              </a:rPr>
-              <a:t>Errors return to the agent as context. Budgets remain application-owned.</a:t>
-            </a:r>
-          </a:p>
-        </p:txBody>
-      </p:sp>
-      <p:sp>
-        <p:nvSpPr>
-          <p:cNvPr id="23" name="">
-            <a:extLst xmlns:a="http://schemas.openxmlformats.org/drawingml/2006/main">
-              <a:ext uri="{FF2B5EF4-FFF2-40B4-BE49-F238E27FC236}">
-                <a16:creationId xmlns:a16="http://schemas.microsoft.com/office/drawing/2014/main" id="{3CA8D079-E333-430B-9198-F3840FF42229}"/>
-              </a:ext>
-            </a:extLst>
-          </p:cNvPr>
-          <p:cNvSpPr>
-            <a:spLocks xmlns:a="http://schemas.openxmlformats.org/drawingml/2006/main" noGrp="1"/>
-          </p:cNvSpPr>
-          <p:nvPr/>
-        </p:nvSpPr>
-        <p:spPr>
-          <a:xfrm xmlns:a="http://schemas.openxmlformats.org/drawingml/2006/main">
-            <a:off x="857250" y="7896225"/>
-            <a:ext cx="13525500" cy="28575"/>
-          </a:xfrm>
-          <a:prstGeom xmlns:a="http://schemas.openxmlformats.org/drawingml/2006/main" prst="rect">
-            <a:avLst/>
-          </a:prstGeom>
-          <a:solidFill xmlns:a="http://schemas.openxmlformats.org/drawingml/2006/main">
-            <a:srgbClr val="E4E7E9"/>
-          </a:solidFill>
-          <a:ln xmlns:a="http://schemas.openxmlformats.org/drawingml/2006/main" w="0">
-            <a:solidFill>
-              <a:srgbClr val="E4E7E9"/>
-            </a:solidFill>
-            <a:prstDash val="solid"/>
-          </a:ln>
-        </p:spPr>
-      </p:sp>
-      <p:sp>
-        <p:nvSpPr>
-          <p:cNvPr id="24" name="">
-            <a:extLst xmlns:a="http://schemas.openxmlformats.org/drawingml/2006/main">
-              <a:ext uri="{FF2B5EF4-FFF2-40B4-BE49-F238E27FC236}">
-                <a16:creationId xmlns:a16="http://schemas.microsoft.com/office/drawing/2014/main" id="{56B1FA6E-7D19-4BD4-95AB-A7A96F2D9D4D}"/>
-              </a:ext>
-            </a:extLst>
-          </p:cNvPr>
-          <p:cNvSpPr>
-            <a:spLocks xmlns:a="http://schemas.openxmlformats.org/drawingml/2006/main" noGrp="1"/>
-          </p:cNvSpPr>
-          <p:nvPr/>
-        </p:nvSpPr>
-        <p:spPr>
-          <a:xfrm xmlns:a="http://schemas.openxmlformats.org/drawingml/2006/main">
-            <a:off x="857250" y="7896225"/>
-            <a:ext cx="8001000" cy="38100"/>
-          </a:xfrm>
-          <a:prstGeom xmlns:a="http://schemas.openxmlformats.org/drawingml/2006/main" prst="rect">
-            <a:avLst/>
-          </a:prstGeom>
-          <a:solidFill xmlns:a="http://schemas.openxmlformats.org/drawingml/2006/main">
-            <a:srgbClr val="00A2EB"/>
-          </a:solidFill>
-          <a:ln xmlns:a="http://schemas.openxmlformats.org/drawingml/2006/main" w="0">
-            <a:solidFill>
-              <a:srgbClr val="00A2EB"/>
-            </a:solidFill>
-            <a:prstDash val="solid"/>
-          </a:ln>
-        </p:spPr>
-      </p:sp>
-      <p:sp>
-        <p:nvSpPr>
-          <p:cNvPr id="25" name="">
-            <a:extLst xmlns:a="http://schemas.openxmlformats.org/drawingml/2006/main">
-              <a:ext uri="{FF2B5EF4-FFF2-40B4-BE49-F238E27FC236}">
-                <a16:creationId xmlns:a16="http://schemas.microsoft.com/office/drawing/2014/main" id="{C621D69C-B05C-4F0B-A6BD-0B4E43C7FA72}"/>
-              </a:ext>
-            </a:extLst>
-          </p:cNvPr>
-          <p:cNvSpPr>
-            <a:spLocks xmlns:a="http://schemas.openxmlformats.org/drawingml/2006/main" noGrp="1"/>
-          </p:cNvSpPr>
-          <p:nvPr/>
-        </p:nvSpPr>
-        <p:spPr>
-          <a:xfrm xmlns:a="http://schemas.openxmlformats.org/drawingml/2006/main">
-            <a:off x="971550" y="8058150"/>
-            <a:ext cx="3714750" cy="323850"/>
-          </a:xfrm>
-          <a:prstGeom xmlns:a="http://schemas.openxmlformats.org/drawingml/2006/main" prst="rect">
-            <a:avLst/>
-          </a:prstGeom>
-          <a:noFill xmlns:a="http://schemas.openxmlformats.org/drawingml/2006/main"/>
-          <a:ln xmlns:a="http://schemas.openxmlformats.org/drawingml/2006/main" w="0">
-            <a:noFill/>
-            <a:prstDash val="solid"/>
-          </a:ln>
-        </p:spPr>
-        <p:txBody>
-          <a:bodyPr xmlns:a="http://schemas.openxmlformats.org/drawingml/2006/main" wrap="square" lIns="0" tIns="0" rIns="0" bIns="0" anchor="ctr">
-            <a:normAutofit fontScale="100000"/>
-          </a:bodyPr>
-          <a:lstStyle xmlns:a="http://schemas.openxmlformats.org/drawingml/2006/main"/>
-          <a:p xmlns:a="http://schemas.openxmlformats.org/drawingml/2006/main">
-            <a:pPr algn="l">
-              <a:lnSpc>
-                <a:spcPct val="100000"/>
-              </a:lnSpc>
-              <a:buNone/>
-              <a:defRPr sz="1200" b="0">
+            <a:pPr algn="r">
+              <a:lnSpc>
+                <a:spcPct val="100000"/>
+              </a:lnSpc>
+              <a:buNone/>
+              <a:defRPr sz="1200" b="1">
                 <a:solidFill>
                   <a:srgbClr val="9A9A9F"/>
                 </a:solidFill>
@@ -6974,7 +6061,7 @@
               </a:defRPr>
             </a:pPr>
             <a:r>
-              <a:rPr sz="1200" b="0">
+              <a:rPr sz="1200" b="1">
                 <a:solidFill>
                   <a:srgbClr val="9A9A9F"/>
                 </a:solidFill>
@@ -6982,135 +6069,33 @@
                 <a:ea typeface="Calibri"/>
                 <a:cs typeface="Calibri"/>
               </a:rPr>
-              <a:t>First Finance - Arnaud Demes</a:t>
-            </a:r>
-          </a:p>
-        </p:txBody>
-      </p:sp>
-      <p:sp>
-        <p:nvSpPr>
-          <p:cNvPr id="26" name="">
-            <a:extLst xmlns:a="http://schemas.openxmlformats.org/drawingml/2006/main">
-              <a:ext uri="{FF2B5EF4-FFF2-40B4-BE49-F238E27FC236}">
-                <a16:creationId xmlns:a16="http://schemas.microsoft.com/office/drawing/2014/main" id="{84A9C6EC-5AC1-4AD4-9D79-D0462CD01225}"/>
-              </a:ext>
-            </a:extLst>
-          </p:cNvPr>
-          <p:cNvSpPr>
-            <a:spLocks xmlns:a="http://schemas.openxmlformats.org/drawingml/2006/main" noGrp="1"/>
-          </p:cNvSpPr>
-          <p:nvPr/>
-        </p:nvSpPr>
-        <p:spPr>
-          <a:xfrm xmlns:a="http://schemas.openxmlformats.org/drawingml/2006/main">
-            <a:off x="12192000" y="8058150"/>
-            <a:ext cx="1809750" cy="323850"/>
-          </a:xfrm>
-          <a:prstGeom xmlns:a="http://schemas.openxmlformats.org/drawingml/2006/main" prst="rect">
-            <a:avLst/>
-          </a:prstGeom>
-          <a:noFill xmlns:a="http://schemas.openxmlformats.org/drawingml/2006/main"/>
-          <a:ln xmlns:a="http://schemas.openxmlformats.org/drawingml/2006/main" w="0">
-            <a:noFill/>
-            <a:prstDash val="solid"/>
-          </a:ln>
-        </p:spPr>
-        <p:txBody>
-          <a:bodyPr xmlns:a="http://schemas.openxmlformats.org/drawingml/2006/main" wrap="square" lIns="0" tIns="0" rIns="0" bIns="0" anchor="ctr">
-            <a:normAutofit fontScale="100000"/>
-          </a:bodyPr>
-          <a:lstStyle xmlns:a="http://schemas.openxmlformats.org/drawingml/2006/main"/>
-          <a:p xmlns:a="http://schemas.openxmlformats.org/drawingml/2006/main">
-            <a:pPr algn="r">
-              <a:lnSpc>
-                <a:spcPct val="100000"/>
-              </a:lnSpc>
-              <a:buNone/>
-              <a:defRPr sz="1200" b="1">
-                <a:solidFill>
-                  <a:srgbClr val="9A9A9F"/>
-                </a:solidFill>
-                <a:latin typeface="Calibri"/>
-                <a:ea typeface="Calibri"/>
-                <a:cs typeface="Calibri"/>
-              </a:defRPr>
-            </a:pPr>
-            <a:r>
-              <a:rPr sz="1200" b="1">
-                <a:solidFill>
-                  <a:srgbClr val="9A9A9F"/>
-                </a:solidFill>
-                <a:latin typeface="Calibri"/>
-                <a:ea typeface="Calibri"/>
-                <a:cs typeface="Calibri"/>
-              </a:rPr>
-              <a:t>GRAPH</a:t>
-            </a:r>
-          </a:p>
-        </p:txBody>
-      </p:sp>
-      <p:sp>
-        <p:nvSpPr>
-          <p:cNvPr id="27" name="">
-            <a:extLst xmlns:a="http://schemas.openxmlformats.org/drawingml/2006/main">
-              <a:ext uri="{FF2B5EF4-FFF2-40B4-BE49-F238E27FC236}">
-                <a16:creationId xmlns:a16="http://schemas.microsoft.com/office/drawing/2014/main" id="{E30F561A-2997-41E1-8361-56739584F871}"/>
-              </a:ext>
-            </a:extLst>
-          </p:cNvPr>
-          <p:cNvSpPr>
-            <a:spLocks xmlns:a="http://schemas.openxmlformats.org/drawingml/2006/main" noGrp="1"/>
-          </p:cNvSpPr>
-          <p:nvPr/>
-        </p:nvSpPr>
-        <p:spPr>
-          <a:xfrm xmlns:a="http://schemas.openxmlformats.org/drawingml/2006/main">
-            <a:off x="14135100" y="8058150"/>
-            <a:ext cx="266700" cy="323850"/>
-          </a:xfrm>
-          <a:prstGeom xmlns:a="http://schemas.openxmlformats.org/drawingml/2006/main" prst="rect">
-            <a:avLst/>
-          </a:prstGeom>
-          <a:noFill xmlns:a="http://schemas.openxmlformats.org/drawingml/2006/main"/>
-          <a:ln xmlns:a="http://schemas.openxmlformats.org/drawingml/2006/main" w="0">
-            <a:noFill/>
-            <a:prstDash val="solid"/>
-          </a:ln>
-        </p:spPr>
-        <p:txBody>
-          <a:bodyPr xmlns:a="http://schemas.openxmlformats.org/drawingml/2006/main" wrap="square" lIns="0" tIns="0" rIns="0" bIns="0" anchor="ctr">
-            <a:normAutofit fontScale="100000"/>
-          </a:bodyPr>
-          <a:lstStyle xmlns:a="http://schemas.openxmlformats.org/drawingml/2006/main"/>
-          <a:p xmlns:a="http://schemas.openxmlformats.org/drawingml/2006/main">
-            <a:pPr algn="r">
-              <a:lnSpc>
-                <a:spcPct val="100000"/>
-              </a:lnSpc>
-              <a:buNone/>
-              <a:defRPr sz="1200" b="1">
-                <a:solidFill>
-                  <a:srgbClr val="9A9A9F"/>
-                </a:solidFill>
-                <a:latin typeface="Calibri"/>
-                <a:ea typeface="Calibri"/>
-                <a:cs typeface="Calibri"/>
-              </a:defRPr>
-            </a:pPr>
-            <a:r>
-              <a:rPr sz="1200" b="1">
-                <a:solidFill>
-                  <a:srgbClr val="9A9A9F"/>
-                </a:solidFill>
-                <a:latin typeface="Calibri"/>
-                <a:ea typeface="Calibri"/>
-                <a:cs typeface="Calibri"/>
-              </a:rPr>
               <a:t>03</a:t>
             </a:r>
           </a:p>
         </p:txBody>
       </p:sp>
+      <p:pic>
+        <p:nvPicPr>
+          <p:cNvPr id="39" name=""/>
+          <p:cNvPicPr>
+            <a:picLocks xmlns:a="http://schemas.openxmlformats.org/drawingml/2006/main" noChangeAspect="1"/>
+          </p:cNvPicPr>
+          <p:nvPr/>
+        </p:nvPicPr>
+        <p:blipFill>
+          <a:blip xmlns:r="http://schemas.openxmlformats.org/officeDocument/2006/relationships" xmlns:a="http://schemas.openxmlformats.org/drawingml/2006/main" r:embed="R32af756bfec14436"/>
+          <a:stretch xmlns:a="http://schemas.openxmlformats.org/drawingml/2006/main"/>
+        </p:blipFill>
+        <p:spPr>
+          <a:xfrm xmlns:a="http://schemas.openxmlformats.org/drawingml/2006/main">
+            <a:off x="5848764" y="2076450"/>
+            <a:ext cx="3542472" cy="4333875"/>
+          </a:xfrm>
+          <a:prstGeom xmlns:a="http://schemas.openxmlformats.org/drawingml/2006/main" prst="rect">
+            <a:avLst/>
+          </a:prstGeom>
+        </p:spPr>
+      </p:pic>
     </p:spTree>
     <p:extLst>
       <p:ext uri="{BB962C8B-B14F-4D97-AF65-F5344CB8AC3E}">
@@ -7197,7 +6182,7 @@
                 <a:ea typeface="Calibri"/>
                 <a:cs typeface="Calibri"/>
               </a:rPr>
-              <a:t>ERRORS BECOME CONTEXT</a:t>
+              <a:t>WHAT SELF-CORRECTION MEANS</a:t>
             </a:r>
           </a:p>
         </p:txBody>
@@ -7259,1288 +6244,10 @@
                 <a:ea typeface="Calibri"/>
                 <a:cs typeface="Calibri"/>
               </a:rPr>
-              <a:t>A precise error tells the agent what to change</a:t>
-            </a:r>
-          </a:p>
-        </p:txBody>
-      </p:sp>
-      <p:sp>
-        <p:nvSpPr>
-          <p:cNvPr id="3" name="">
-            <a:extLst xmlns:a="http://schemas.openxmlformats.org/drawingml/2006/main">
-              <a:ext uri="{FF2B5EF4-FFF2-40B4-BE49-F238E27FC236}">
-                <a16:creationId xmlns:a16="http://schemas.microsoft.com/office/drawing/2014/main" id="{D7E8B752-5838-4084-A09E-2C38B9D5B30B}"/>
-              </a:ext>
-            </a:extLst>
-          </p:cNvPr>
-          <p:cNvSpPr>
-            <a:spLocks xmlns:a="http://schemas.openxmlformats.org/drawingml/2006/main" noGrp="1"/>
-          </p:cNvSpPr>
-          <p:nvPr/>
-        </p:nvSpPr>
-        <p:spPr>
-          <a:xfrm xmlns:a="http://schemas.openxmlformats.org/drawingml/2006/main">
-            <a:off x="1028700" y="2800350"/>
-            <a:ext cx="2476500" cy="361950"/>
-          </a:xfrm>
-          <a:prstGeom xmlns:a="http://schemas.openxmlformats.org/drawingml/2006/main" prst="rect">
-            <a:avLst/>
-          </a:prstGeom>
-          <a:noFill xmlns:a="http://schemas.openxmlformats.org/drawingml/2006/main"/>
-          <a:ln xmlns:a="http://schemas.openxmlformats.org/drawingml/2006/main" w="0">
-            <a:noFill/>
-            <a:prstDash val="solid"/>
-          </a:ln>
-        </p:spPr>
-        <p:txBody>
-          <a:bodyPr xmlns:a="http://schemas.openxmlformats.org/drawingml/2006/main" wrap="square" lIns="0" tIns="0" rIns="0" bIns="0" anchor="ctr">
-            <a:noAutofit/>
-          </a:bodyPr>
-          <a:lstStyle xmlns:a="http://schemas.openxmlformats.org/drawingml/2006/main"/>
-          <a:p xmlns:a="http://schemas.openxmlformats.org/drawingml/2006/main">
-            <a:pPr algn="l">
-              <a:lnSpc>
-                <a:spcPct val="100000"/>
-              </a:lnSpc>
-              <a:buNone/>
-              <a:defRPr sz="1350" b="1">
-                <a:solidFill>
-                  <a:srgbClr val="F07D00"/>
-                </a:solidFill>
-                <a:latin typeface="Calibri"/>
-                <a:ea typeface="Calibri"/>
-                <a:cs typeface="Calibri"/>
-              </a:defRPr>
-            </a:pPr>
-            <a:r>
-              <a:rPr sz="1800" b="1">
-                <a:solidFill>
-                  <a:srgbClr val="F07D00"/>
-                </a:solidFill>
-                <a:latin typeface="Calibri"/>
-                <a:ea typeface="Calibri"/>
-                <a:cs typeface="Calibri"/>
-              </a:rPr>
-              <a:t>INVALID REQUEST</a:t>
-            </a:r>
-          </a:p>
-        </p:txBody>
-      </p:sp>
-      <p:sp>
-        <p:nvSpPr>
-          <p:cNvPr id="4" name="">
-            <a:extLst xmlns:a="http://schemas.openxmlformats.org/drawingml/2006/main">
-              <a:ext uri="{FF2B5EF4-FFF2-40B4-BE49-F238E27FC236}">
-                <a16:creationId xmlns:a16="http://schemas.microsoft.com/office/drawing/2014/main" id="{6CA53B89-6D78-4803-9B7F-A0162294F364}"/>
-              </a:ext>
-            </a:extLst>
-          </p:cNvPr>
-          <p:cNvSpPr>
-            <a:spLocks xmlns:a="http://schemas.openxmlformats.org/drawingml/2006/main" noGrp="1"/>
-          </p:cNvSpPr>
-          <p:nvPr/>
-        </p:nvSpPr>
-        <p:spPr>
-          <a:xfrm xmlns:a="http://schemas.openxmlformats.org/drawingml/2006/main">
-            <a:off x="3714750" y="2743200"/>
-            <a:ext cx="2381250" cy="647700"/>
-          </a:xfrm>
-          <a:prstGeom xmlns:a="http://schemas.openxmlformats.org/drawingml/2006/main" prst="roundRect">
-            <a:avLst>
-              <a:gd name="adj" fmla="val 5882"/>
-            </a:avLst>
-          </a:prstGeom>
-          <a:solidFill xmlns:a="http://schemas.openxmlformats.org/drawingml/2006/main">
-            <a:srgbClr val="1F40CB"/>
-          </a:solidFill>
-          <a:ln xmlns:a="http://schemas.openxmlformats.org/drawingml/2006/main" w="9525">
-            <a:solidFill>
-              <a:srgbClr val="FFFFFF"/>
-            </a:solidFill>
-            <a:prstDash val="solid"/>
-          </a:ln>
-        </p:spPr>
-      </p:sp>
-      <p:sp>
-        <p:nvSpPr>
-          <p:cNvPr id="5" name="">
-            <a:extLst xmlns:a="http://schemas.openxmlformats.org/drawingml/2006/main">
-              <a:ext uri="{FF2B5EF4-FFF2-40B4-BE49-F238E27FC236}">
-                <a16:creationId xmlns:a16="http://schemas.microsoft.com/office/drawing/2014/main" id="{132FC0D2-12CA-4723-B1F4-C8F21C5F174F}"/>
-              </a:ext>
-            </a:extLst>
-          </p:cNvPr>
-          <p:cNvSpPr>
-            <a:spLocks xmlns:a="http://schemas.openxmlformats.org/drawingml/2006/main" noGrp="1"/>
-          </p:cNvSpPr>
-          <p:nvPr/>
-        </p:nvSpPr>
-        <p:spPr>
-          <a:xfrm xmlns:a="http://schemas.openxmlformats.org/drawingml/2006/main">
-            <a:off x="3810000" y="2838450"/>
-            <a:ext cx="2190750" cy="457200"/>
-          </a:xfrm>
-          <a:prstGeom xmlns:a="http://schemas.openxmlformats.org/drawingml/2006/main" prst="rect">
-            <a:avLst/>
-          </a:prstGeom>
-          <a:noFill xmlns:a="http://schemas.openxmlformats.org/drawingml/2006/main"/>
-          <a:ln xmlns:a="http://schemas.openxmlformats.org/drawingml/2006/main" w="0">
-            <a:noFill/>
-            <a:prstDash val="solid"/>
-          </a:ln>
-        </p:spPr>
-        <p:txBody>
-          <a:bodyPr xmlns:a="http://schemas.openxmlformats.org/drawingml/2006/main" wrap="square" lIns="0" tIns="0" rIns="0" bIns="0" anchor="ctr">
-            <a:noAutofit/>
-          </a:bodyPr>
-          <a:lstStyle xmlns:a="http://schemas.openxmlformats.org/drawingml/2006/main"/>
-          <a:p xmlns:a="http://schemas.openxmlformats.org/drawingml/2006/main">
-            <a:pPr algn="ctr">
-              <a:lnSpc>
-                <a:spcPct val="100000"/>
-              </a:lnSpc>
-              <a:buNone/>
-              <a:defRPr sz="1275" b="1">
-                <a:solidFill>
-                  <a:srgbClr val="FFFFFF"/>
-                </a:solidFill>
-                <a:latin typeface="Calibri"/>
-                <a:ea typeface="Calibri"/>
-                <a:cs typeface="Calibri"/>
-              </a:defRPr>
-            </a:pPr>
-            <a:r>
-              <a:rPr sz="1800" b="1">
-                <a:solidFill>
-                  <a:srgbClr val="FFFFFF"/>
-                </a:solidFill>
-                <a:latin typeface="Calibri"/>
-                <a:ea typeface="Calibri"/>
-                <a:cs typeface="Calibri"/>
-              </a:rPr>
-              <a:t>get_metric</a:t>
-            </a:r>
-          </a:p>
-        </p:txBody>
-      </p:sp>
-      <p:sp>
-        <p:nvSpPr>
-          <p:cNvPr id="6" name="">
-            <a:extLst xmlns:a="http://schemas.openxmlformats.org/drawingml/2006/main">
-              <a:ext uri="{FF2B5EF4-FFF2-40B4-BE49-F238E27FC236}">
-                <a16:creationId xmlns:a16="http://schemas.microsoft.com/office/drawing/2014/main" id="{3E9AAB83-2BB1-4A7A-84F9-1F2BE14A6F81}"/>
-              </a:ext>
-            </a:extLst>
-          </p:cNvPr>
-          <p:cNvSpPr>
-            <a:spLocks xmlns:a="http://schemas.openxmlformats.org/drawingml/2006/main" noGrp="1"/>
-          </p:cNvSpPr>
-          <p:nvPr/>
-        </p:nvSpPr>
-        <p:spPr>
-          <a:xfrm xmlns:a="http://schemas.openxmlformats.org/drawingml/2006/main">
-            <a:off x="6153150" y="2743200"/>
-            <a:ext cx="2000250" cy="647700"/>
-          </a:xfrm>
-          <a:prstGeom xmlns:a="http://schemas.openxmlformats.org/drawingml/2006/main" prst="roundRect">
-            <a:avLst>
-              <a:gd name="adj" fmla="val 5882"/>
-            </a:avLst>
-          </a:prstGeom>
-          <a:solidFill xmlns:a="http://schemas.openxmlformats.org/drawingml/2006/main">
-            <a:srgbClr val="F07D00"/>
-          </a:solidFill>
-          <a:ln xmlns:a="http://schemas.openxmlformats.org/drawingml/2006/main" w="9525">
-            <a:solidFill>
-              <a:srgbClr val="FFFFFF"/>
-            </a:solidFill>
-            <a:prstDash val="solid"/>
-          </a:ln>
-        </p:spPr>
-      </p:sp>
-      <p:sp>
-        <p:nvSpPr>
-          <p:cNvPr id="7" name="">
-            <a:extLst xmlns:a="http://schemas.openxmlformats.org/drawingml/2006/main">
-              <a:ext uri="{FF2B5EF4-FFF2-40B4-BE49-F238E27FC236}">
-                <a16:creationId xmlns:a16="http://schemas.microsoft.com/office/drawing/2014/main" id="{6740ED07-2E49-4E7A-9CBF-23CD3B8CFFB4}"/>
-              </a:ext>
-            </a:extLst>
-          </p:cNvPr>
-          <p:cNvSpPr>
-            <a:spLocks xmlns:a="http://schemas.openxmlformats.org/drawingml/2006/main" noGrp="1"/>
-          </p:cNvSpPr>
-          <p:nvPr/>
-        </p:nvSpPr>
-        <p:spPr>
-          <a:xfrm xmlns:a="http://schemas.openxmlformats.org/drawingml/2006/main">
-            <a:off x="6248400" y="2838450"/>
-            <a:ext cx="1809750" cy="457200"/>
-          </a:xfrm>
-          <a:prstGeom xmlns:a="http://schemas.openxmlformats.org/drawingml/2006/main" prst="rect">
-            <a:avLst/>
-          </a:prstGeom>
-          <a:noFill xmlns:a="http://schemas.openxmlformats.org/drawingml/2006/main"/>
-          <a:ln xmlns:a="http://schemas.openxmlformats.org/drawingml/2006/main" w="0">
-            <a:noFill/>
-            <a:prstDash val="solid"/>
-          </a:ln>
-        </p:spPr>
-        <p:txBody>
-          <a:bodyPr xmlns:a="http://schemas.openxmlformats.org/drawingml/2006/main" wrap="square" lIns="0" tIns="0" rIns="0" bIns="0" anchor="ctr">
-            <a:noAutofit/>
-          </a:bodyPr>
-          <a:lstStyle xmlns:a="http://schemas.openxmlformats.org/drawingml/2006/main"/>
-          <a:p xmlns:a="http://schemas.openxmlformats.org/drawingml/2006/main">
-            <a:pPr algn="ctr">
-              <a:lnSpc>
-                <a:spcPct val="100000"/>
-              </a:lnSpc>
-              <a:buNone/>
-              <a:defRPr sz="1275" b="1">
-                <a:solidFill>
-                  <a:srgbClr val="FFFFFF"/>
-                </a:solidFill>
-                <a:latin typeface="Calibri"/>
-                <a:ea typeface="Calibri"/>
-                <a:cs typeface="Calibri"/>
-              </a:defRPr>
-            </a:pPr>
-            <a:r>
-              <a:rPr sz="1800" b="1">
-                <a:solidFill>
-                  <a:srgbClr val="FFFFFF"/>
-                </a:solidFill>
-                <a:latin typeface="Calibri"/>
-                <a:ea typeface="Calibri"/>
-                <a:cs typeface="Calibri"/>
-              </a:rPr>
-              <a:t>ticker = NVDA</a:t>
-            </a:r>
-          </a:p>
-        </p:txBody>
-      </p:sp>
-      <p:sp>
-        <p:nvSpPr>
-          <p:cNvPr id="8" name="">
-            <a:extLst xmlns:a="http://schemas.openxmlformats.org/drawingml/2006/main">
-              <a:ext uri="{FF2B5EF4-FFF2-40B4-BE49-F238E27FC236}">
-                <a16:creationId xmlns:a16="http://schemas.microsoft.com/office/drawing/2014/main" id="{E5A5E176-BCBA-4C49-9196-B98EF7C59C62}"/>
-              </a:ext>
-            </a:extLst>
-          </p:cNvPr>
-          <p:cNvSpPr>
-            <a:spLocks xmlns:a="http://schemas.openxmlformats.org/drawingml/2006/main" noGrp="1"/>
-          </p:cNvSpPr>
-          <p:nvPr/>
-        </p:nvSpPr>
-        <p:spPr>
-          <a:xfrm xmlns:a="http://schemas.openxmlformats.org/drawingml/2006/main">
-            <a:off x="8210550" y="2743200"/>
-            <a:ext cx="1676400" cy="647700"/>
-          </a:xfrm>
-          <a:prstGeom xmlns:a="http://schemas.openxmlformats.org/drawingml/2006/main" prst="roundRect">
-            <a:avLst>
-              <a:gd name="adj" fmla="val 5882"/>
-            </a:avLst>
-          </a:prstGeom>
-          <a:solidFill xmlns:a="http://schemas.openxmlformats.org/drawingml/2006/main">
-            <a:srgbClr val="1F40CB"/>
-          </a:solidFill>
-          <a:ln xmlns:a="http://schemas.openxmlformats.org/drawingml/2006/main" w="9525">
-            <a:solidFill>
-              <a:srgbClr val="FFFFFF"/>
-            </a:solidFill>
-            <a:prstDash val="solid"/>
-          </a:ln>
-        </p:spPr>
-      </p:sp>
-      <p:sp>
-        <p:nvSpPr>
-          <p:cNvPr id="9" name="">
-            <a:extLst xmlns:a="http://schemas.openxmlformats.org/drawingml/2006/main">
-              <a:ext uri="{FF2B5EF4-FFF2-40B4-BE49-F238E27FC236}">
-                <a16:creationId xmlns:a16="http://schemas.microsoft.com/office/drawing/2014/main" id="{2D62C752-A7F9-4B50-9D20-A71CEAD8FABF}"/>
-              </a:ext>
-            </a:extLst>
-          </p:cNvPr>
-          <p:cNvSpPr>
-            <a:spLocks xmlns:a="http://schemas.openxmlformats.org/drawingml/2006/main" noGrp="1"/>
-          </p:cNvSpPr>
-          <p:nvPr/>
-        </p:nvSpPr>
-        <p:spPr>
-          <a:xfrm xmlns:a="http://schemas.openxmlformats.org/drawingml/2006/main">
-            <a:off x="8305800" y="2838450"/>
-            <a:ext cx="1485900" cy="457200"/>
-          </a:xfrm>
-          <a:prstGeom xmlns:a="http://schemas.openxmlformats.org/drawingml/2006/main" prst="rect">
-            <a:avLst/>
-          </a:prstGeom>
-          <a:noFill xmlns:a="http://schemas.openxmlformats.org/drawingml/2006/main"/>
-          <a:ln xmlns:a="http://schemas.openxmlformats.org/drawingml/2006/main" w="0">
-            <a:noFill/>
-            <a:prstDash val="solid"/>
-          </a:ln>
-        </p:spPr>
-        <p:txBody>
-          <a:bodyPr xmlns:a="http://schemas.openxmlformats.org/drawingml/2006/main" wrap="square" lIns="0" tIns="0" rIns="0" bIns="0" anchor="ctr">
-            <a:noAutofit/>
-          </a:bodyPr>
-          <a:lstStyle xmlns:a="http://schemas.openxmlformats.org/drawingml/2006/main"/>
-          <a:p xmlns:a="http://schemas.openxmlformats.org/drawingml/2006/main">
-            <a:pPr algn="ctr">
-              <a:lnSpc>
-                <a:spcPct val="100000"/>
-              </a:lnSpc>
-              <a:buNone/>
-              <a:defRPr sz="1275" b="1">
-                <a:solidFill>
-                  <a:srgbClr val="FFFFFF"/>
-                </a:solidFill>
-                <a:latin typeface="Calibri"/>
-                <a:ea typeface="Calibri"/>
-                <a:cs typeface="Calibri"/>
-              </a:defRPr>
-            </a:pPr>
-            <a:r>
-              <a:rPr sz="1800" b="1">
-                <a:solidFill>
-                  <a:srgbClr val="FFFFFF"/>
-                </a:solidFill>
-                <a:latin typeface="Calibri"/>
-                <a:ea typeface="Calibri"/>
-                <a:cs typeface="Calibri"/>
-              </a:rPr>
-              <a:t>metric = PE</a:t>
-            </a:r>
-          </a:p>
-        </p:txBody>
-      </p:sp>
-      <p:sp>
-        <p:nvSpPr>
-          <p:cNvPr id="10" name="">
-            <a:extLst xmlns:a="http://schemas.openxmlformats.org/drawingml/2006/main">
-              <a:ext uri="{FF2B5EF4-FFF2-40B4-BE49-F238E27FC236}">
-                <a16:creationId xmlns:a16="http://schemas.microsoft.com/office/drawing/2014/main" id="{F9A9A56C-9DB1-49FF-8E87-2C6B8DB8CE93}"/>
-              </a:ext>
-            </a:extLst>
-          </p:cNvPr>
-          <p:cNvSpPr>
-            <a:spLocks xmlns:a="http://schemas.openxmlformats.org/drawingml/2006/main" noGrp="1"/>
-          </p:cNvSpPr>
-          <p:nvPr/>
-        </p:nvSpPr>
-        <p:spPr>
-          <a:xfrm xmlns:a="http://schemas.openxmlformats.org/drawingml/2006/main">
-            <a:off x="9944100" y="2743200"/>
-            <a:ext cx="1066800" cy="647700"/>
-          </a:xfrm>
-          <a:prstGeom xmlns:a="http://schemas.openxmlformats.org/drawingml/2006/main" prst="roundRect">
-            <a:avLst>
-              <a:gd name="adj" fmla="val 5882"/>
-            </a:avLst>
-          </a:prstGeom>
-          <a:solidFill xmlns:a="http://schemas.openxmlformats.org/drawingml/2006/main">
-            <a:srgbClr val="F07D00"/>
-          </a:solidFill>
-          <a:ln xmlns:a="http://schemas.openxmlformats.org/drawingml/2006/main" w="9525">
-            <a:solidFill>
-              <a:srgbClr val="FFFFFF"/>
-            </a:solidFill>
-            <a:prstDash val="solid"/>
-          </a:ln>
-        </p:spPr>
-      </p:sp>
-      <p:sp>
-        <p:nvSpPr>
-          <p:cNvPr id="11" name="">
-            <a:extLst xmlns:a="http://schemas.openxmlformats.org/drawingml/2006/main">
-              <a:ext uri="{FF2B5EF4-FFF2-40B4-BE49-F238E27FC236}">
-                <a16:creationId xmlns:a16="http://schemas.microsoft.com/office/drawing/2014/main" id="{D9D4F50D-12C3-4331-801A-91C1EC1A4D30}"/>
-              </a:ext>
-            </a:extLst>
-          </p:cNvPr>
-          <p:cNvSpPr>
-            <a:spLocks xmlns:a="http://schemas.openxmlformats.org/drawingml/2006/main" noGrp="1"/>
-          </p:cNvSpPr>
-          <p:nvPr/>
-        </p:nvSpPr>
-        <p:spPr>
-          <a:xfrm xmlns:a="http://schemas.openxmlformats.org/drawingml/2006/main">
-            <a:off x="10039350" y="2838450"/>
-            <a:ext cx="876300" cy="457200"/>
-          </a:xfrm>
-          <a:prstGeom xmlns:a="http://schemas.openxmlformats.org/drawingml/2006/main" prst="rect">
-            <a:avLst/>
-          </a:prstGeom>
-          <a:noFill xmlns:a="http://schemas.openxmlformats.org/drawingml/2006/main"/>
-          <a:ln xmlns:a="http://schemas.openxmlformats.org/drawingml/2006/main" w="0">
-            <a:noFill/>
-            <a:prstDash val="solid"/>
-          </a:ln>
-        </p:spPr>
-        <p:txBody>
-          <a:bodyPr xmlns:a="http://schemas.openxmlformats.org/drawingml/2006/main" wrap="square" lIns="0" tIns="0" rIns="0" bIns="0" anchor="ctr">
-            <a:noAutofit/>
-          </a:bodyPr>
-          <a:lstStyle xmlns:a="http://schemas.openxmlformats.org/drawingml/2006/main"/>
-          <a:p xmlns:a="http://schemas.openxmlformats.org/drawingml/2006/main">
-            <a:pPr algn="ctr">
-              <a:lnSpc>
-                <a:spcPct val="100000"/>
-              </a:lnSpc>
-              <a:buNone/>
-              <a:defRPr sz="1275" b="1">
-                <a:solidFill>
-                  <a:srgbClr val="FFFFFF"/>
-                </a:solidFill>
-                <a:latin typeface="Calibri"/>
-                <a:ea typeface="Calibri"/>
-                <a:cs typeface="Calibri"/>
-              </a:defRPr>
-            </a:pPr>
-            <a:r>
-              <a:rPr sz="1800" b="1">
-                <a:solidFill>
-                  <a:srgbClr val="FFFFFF"/>
-                </a:solidFill>
-                <a:latin typeface="Calibri"/>
-                <a:ea typeface="Calibri"/>
-                <a:cs typeface="Calibri"/>
-              </a:rPr>
-              <a:t>typed</a:t>
-            </a:r>
-          </a:p>
-        </p:txBody>
-      </p:sp>
-      <p:sp>
-        <p:nvSpPr>
-          <p:cNvPr id="12" name="">
-            <a:extLst xmlns:a="http://schemas.openxmlformats.org/drawingml/2006/main">
-              <a:ext uri="{FF2B5EF4-FFF2-40B4-BE49-F238E27FC236}">
-                <a16:creationId xmlns:a16="http://schemas.microsoft.com/office/drawing/2014/main" id="{194D2954-A4C1-482E-AAB1-42DAC0BB1957}"/>
-              </a:ext>
-            </a:extLst>
-          </p:cNvPr>
-          <p:cNvSpPr>
-            <a:spLocks xmlns:a="http://schemas.openxmlformats.org/drawingml/2006/main" noGrp="1"/>
-          </p:cNvSpPr>
-          <p:nvPr/>
-        </p:nvSpPr>
-        <p:spPr>
-          <a:xfrm xmlns:a="http://schemas.openxmlformats.org/drawingml/2006/main">
-            <a:off x="12001500" y="2800350"/>
-            <a:ext cx="2190750" cy="361950"/>
-          </a:xfrm>
-          <a:prstGeom xmlns:a="http://schemas.openxmlformats.org/drawingml/2006/main" prst="rect">
-            <a:avLst/>
-          </a:prstGeom>
-          <a:noFill xmlns:a="http://schemas.openxmlformats.org/drawingml/2006/main"/>
-          <a:ln xmlns:a="http://schemas.openxmlformats.org/drawingml/2006/main" w="0">
-            <a:noFill/>
-            <a:prstDash val="solid"/>
-          </a:ln>
-        </p:spPr>
-        <p:txBody>
-          <a:bodyPr xmlns:a="http://schemas.openxmlformats.org/drawingml/2006/main" wrap="square" lIns="0" tIns="0" rIns="0" bIns="0" anchor="ctr">
-            <a:noAutofit/>
-          </a:bodyPr>
-          <a:lstStyle xmlns:a="http://schemas.openxmlformats.org/drawingml/2006/main"/>
-          <a:p xmlns:a="http://schemas.openxmlformats.org/drawingml/2006/main">
-            <a:pPr algn="r">
-              <a:lnSpc>
-                <a:spcPct val="100000"/>
-              </a:lnSpc>
-              <a:buNone/>
-              <a:defRPr sz="1350" b="1">
-                <a:solidFill>
-                  <a:srgbClr val="F07D00"/>
-                </a:solidFill>
-                <a:latin typeface="Calibri"/>
-                <a:ea typeface="Calibri"/>
-                <a:cs typeface="Calibri"/>
-              </a:defRPr>
-            </a:pPr>
-            <a:r>
-              <a:rPr sz="1800" b="1">
-                <a:solidFill>
-                  <a:srgbClr val="F07D00"/>
-                </a:solidFill>
-                <a:latin typeface="Calibri"/>
-                <a:ea typeface="Calibri"/>
-                <a:cs typeface="Calibri"/>
-              </a:rPr>
-              <a:t>rejected</a:t>
-            </a:r>
-          </a:p>
-        </p:txBody>
-      </p:sp>
-      <p:sp>
-        <p:nvSpPr>
-          <p:cNvPr id="13" name="">
-            <a:extLst xmlns:a="http://schemas.openxmlformats.org/drawingml/2006/main">
-              <a:ext uri="{FF2B5EF4-FFF2-40B4-BE49-F238E27FC236}">
-                <a16:creationId xmlns:a16="http://schemas.microsoft.com/office/drawing/2014/main" id="{B3122776-3C69-478E-8B1D-4E859ACC8602}"/>
-              </a:ext>
-            </a:extLst>
-          </p:cNvPr>
-          <p:cNvSpPr>
-            <a:spLocks xmlns:a="http://schemas.openxmlformats.org/drawingml/2006/main" noGrp="1"/>
-          </p:cNvSpPr>
-          <p:nvPr/>
-        </p:nvSpPr>
-        <p:spPr>
-          <a:xfrm xmlns:a="http://schemas.openxmlformats.org/drawingml/2006/main">
-            <a:off x="1028700" y="4267200"/>
-            <a:ext cx="2476500" cy="361950"/>
-          </a:xfrm>
-          <a:prstGeom xmlns:a="http://schemas.openxmlformats.org/drawingml/2006/main" prst="rect">
-            <a:avLst/>
-          </a:prstGeom>
-          <a:noFill xmlns:a="http://schemas.openxmlformats.org/drawingml/2006/main"/>
-          <a:ln xmlns:a="http://schemas.openxmlformats.org/drawingml/2006/main" w="0">
-            <a:noFill/>
-            <a:prstDash val="solid"/>
-          </a:ln>
-        </p:spPr>
-        <p:txBody>
-          <a:bodyPr xmlns:a="http://schemas.openxmlformats.org/drawingml/2006/main" wrap="square" lIns="0" tIns="0" rIns="0" bIns="0" anchor="ctr">
-            <a:noAutofit/>
-          </a:bodyPr>
-          <a:lstStyle xmlns:a="http://schemas.openxmlformats.org/drawingml/2006/main"/>
-          <a:p xmlns:a="http://schemas.openxmlformats.org/drawingml/2006/main">
-            <a:pPr algn="l">
-              <a:lnSpc>
-                <a:spcPct val="100000"/>
-              </a:lnSpc>
-              <a:buNone/>
-              <a:defRPr sz="1350" b="1">
-                <a:solidFill>
-                  <a:srgbClr val="00A2EB"/>
-                </a:solidFill>
-                <a:latin typeface="Calibri"/>
-                <a:ea typeface="Calibri"/>
-                <a:cs typeface="Calibri"/>
-              </a:defRPr>
-            </a:pPr>
-            <a:r>
-              <a:rPr sz="1800" b="1">
-                <a:solidFill>
-                  <a:srgbClr val="00A2EB"/>
-                </a:solidFill>
-                <a:latin typeface="Calibri"/>
-                <a:ea typeface="Calibri"/>
-                <a:cs typeface="Calibri"/>
-              </a:rPr>
-              <a:t>TOOL FEEDBACK</a:t>
-            </a:r>
-          </a:p>
-        </p:txBody>
-      </p:sp>
-      <p:sp>
-        <p:nvSpPr>
-          <p:cNvPr id="14" name="">
-            <a:extLst xmlns:a="http://schemas.openxmlformats.org/drawingml/2006/main">
-              <a:ext uri="{FF2B5EF4-FFF2-40B4-BE49-F238E27FC236}">
-                <a16:creationId xmlns:a16="http://schemas.microsoft.com/office/drawing/2014/main" id="{0020E4D2-1B72-432A-AD48-61D3EF9BCCA8}"/>
-              </a:ext>
-            </a:extLst>
-          </p:cNvPr>
-          <p:cNvSpPr>
-            <a:spLocks xmlns:a="http://schemas.openxmlformats.org/drawingml/2006/main" noGrp="1"/>
-          </p:cNvSpPr>
-          <p:nvPr/>
-        </p:nvSpPr>
-        <p:spPr>
-          <a:xfrm xmlns:a="http://schemas.openxmlformats.org/drawingml/2006/main">
-            <a:off x="3714750" y="4210050"/>
-            <a:ext cx="3143250" cy="647700"/>
-          </a:xfrm>
-          <a:prstGeom xmlns:a="http://schemas.openxmlformats.org/drawingml/2006/main" prst="roundRect">
-            <a:avLst>
-              <a:gd name="adj" fmla="val 5882"/>
-            </a:avLst>
-          </a:prstGeom>
-          <a:solidFill xmlns:a="http://schemas.openxmlformats.org/drawingml/2006/main">
-            <a:srgbClr val="1F40CB"/>
-          </a:solidFill>
-          <a:ln xmlns:a="http://schemas.openxmlformats.org/drawingml/2006/main" w="9525">
-            <a:solidFill>
-              <a:srgbClr val="FFFFFF"/>
-            </a:solidFill>
-            <a:prstDash val="solid"/>
-          </a:ln>
-        </p:spPr>
-      </p:sp>
-      <p:sp>
-        <p:nvSpPr>
-          <p:cNvPr id="15" name="">
-            <a:extLst xmlns:a="http://schemas.openxmlformats.org/drawingml/2006/main">
-              <a:ext uri="{FF2B5EF4-FFF2-40B4-BE49-F238E27FC236}">
-                <a16:creationId xmlns:a16="http://schemas.microsoft.com/office/drawing/2014/main" id="{499905A1-C4D3-46AB-A516-DCFB88A03736}"/>
-              </a:ext>
-            </a:extLst>
-          </p:cNvPr>
-          <p:cNvSpPr>
-            <a:spLocks xmlns:a="http://schemas.openxmlformats.org/drawingml/2006/main" noGrp="1"/>
-          </p:cNvSpPr>
-          <p:nvPr/>
-        </p:nvSpPr>
-        <p:spPr>
-          <a:xfrm xmlns:a="http://schemas.openxmlformats.org/drawingml/2006/main">
-            <a:off x="3810000" y="4305300"/>
-            <a:ext cx="2952750" cy="457200"/>
-          </a:xfrm>
-          <a:prstGeom xmlns:a="http://schemas.openxmlformats.org/drawingml/2006/main" prst="rect">
-            <a:avLst/>
-          </a:prstGeom>
-          <a:noFill xmlns:a="http://schemas.openxmlformats.org/drawingml/2006/main"/>
-          <a:ln xmlns:a="http://schemas.openxmlformats.org/drawingml/2006/main" w="0">
-            <a:noFill/>
-            <a:prstDash val="solid"/>
-          </a:ln>
-        </p:spPr>
-        <p:txBody>
-          <a:bodyPr xmlns:a="http://schemas.openxmlformats.org/drawingml/2006/main" wrap="square" lIns="0" tIns="0" rIns="0" bIns="0" anchor="ctr">
-            <a:noAutofit/>
-          </a:bodyPr>
-          <a:lstStyle xmlns:a="http://schemas.openxmlformats.org/drawingml/2006/main"/>
-          <a:p xmlns:a="http://schemas.openxmlformats.org/drawingml/2006/main">
-            <a:pPr algn="ctr">
-              <a:lnSpc>
-                <a:spcPct val="100000"/>
-              </a:lnSpc>
-              <a:buNone/>
-              <a:defRPr sz="1275" b="1">
-                <a:solidFill>
-                  <a:srgbClr val="FFFFFF"/>
-                </a:solidFill>
-                <a:latin typeface="Calibri"/>
-                <a:ea typeface="Calibri"/>
-                <a:cs typeface="Calibri"/>
-              </a:defRPr>
-            </a:pPr>
-            <a:r>
-              <a:rPr sz="1800" b="1">
-                <a:solidFill>
-                  <a:srgbClr val="FFFFFF"/>
-                </a:solidFill>
-                <a:latin typeface="Calibri"/>
-                <a:ea typeface="Calibri"/>
-                <a:cs typeface="Calibri"/>
-              </a:rPr>
-              <a:t>unsupported_metric</a:t>
-            </a:r>
-          </a:p>
-        </p:txBody>
-      </p:sp>
-      <p:sp>
-        <p:nvSpPr>
-          <p:cNvPr id="16" name="">
-            <a:extLst xmlns:a="http://schemas.openxmlformats.org/drawingml/2006/main">
-              <a:ext uri="{FF2B5EF4-FFF2-40B4-BE49-F238E27FC236}">
-                <a16:creationId xmlns:a16="http://schemas.microsoft.com/office/drawing/2014/main" id="{7C2240E6-0102-4064-B038-AB12EDED68BD}"/>
-              </a:ext>
-            </a:extLst>
-          </p:cNvPr>
-          <p:cNvSpPr>
-            <a:spLocks xmlns:a="http://schemas.openxmlformats.org/drawingml/2006/main" noGrp="1"/>
-          </p:cNvSpPr>
-          <p:nvPr/>
-        </p:nvSpPr>
-        <p:spPr>
-          <a:xfrm xmlns:a="http://schemas.openxmlformats.org/drawingml/2006/main">
-            <a:off x="6915150" y="4210050"/>
-            <a:ext cx="2952750" cy="647700"/>
-          </a:xfrm>
-          <a:prstGeom xmlns:a="http://schemas.openxmlformats.org/drawingml/2006/main" prst="roundRect">
-            <a:avLst>
-              <a:gd name="adj" fmla="val 5882"/>
-            </a:avLst>
-          </a:prstGeom>
-          <a:solidFill xmlns:a="http://schemas.openxmlformats.org/drawingml/2006/main">
-            <a:srgbClr val="00A2EB"/>
-          </a:solidFill>
-          <a:ln xmlns:a="http://schemas.openxmlformats.org/drawingml/2006/main" w="9525">
-            <a:solidFill>
-              <a:srgbClr val="FFFFFF"/>
-            </a:solidFill>
-            <a:prstDash val="solid"/>
-          </a:ln>
-        </p:spPr>
-      </p:sp>
-      <p:sp>
-        <p:nvSpPr>
-          <p:cNvPr id="17" name="">
-            <a:extLst xmlns:a="http://schemas.openxmlformats.org/drawingml/2006/main">
-              <a:ext uri="{FF2B5EF4-FFF2-40B4-BE49-F238E27FC236}">
-                <a16:creationId xmlns:a16="http://schemas.microsoft.com/office/drawing/2014/main" id="{7ECBA82F-0F85-40C1-9BE1-6E7847AE3FF4}"/>
-              </a:ext>
-            </a:extLst>
-          </p:cNvPr>
-          <p:cNvSpPr>
-            <a:spLocks xmlns:a="http://schemas.openxmlformats.org/drawingml/2006/main" noGrp="1"/>
-          </p:cNvSpPr>
-          <p:nvPr/>
-        </p:nvSpPr>
-        <p:spPr>
-          <a:xfrm xmlns:a="http://schemas.openxmlformats.org/drawingml/2006/main">
-            <a:off x="7010400" y="4305300"/>
-            <a:ext cx="2762250" cy="457200"/>
-          </a:xfrm>
-          <a:prstGeom xmlns:a="http://schemas.openxmlformats.org/drawingml/2006/main" prst="rect">
-            <a:avLst/>
-          </a:prstGeom>
-          <a:noFill xmlns:a="http://schemas.openxmlformats.org/drawingml/2006/main"/>
-          <a:ln xmlns:a="http://schemas.openxmlformats.org/drawingml/2006/main" w="0">
-            <a:noFill/>
-            <a:prstDash val="solid"/>
-          </a:ln>
-        </p:spPr>
-        <p:txBody>
-          <a:bodyPr xmlns:a="http://schemas.openxmlformats.org/drawingml/2006/main" wrap="square" lIns="0" tIns="0" rIns="0" bIns="0" anchor="ctr">
-            <a:noAutofit/>
-          </a:bodyPr>
-          <a:lstStyle xmlns:a="http://schemas.openxmlformats.org/drawingml/2006/main"/>
-          <a:p xmlns:a="http://schemas.openxmlformats.org/drawingml/2006/main">
-            <a:pPr algn="ctr">
-              <a:lnSpc>
-                <a:spcPct val="100000"/>
-              </a:lnSpc>
-              <a:buNone/>
-              <a:defRPr sz="1275" b="1">
-                <a:solidFill>
-                  <a:srgbClr val="FFFFFF"/>
-                </a:solidFill>
-                <a:latin typeface="Calibri"/>
-                <a:ea typeface="Calibri"/>
-                <a:cs typeface="Calibri"/>
-              </a:defRPr>
-            </a:pPr>
-            <a:r>
-              <a:rPr sz="1800" b="1">
-                <a:solidFill>
-                  <a:srgbClr val="FFFFFF"/>
-                </a:solidFill>
-                <a:latin typeface="Calibri"/>
-                <a:ea typeface="Calibri"/>
-                <a:cs typeface="Calibri"/>
-              </a:rPr>
-              <a:t>retryable = true</a:t>
-            </a:r>
-          </a:p>
-        </p:txBody>
-      </p:sp>
-      <p:sp>
-        <p:nvSpPr>
-          <p:cNvPr id="18" name="">
-            <a:extLst xmlns:a="http://schemas.openxmlformats.org/drawingml/2006/main">
-              <a:ext uri="{FF2B5EF4-FFF2-40B4-BE49-F238E27FC236}">
-                <a16:creationId xmlns:a16="http://schemas.microsoft.com/office/drawing/2014/main" id="{6BD7C7D4-5A09-43DC-B381-56DF305B4223}"/>
-              </a:ext>
-            </a:extLst>
-          </p:cNvPr>
-          <p:cNvSpPr>
-            <a:spLocks xmlns:a="http://schemas.openxmlformats.org/drawingml/2006/main" noGrp="1"/>
-          </p:cNvSpPr>
-          <p:nvPr/>
-        </p:nvSpPr>
-        <p:spPr>
-          <a:xfrm xmlns:a="http://schemas.openxmlformats.org/drawingml/2006/main">
-            <a:off x="9925050" y="4210050"/>
-            <a:ext cx="2000250" cy="647700"/>
-          </a:xfrm>
-          <a:prstGeom xmlns:a="http://schemas.openxmlformats.org/drawingml/2006/main" prst="roundRect">
-            <a:avLst>
-              <a:gd name="adj" fmla="val 5882"/>
-            </a:avLst>
-          </a:prstGeom>
-          <a:solidFill xmlns:a="http://schemas.openxmlformats.org/drawingml/2006/main">
-            <a:srgbClr val="1F40CB"/>
-          </a:solidFill>
-          <a:ln xmlns:a="http://schemas.openxmlformats.org/drawingml/2006/main" w="9525">
-            <a:solidFill>
-              <a:srgbClr val="FFFFFF"/>
-            </a:solidFill>
-            <a:prstDash val="solid"/>
-          </a:ln>
-        </p:spPr>
-      </p:sp>
-      <p:sp>
-        <p:nvSpPr>
-          <p:cNvPr id="19" name="">
-            <a:extLst xmlns:a="http://schemas.openxmlformats.org/drawingml/2006/main">
-              <a:ext uri="{FF2B5EF4-FFF2-40B4-BE49-F238E27FC236}">
-                <a16:creationId xmlns:a16="http://schemas.microsoft.com/office/drawing/2014/main" id="{9A2F20F1-CF35-4789-AC4A-62229AB1DDA9}"/>
-              </a:ext>
-            </a:extLst>
-          </p:cNvPr>
-          <p:cNvSpPr>
-            <a:spLocks xmlns:a="http://schemas.openxmlformats.org/drawingml/2006/main" noGrp="1"/>
-          </p:cNvSpPr>
-          <p:nvPr/>
-        </p:nvSpPr>
-        <p:spPr>
-          <a:xfrm xmlns:a="http://schemas.openxmlformats.org/drawingml/2006/main">
-            <a:off x="10020300" y="4305300"/>
-            <a:ext cx="1809750" cy="457200"/>
-          </a:xfrm>
-          <a:prstGeom xmlns:a="http://schemas.openxmlformats.org/drawingml/2006/main" prst="rect">
-            <a:avLst/>
-          </a:prstGeom>
-          <a:noFill xmlns:a="http://schemas.openxmlformats.org/drawingml/2006/main"/>
-          <a:ln xmlns:a="http://schemas.openxmlformats.org/drawingml/2006/main" w="0">
-            <a:noFill/>
-            <a:prstDash val="solid"/>
-          </a:ln>
-        </p:spPr>
-        <p:txBody>
-          <a:bodyPr xmlns:a="http://schemas.openxmlformats.org/drawingml/2006/main" wrap="square" lIns="0" tIns="0" rIns="0" bIns="0" anchor="ctr">
-            <a:noAutofit/>
-          </a:bodyPr>
-          <a:lstStyle xmlns:a="http://schemas.openxmlformats.org/drawingml/2006/main"/>
-          <a:p xmlns:a="http://schemas.openxmlformats.org/drawingml/2006/main">
-            <a:pPr algn="ctr">
-              <a:lnSpc>
-                <a:spcPct val="100000"/>
-              </a:lnSpc>
-              <a:buNone/>
-              <a:defRPr sz="1275" b="1">
-                <a:solidFill>
-                  <a:srgbClr val="FFFFFF"/>
-                </a:solidFill>
-                <a:latin typeface="Calibri"/>
-                <a:ea typeface="Calibri"/>
-                <a:cs typeface="Calibri"/>
-              </a:defRPr>
-            </a:pPr>
-            <a:r>
-              <a:rPr sz="1800" b="1">
-                <a:solidFill>
-                  <a:srgbClr val="FFFFFF"/>
-                </a:solidFill>
-                <a:latin typeface="Calibri"/>
-                <a:ea typeface="Calibri"/>
-                <a:cs typeface="Calibri"/>
-              </a:rPr>
-              <a:t>Valid metrics: EPS, P/E</a:t>
-            </a:r>
-          </a:p>
-        </p:txBody>
-      </p:sp>
-      <p:sp>
-        <p:nvSpPr>
-          <p:cNvPr id="20" name="">
-            <a:extLst xmlns:a="http://schemas.openxmlformats.org/drawingml/2006/main">
-              <a:ext uri="{FF2B5EF4-FFF2-40B4-BE49-F238E27FC236}">
-                <a16:creationId xmlns:a16="http://schemas.microsoft.com/office/drawing/2014/main" id="{E58CD3E4-48E0-4421-8A8E-9A03948E1061}"/>
-              </a:ext>
-            </a:extLst>
-          </p:cNvPr>
-          <p:cNvSpPr>
-            <a:spLocks xmlns:a="http://schemas.openxmlformats.org/drawingml/2006/main" noGrp="1"/>
-          </p:cNvSpPr>
-          <p:nvPr/>
-        </p:nvSpPr>
-        <p:spPr>
-          <a:xfrm xmlns:a="http://schemas.openxmlformats.org/drawingml/2006/main">
-            <a:off x="12001500" y="4267200"/>
-            <a:ext cx="2190750" cy="361950"/>
-          </a:xfrm>
-          <a:prstGeom xmlns:a="http://schemas.openxmlformats.org/drawingml/2006/main" prst="rect">
-            <a:avLst/>
-          </a:prstGeom>
-          <a:noFill xmlns:a="http://schemas.openxmlformats.org/drawingml/2006/main"/>
-          <a:ln xmlns:a="http://schemas.openxmlformats.org/drawingml/2006/main" w="0">
-            <a:noFill/>
-            <a:prstDash val="solid"/>
-          </a:ln>
-        </p:spPr>
-        <p:txBody>
-          <a:bodyPr xmlns:a="http://schemas.openxmlformats.org/drawingml/2006/main" wrap="square" lIns="0" tIns="0" rIns="0" bIns="0" anchor="ctr">
-            <a:noAutofit/>
-          </a:bodyPr>
-          <a:lstStyle xmlns:a="http://schemas.openxmlformats.org/drawingml/2006/main"/>
-          <a:p xmlns:a="http://schemas.openxmlformats.org/drawingml/2006/main">
-            <a:pPr algn="r">
-              <a:lnSpc>
-                <a:spcPct val="100000"/>
-              </a:lnSpc>
-              <a:buNone/>
-              <a:defRPr sz="1350" b="1">
-                <a:solidFill>
-                  <a:srgbClr val="00A2EB"/>
-                </a:solidFill>
-                <a:latin typeface="Calibri"/>
-                <a:ea typeface="Calibri"/>
-                <a:cs typeface="Calibri"/>
-              </a:defRPr>
-            </a:pPr>
-            <a:r>
-              <a:rPr sz="1800" b="1">
-                <a:solidFill>
-                  <a:srgbClr val="00A2EB"/>
-                </a:solidFill>
-                <a:latin typeface="Calibri"/>
-                <a:ea typeface="Calibri"/>
-                <a:cs typeface="Calibri"/>
-              </a:rPr>
-              <a:t>context</a:t>
-            </a:r>
-          </a:p>
-        </p:txBody>
-      </p:sp>
-      <p:sp>
-        <p:nvSpPr>
-          <p:cNvPr id="21" name="">
-            <a:extLst xmlns:a="http://schemas.openxmlformats.org/drawingml/2006/main">
-              <a:ext uri="{FF2B5EF4-FFF2-40B4-BE49-F238E27FC236}">
-                <a16:creationId xmlns:a16="http://schemas.microsoft.com/office/drawing/2014/main" id="{DA8DF2BD-542C-4821-AB60-F914C2D7D54D}"/>
-              </a:ext>
-            </a:extLst>
-          </p:cNvPr>
-          <p:cNvSpPr>
-            <a:spLocks xmlns:a="http://schemas.openxmlformats.org/drawingml/2006/main" noGrp="1"/>
-          </p:cNvSpPr>
-          <p:nvPr/>
-        </p:nvSpPr>
-        <p:spPr>
-          <a:xfrm xmlns:a="http://schemas.openxmlformats.org/drawingml/2006/main">
-            <a:off x="1028700" y="5734050"/>
-            <a:ext cx="2476500" cy="361950"/>
-          </a:xfrm>
-          <a:prstGeom xmlns:a="http://schemas.openxmlformats.org/drawingml/2006/main" prst="rect">
-            <a:avLst/>
-          </a:prstGeom>
-          <a:noFill xmlns:a="http://schemas.openxmlformats.org/drawingml/2006/main"/>
-          <a:ln xmlns:a="http://schemas.openxmlformats.org/drawingml/2006/main" w="0">
-            <a:noFill/>
-            <a:prstDash val="solid"/>
-          </a:ln>
-        </p:spPr>
-        <p:txBody>
-          <a:bodyPr xmlns:a="http://schemas.openxmlformats.org/drawingml/2006/main" wrap="square" lIns="0" tIns="0" rIns="0" bIns="0" anchor="ctr">
-            <a:noAutofit/>
-          </a:bodyPr>
-          <a:lstStyle xmlns:a="http://schemas.openxmlformats.org/drawingml/2006/main"/>
-          <a:p xmlns:a="http://schemas.openxmlformats.org/drawingml/2006/main">
-            <a:pPr algn="l">
-              <a:lnSpc>
-                <a:spcPct val="100000"/>
-              </a:lnSpc>
-              <a:buNone/>
-              <a:defRPr sz="1350" b="1">
-                <a:solidFill>
-                  <a:srgbClr val="2E8B57"/>
-                </a:solidFill>
-                <a:latin typeface="Calibri"/>
-                <a:ea typeface="Calibri"/>
-                <a:cs typeface="Calibri"/>
-              </a:defRPr>
-            </a:pPr>
-            <a:r>
-              <a:rPr sz="1800" b="1">
-                <a:solidFill>
-                  <a:srgbClr val="2E8B57"/>
-                </a:solidFill>
-                <a:latin typeface="Calibri"/>
-                <a:ea typeface="Calibri"/>
-                <a:cs typeface="Calibri"/>
-              </a:rPr>
-              <a:t>CORRECTED REQUEST</a:t>
-            </a:r>
-          </a:p>
-        </p:txBody>
-      </p:sp>
-      <p:sp>
-        <p:nvSpPr>
-          <p:cNvPr id="22" name="">
-            <a:extLst xmlns:a="http://schemas.openxmlformats.org/drawingml/2006/main">
-              <a:ext uri="{FF2B5EF4-FFF2-40B4-BE49-F238E27FC236}">
-                <a16:creationId xmlns:a16="http://schemas.microsoft.com/office/drawing/2014/main" id="{80D1C47B-0B67-4AFB-8BDC-2F9D29D00182}"/>
-              </a:ext>
-            </a:extLst>
-          </p:cNvPr>
-          <p:cNvSpPr>
-            <a:spLocks xmlns:a="http://schemas.openxmlformats.org/drawingml/2006/main" noGrp="1"/>
-          </p:cNvSpPr>
-          <p:nvPr/>
-        </p:nvSpPr>
-        <p:spPr>
-          <a:xfrm xmlns:a="http://schemas.openxmlformats.org/drawingml/2006/main">
-            <a:off x="3714750" y="5676900"/>
-            <a:ext cx="3314700" cy="647700"/>
-          </a:xfrm>
-          <a:prstGeom xmlns:a="http://schemas.openxmlformats.org/drawingml/2006/main" prst="roundRect">
-            <a:avLst>
-              <a:gd name="adj" fmla="val 5882"/>
-            </a:avLst>
-          </a:prstGeom>
-          <a:solidFill xmlns:a="http://schemas.openxmlformats.org/drawingml/2006/main">
-            <a:srgbClr val="1F40CB"/>
-          </a:solidFill>
-          <a:ln xmlns:a="http://schemas.openxmlformats.org/drawingml/2006/main" w="9525">
-            <a:solidFill>
-              <a:srgbClr val="FFFFFF"/>
-            </a:solidFill>
-            <a:prstDash val="solid"/>
-          </a:ln>
-        </p:spPr>
-      </p:sp>
-      <p:sp>
-        <p:nvSpPr>
-          <p:cNvPr id="23" name="">
-            <a:extLst xmlns:a="http://schemas.openxmlformats.org/drawingml/2006/main">
-              <a:ext uri="{FF2B5EF4-FFF2-40B4-BE49-F238E27FC236}">
-                <a16:creationId xmlns:a16="http://schemas.microsoft.com/office/drawing/2014/main" id="{0E2F7603-BBFF-4854-9F2D-F8FF1E3B19D5}"/>
-              </a:ext>
-            </a:extLst>
-          </p:cNvPr>
-          <p:cNvSpPr>
-            <a:spLocks xmlns:a="http://schemas.openxmlformats.org/drawingml/2006/main" noGrp="1"/>
-          </p:cNvSpPr>
-          <p:nvPr/>
-        </p:nvSpPr>
-        <p:spPr>
-          <a:xfrm xmlns:a="http://schemas.openxmlformats.org/drawingml/2006/main">
-            <a:off x="3810000" y="5772150"/>
-            <a:ext cx="3124200" cy="457200"/>
-          </a:xfrm>
-          <a:prstGeom xmlns:a="http://schemas.openxmlformats.org/drawingml/2006/main" prst="rect">
-            <a:avLst/>
-          </a:prstGeom>
-          <a:noFill xmlns:a="http://schemas.openxmlformats.org/drawingml/2006/main"/>
-          <a:ln xmlns:a="http://schemas.openxmlformats.org/drawingml/2006/main" w="0">
-            <a:noFill/>
-            <a:prstDash val="solid"/>
-          </a:ln>
-        </p:spPr>
-        <p:txBody>
-          <a:bodyPr xmlns:a="http://schemas.openxmlformats.org/drawingml/2006/main" wrap="square" lIns="0" tIns="0" rIns="0" bIns="0" anchor="ctr">
-            <a:noAutofit/>
-          </a:bodyPr>
-          <a:lstStyle xmlns:a="http://schemas.openxmlformats.org/drawingml/2006/main"/>
-          <a:p xmlns:a="http://schemas.openxmlformats.org/drawingml/2006/main">
-            <a:pPr algn="ctr">
-              <a:lnSpc>
-                <a:spcPct val="100000"/>
-              </a:lnSpc>
-              <a:buNone/>
-              <a:defRPr sz="1275" b="1">
-                <a:solidFill>
-                  <a:srgbClr val="FFFFFF"/>
-                </a:solidFill>
-                <a:latin typeface="Calibri"/>
-                <a:ea typeface="Calibri"/>
-                <a:cs typeface="Calibri"/>
-              </a:defRPr>
-            </a:pPr>
-            <a:r>
-              <a:rPr sz="1800" b="1">
-                <a:solidFill>
-                  <a:srgbClr val="FFFFFF"/>
-                </a:solidFill>
-                <a:latin typeface="Calibri"/>
-                <a:ea typeface="Calibri"/>
-                <a:cs typeface="Calibri"/>
-              </a:rPr>
-              <a:t>ticker = NVDA</a:t>
-            </a:r>
-          </a:p>
-        </p:txBody>
-      </p:sp>
-      <p:sp>
-        <p:nvSpPr>
-          <p:cNvPr id="24" name="">
-            <a:extLst xmlns:a="http://schemas.openxmlformats.org/drawingml/2006/main">
-              <a:ext uri="{FF2B5EF4-FFF2-40B4-BE49-F238E27FC236}">
-                <a16:creationId xmlns:a16="http://schemas.microsoft.com/office/drawing/2014/main" id="{518F6C86-F0E1-4812-B3DD-797EA0ED5A4E}"/>
-              </a:ext>
-            </a:extLst>
-          </p:cNvPr>
-          <p:cNvSpPr>
-            <a:spLocks xmlns:a="http://schemas.openxmlformats.org/drawingml/2006/main" noGrp="1"/>
-          </p:cNvSpPr>
-          <p:nvPr/>
-        </p:nvSpPr>
-        <p:spPr>
-          <a:xfrm xmlns:a="http://schemas.openxmlformats.org/drawingml/2006/main">
-            <a:off x="7086600" y="5676900"/>
-            <a:ext cx="4781550" cy="647700"/>
-          </a:xfrm>
-          <a:prstGeom xmlns:a="http://schemas.openxmlformats.org/drawingml/2006/main" prst="roundRect">
-            <a:avLst>
-              <a:gd name="adj" fmla="val 5882"/>
-            </a:avLst>
-          </a:prstGeom>
-          <a:solidFill xmlns:a="http://schemas.openxmlformats.org/drawingml/2006/main">
-            <a:srgbClr val="2E8B57"/>
-          </a:solidFill>
-          <a:ln xmlns:a="http://schemas.openxmlformats.org/drawingml/2006/main" w="9525">
-            <a:solidFill>
-              <a:srgbClr val="FFFFFF"/>
-            </a:solidFill>
-            <a:prstDash val="solid"/>
-          </a:ln>
-        </p:spPr>
-      </p:sp>
-      <p:sp>
-        <p:nvSpPr>
-          <p:cNvPr id="25" name="">
-            <a:extLst xmlns:a="http://schemas.openxmlformats.org/drawingml/2006/main">
-              <a:ext uri="{FF2B5EF4-FFF2-40B4-BE49-F238E27FC236}">
-                <a16:creationId xmlns:a16="http://schemas.microsoft.com/office/drawing/2014/main" id="{B9A6A990-C3AB-4ED0-A029-B6138AA54242}"/>
-              </a:ext>
-            </a:extLst>
-          </p:cNvPr>
-          <p:cNvSpPr>
-            <a:spLocks xmlns:a="http://schemas.openxmlformats.org/drawingml/2006/main" noGrp="1"/>
-          </p:cNvSpPr>
-          <p:nvPr/>
-        </p:nvSpPr>
-        <p:spPr>
-          <a:xfrm xmlns:a="http://schemas.openxmlformats.org/drawingml/2006/main">
-            <a:off x="7181850" y="5772150"/>
-            <a:ext cx="4591050" cy="457200"/>
-          </a:xfrm>
-          <a:prstGeom xmlns:a="http://schemas.openxmlformats.org/drawingml/2006/main" prst="rect">
-            <a:avLst/>
-          </a:prstGeom>
-          <a:noFill xmlns:a="http://schemas.openxmlformats.org/drawingml/2006/main"/>
-          <a:ln xmlns:a="http://schemas.openxmlformats.org/drawingml/2006/main" w="0">
-            <a:noFill/>
-            <a:prstDash val="solid"/>
-          </a:ln>
-        </p:spPr>
-        <p:txBody>
-          <a:bodyPr xmlns:a="http://schemas.openxmlformats.org/drawingml/2006/main" wrap="square" lIns="0" tIns="0" rIns="0" bIns="0" anchor="ctr">
-            <a:noAutofit/>
-          </a:bodyPr>
-          <a:lstStyle xmlns:a="http://schemas.openxmlformats.org/drawingml/2006/main"/>
-          <a:p xmlns:a="http://schemas.openxmlformats.org/drawingml/2006/main">
-            <a:pPr algn="ctr">
-              <a:lnSpc>
-                <a:spcPct val="100000"/>
-              </a:lnSpc>
-              <a:buNone/>
-              <a:defRPr sz="1275" b="1">
-                <a:solidFill>
-                  <a:srgbClr val="FFFFFF"/>
-                </a:solidFill>
-                <a:latin typeface="Calibri"/>
-                <a:ea typeface="Calibri"/>
-                <a:cs typeface="Calibri"/>
-              </a:defRPr>
-            </a:pPr>
-            <a:r>
-              <a:rPr sz="1800" b="1">
-                <a:solidFill>
-                  <a:srgbClr val="FFFFFF"/>
-                </a:solidFill>
-                <a:latin typeface="Calibri"/>
-                <a:ea typeface="Calibri"/>
-                <a:cs typeface="Calibri"/>
-              </a:rPr>
-              <a:t>metric = P/E</a:t>
-            </a:r>
-          </a:p>
-        </p:txBody>
-      </p:sp>
-      <p:sp>
-        <p:nvSpPr>
-          <p:cNvPr id="26" name="">
-            <a:extLst xmlns:a="http://schemas.openxmlformats.org/drawingml/2006/main">
-              <a:ext uri="{FF2B5EF4-FFF2-40B4-BE49-F238E27FC236}">
-                <a16:creationId xmlns:a16="http://schemas.microsoft.com/office/drawing/2014/main" id="{24845B58-81DD-48AA-9B5B-C9CA27F8A4A0}"/>
-              </a:ext>
-            </a:extLst>
-          </p:cNvPr>
-          <p:cNvSpPr>
-            <a:spLocks xmlns:a="http://schemas.openxmlformats.org/drawingml/2006/main" noGrp="1"/>
-          </p:cNvSpPr>
-          <p:nvPr/>
-        </p:nvSpPr>
-        <p:spPr>
-          <a:xfrm xmlns:a="http://schemas.openxmlformats.org/drawingml/2006/main">
-            <a:off x="12001500" y="5734050"/>
-            <a:ext cx="2190750" cy="361950"/>
-          </a:xfrm>
-          <a:prstGeom xmlns:a="http://schemas.openxmlformats.org/drawingml/2006/main" prst="rect">
-            <a:avLst/>
-          </a:prstGeom>
-          <a:noFill xmlns:a="http://schemas.openxmlformats.org/drawingml/2006/main"/>
-          <a:ln xmlns:a="http://schemas.openxmlformats.org/drawingml/2006/main" w="0">
-            <a:noFill/>
-            <a:prstDash val="solid"/>
-          </a:ln>
-        </p:spPr>
-        <p:txBody>
-          <a:bodyPr xmlns:a="http://schemas.openxmlformats.org/drawingml/2006/main" wrap="square" lIns="0" tIns="0" rIns="0" bIns="0" anchor="ctr">
-            <a:noAutofit/>
-          </a:bodyPr>
-          <a:lstStyle xmlns:a="http://schemas.openxmlformats.org/drawingml/2006/main"/>
-          <a:p xmlns:a="http://schemas.openxmlformats.org/drawingml/2006/main">
-            <a:pPr algn="r">
-              <a:lnSpc>
-                <a:spcPct val="100000"/>
-              </a:lnSpc>
-              <a:buNone/>
-              <a:defRPr sz="1350" b="1">
-                <a:solidFill>
-                  <a:srgbClr val="2E8B57"/>
-                </a:solidFill>
-                <a:latin typeface="Calibri"/>
-                <a:ea typeface="Calibri"/>
-                <a:cs typeface="Calibri"/>
-              </a:defRPr>
-            </a:pPr>
-            <a:r>
-              <a:rPr sz="1800" b="1">
-                <a:solidFill>
-                  <a:srgbClr val="2E8B57"/>
-                </a:solidFill>
-                <a:latin typeface="Calibri"/>
-                <a:ea typeface="Calibri"/>
-                <a:cs typeface="Calibri"/>
-              </a:rPr>
-              <a:t>valid</a:t>
-            </a:r>
-          </a:p>
-        </p:txBody>
-      </p:sp>
-      <p:sp>
-        <p:nvSpPr>
-          <p:cNvPr id="27" name="">
-            <a:extLst xmlns:a="http://schemas.openxmlformats.org/drawingml/2006/main">
-              <a:ext uri="{FF2B5EF4-FFF2-40B4-BE49-F238E27FC236}">
-                <a16:creationId xmlns:a16="http://schemas.microsoft.com/office/drawing/2014/main" id="{1F021015-2BDE-427C-B7E6-89D40DC755A5}"/>
-              </a:ext>
-            </a:extLst>
-          </p:cNvPr>
-          <p:cNvSpPr>
-            <a:spLocks xmlns:a="http://schemas.openxmlformats.org/drawingml/2006/main" noGrp="1"/>
-          </p:cNvSpPr>
-          <p:nvPr/>
-        </p:nvSpPr>
-        <p:spPr>
-          <a:xfrm xmlns:a="http://schemas.openxmlformats.org/drawingml/2006/main">
-            <a:off x="3714750" y="2819400"/>
-            <a:ext cx="28575" cy="3486150"/>
-          </a:xfrm>
-          <a:prstGeom xmlns:a="http://schemas.openxmlformats.org/drawingml/2006/main" prst="rect">
-            <a:avLst/>
-          </a:prstGeom>
-          <a:solidFill xmlns:a="http://schemas.openxmlformats.org/drawingml/2006/main">
-            <a:srgbClr val="E4E7E9"/>
-          </a:solidFill>
-          <a:ln xmlns:a="http://schemas.openxmlformats.org/drawingml/2006/main" w="0">
-            <a:solidFill>
-              <a:srgbClr val="E4E7E9"/>
-            </a:solidFill>
-            <a:prstDash val="solid"/>
-          </a:ln>
-        </p:spPr>
+              <a:t>External feedback changes the next action</a:t>
+            </a:r>
+          </a:p>
+        </p:txBody>
       </p:sp>
       <p:sp>
         <p:nvSpPr>
@@ -8634,7 +6341,7 @@
                 <a:ea typeface="Calibri"/>
                 <a:cs typeface="Calibri"/>
               </a:rPr>
-              <a:t>The tool returns a typed observation. The notebook does not crash.</a:t>
+              <a:t>External feedback changes an action. Self-critique evaluates a generated answer.</a:t>
             </a:r>
           </a:p>
         </p:txBody>
@@ -8891,6 +6598,28 @@
           </a:p>
         </p:txBody>
       </p:sp>
+      <p:pic>
+        <p:nvPicPr>
+          <p:cNvPr id="46" name=""/>
+          <p:cNvPicPr>
+            <a:picLocks xmlns:a="http://schemas.openxmlformats.org/drawingml/2006/main" noChangeAspect="1"/>
+          </p:cNvPicPr>
+          <p:nvPr/>
+        </p:nvPicPr>
+        <p:blipFill>
+          <a:blip xmlns:r="http://schemas.openxmlformats.org/officeDocument/2006/relationships" xmlns:a="http://schemas.openxmlformats.org/drawingml/2006/main" r:embed="R9f4ee02f0dbf41fd"/>
+          <a:stretch xmlns:a="http://schemas.openxmlformats.org/drawingml/2006/main"/>
+        </p:blipFill>
+        <p:spPr>
+          <a:xfrm xmlns:a="http://schemas.openxmlformats.org/drawingml/2006/main">
+            <a:off x="4499610" y="2095500"/>
+            <a:ext cx="6240780" cy="4333875"/>
+          </a:xfrm>
+          <a:prstGeom xmlns:a="http://schemas.openxmlformats.org/drawingml/2006/main" prst="rect">
+            <a:avLst/>
+          </a:prstGeom>
+        </p:spPr>
+      </p:pic>
     </p:spTree>
     <p:extLst>
       <p:ext uri="{BB962C8B-B14F-4D97-AF65-F5344CB8AC3E}">
@@ -8977,7 +6706,7 @@
                 <a:ea typeface="Calibri"/>
                 <a:cs typeface="Calibri"/>
               </a:rPr>
-              <a:t>CONDITIONAL ROUTING</a:t>
+              <a:t>LANGGRAPH MAKES THE RECOVERY ROUTE EXPLICIT</a:t>
             </a:r>
           </a:p>
         </p:txBody>
@@ -9101,7 +6830,7 @@
                 <a:ea typeface="Calibri"/>
                 <a:cs typeface="Calibri"/>
               </a:rPr>
-              <a:t>AGENT ACTION</a:t>
+              <a:t>MODEL ACTION</a:t>
             </a:r>
           </a:p>
         </p:txBody>
@@ -9392,7 +7121,7 @@
                 <a:ea typeface="Calibri"/>
                 <a:cs typeface="Calibri"/>
               </a:rPr>
-              <a:t>check budgets</a:t>
+              <a:t>update state</a:t>
             </a:r>
           </a:p>
         </p:txBody>
@@ -9613,7 +7342,7 @@
                 <a:ea typeface="Calibri"/>
                 <a:cs typeface="Calibri"/>
               </a:rPr>
-              <a:t>TOOL RESULT</a:t>
+              <a:t>TOOL OBSERVATION</a:t>
             </a:r>
           </a:p>
         </p:txBody>
@@ -9904,7 +7633,7 @@
                 <a:ea typeface="Calibri"/>
                 <a:cs typeface="Calibri"/>
               </a:rPr>
-              <a:t>update state</a:t>
+              <a:t>store feedback</a:t>
             </a:r>
           </a:p>
         </p:txBody>
@@ -10028,7 +7757,7 @@
                 <a:ea typeface="Calibri"/>
                 <a:cs typeface="Calibri"/>
               </a:rPr>
-              <a:t>BUDGET CHECK</a:t>
+              <a:t>APPLICATION GUARDS</a:t>
             </a:r>
           </a:p>
         </p:txBody>
@@ -10414,7 +8143,7 @@
                 <a:ea typeface="Calibri"/>
                 <a:cs typeface="Calibri"/>
               </a:rPr>
-              <a:t>The model proposes. LangGraph routes. Python executes.</a:t>
+              <a:t>The model proposes. LangGraph routes. Python validates and executes.</a:t>
             </a:r>
           </a:p>
         </p:txBody>
@@ -10757,7 +8486,7 @@
                 <a:ea typeface="Calibri"/>
                 <a:cs typeface="Calibri"/>
               </a:rPr>
-              <a:t>FIRST ATTEMPT</a:t>
+              <a:t>TYPED FEEDBACK</a:t>
             </a:r>
           </a:p>
         </p:txBody>
@@ -10819,7 +8548,7 @@
                 <a:ea typeface="Calibri"/>
                 <a:cs typeface="Calibri"/>
               </a:rPr>
-              <a:t>The tool rejects PE and returns the valid names</a:t>
+              <a:t>A precise error is a prompt for the next action</a:t>
             </a:r>
           </a:p>
         </p:txBody>
@@ -11482,7 +9211,7 @@
                 <a:ea typeface="Calibri"/>
                 <a:cs typeface="Calibri"/>
               </a:rPr>
-              <a:t>validate request</a:t>
+              <a:t>unsupported_metric</a:t>
             </a:r>
           </a:p>
         </p:txBody>
@@ -11641,7 +9370,7 @@
                 <a:ea typeface="Calibri"/>
                 <a:cs typeface="Calibri"/>
               </a:rPr>
-              <a:t>Error</a:t>
+              <a:t>Feedback</a:t>
             </a:r>
           </a:p>
         </p:txBody>
@@ -11703,7 +9432,7 @@
                 <a:ea typeface="Calibri"/>
                 <a:cs typeface="Calibri"/>
               </a:rPr>
-              <a:t>unsupported_metric</a:t>
+              <a:t>Valid metrics: EPS, P/E</a:t>
             </a:r>
           </a:p>
         </p:txBody>
@@ -11924,14 +9653,14 @@
                 <a:ea typeface="Calibri"/>
                 <a:cs typeface="Calibri"/>
               </a:rPr>
-              <a:t>EPS, P/E</a:t>
+              <a:t>retryable = true</a:t>
             </a:r>
           </a:p>
         </p:txBody>
       </p:sp>
       <p:cxnSp>
         <p:nvCxnSpPr>
-          <p:cNvPr id="577" name=""/>
+          <p:cNvPr id="629" name=""/>
           <p:cNvCxnSpPr>
             <a:stCxn xmlns:a="http://schemas.openxmlformats.org/drawingml/2006/main" id="3" idx="3"/>
             <a:endCxn xmlns:a="http://schemas.openxmlformats.org/drawingml/2006/main" id="7" idx="1"/>
@@ -11957,7 +9686,7 @@
       </p:cxnSp>
       <p:cxnSp>
         <p:nvCxnSpPr>
-          <p:cNvPr id="578" name=""/>
+          <p:cNvPr id="630" name=""/>
           <p:cNvCxnSpPr>
             <a:stCxn xmlns:a="http://schemas.openxmlformats.org/drawingml/2006/main" id="7" idx="3"/>
             <a:endCxn xmlns:a="http://schemas.openxmlformats.org/drawingml/2006/main" id="11" idx="1"/>
@@ -11983,7 +9712,7 @@
       </p:cxnSp>
       <p:cxnSp>
         <p:nvCxnSpPr>
-          <p:cNvPr id="579" name=""/>
+          <p:cNvPr id="631" name=""/>
           <p:cNvCxnSpPr>
             <a:stCxn xmlns:a="http://schemas.openxmlformats.org/drawingml/2006/main" id="11" idx="3"/>
             <a:endCxn xmlns:a="http://schemas.openxmlformats.org/drawingml/2006/main" id="15" idx="1"/>
@@ -12009,7 +9738,7 @@
       </p:cxnSp>
       <p:cxnSp>
         <p:nvCxnSpPr>
-          <p:cNvPr id="580" name=""/>
+          <p:cNvPr id="632" name=""/>
           <p:cNvCxnSpPr>
             <a:stCxn xmlns:a="http://schemas.openxmlformats.org/drawingml/2006/main" id="15" idx="3"/>
             <a:endCxn xmlns:a="http://schemas.openxmlformats.org/drawingml/2006/main" id="19" idx="1"/>
@@ -12090,7 +9819,7 @@
                 <a:ea typeface="Calibri"/>
                 <a:cs typeface="Calibri"/>
               </a:rPr>
-              <a:t>Nothing is hidden. The failed action stays in the trace.</a:t>
+              <a:t>The rejected value and valid alternatives remain visible in the trace.</a:t>
             </a:r>
           </a:p>
         </p:txBody>
@@ -12557,7 +10286,7 @@
                 <a:ea typeface="Calibri"/>
                 <a:cs typeface="Calibri"/>
               </a:rPr>
-              <a:t>SELF-CORRECTION</a:t>
+              <a:t>CORRECTED PATH</a:t>
             </a:r>
           </a:p>
         </p:txBody>
@@ -12619,7 +10348,7 @@
                 <a:ea typeface="Calibri"/>
                 <a:cs typeface="Calibri"/>
               </a:rPr>
-              <a:t>The agent reads the error and retries with P/E</a:t>
+              <a:t>The agent uses the valid name returned by the tool</a:t>
             </a:r>
           </a:p>
         </p:txBody>
@@ -12778,7 +10507,7 @@
                 <a:ea typeface="Calibri"/>
                 <a:cs typeface="Calibri"/>
               </a:rPr>
-              <a:t>Observe</a:t>
+              <a:t>Error observed</a:t>
             </a:r>
           </a:p>
         </p:txBody>
@@ -12999,7 +10728,7 @@
                 <a:ea typeface="Calibri"/>
                 <a:cs typeface="Calibri"/>
               </a:rPr>
-              <a:t>Correct</a:t>
+              <a:t>Correct request</a:t>
             </a:r>
           </a:p>
         </p:txBody>
@@ -13731,7 +11460,7 @@
       </p:sp>
       <p:cxnSp>
         <p:nvCxnSpPr>
-          <p:cNvPr id="577" name=""/>
+          <p:cNvPr id="629" name=""/>
           <p:cNvCxnSpPr>
             <a:stCxn xmlns:a="http://schemas.openxmlformats.org/drawingml/2006/main" id="3" idx="3"/>
             <a:endCxn xmlns:a="http://schemas.openxmlformats.org/drawingml/2006/main" id="7" idx="1"/>
@@ -13757,7 +11486,7 @@
       </p:cxnSp>
       <p:cxnSp>
         <p:nvCxnSpPr>
-          <p:cNvPr id="578" name=""/>
+          <p:cNvPr id="630" name=""/>
           <p:cNvCxnSpPr>
             <a:stCxn xmlns:a="http://schemas.openxmlformats.org/drawingml/2006/main" id="7" idx="3"/>
             <a:endCxn xmlns:a="http://schemas.openxmlformats.org/drawingml/2006/main" id="11" idx="1"/>
@@ -13783,7 +11512,7 @@
       </p:cxnSp>
       <p:cxnSp>
         <p:nvCxnSpPr>
-          <p:cNvPr id="579" name=""/>
+          <p:cNvPr id="631" name=""/>
           <p:cNvCxnSpPr>
             <a:stCxn xmlns:a="http://schemas.openxmlformats.org/drawingml/2006/main" id="11" idx="3"/>
             <a:endCxn xmlns:a="http://schemas.openxmlformats.org/drawingml/2006/main" id="15" idx="1"/>
@@ -13809,7 +11538,7 @@
       </p:cxnSp>
       <p:cxnSp>
         <p:nvCxnSpPr>
-          <p:cNvPr id="580" name=""/>
+          <p:cNvPr id="632" name=""/>
           <p:cNvCxnSpPr>
             <a:stCxn xmlns:a="http://schemas.openxmlformats.org/drawingml/2006/main" id="15" idx="3"/>
             <a:endCxn xmlns:a="http://schemas.openxmlformats.org/drawingml/2006/main" id="19" idx="1"/>
@@ -14357,7 +12086,7 @@
                 <a:ea typeface="Calibri"/>
                 <a:cs typeface="Calibri"/>
               </a:rPr>
-              <a:t>BOUNDED RECOVERY</a:t>
+              <a:t>BOUNDED OUTCOMES</a:t>
             </a:r>
           </a:p>
         </p:txBody>
@@ -14419,7 +12148,7 @@
                 <a:ea typeface="Calibri"/>
                 <a:cs typeface="Calibri"/>
               </a:rPr>
-              <a:t>Two budgets prevent an endless loop</a:t>
+              <a:t>The same graph can complete safely or stop safely</a:t>
             </a:r>
           </a:p>
         </p:txBody>
@@ -14481,7 +12210,7 @@
                 <a:ea typeface="Calibri"/>
                 <a:cs typeface="Calibri"/>
               </a:rPr>
-              <a:t>MAX_RETRIES = 1</a:t>
+              <a:t>CORRECTED PATH</a:t>
             </a:r>
           </a:p>
         </p:txBody>
@@ -14578,7 +12307,7 @@
                 <a:ea typeface="Calibri"/>
                 <a:cs typeface="Calibri"/>
               </a:rPr>
-              <a:t>one retry</a:t>
+              <a:t>PE fails</a:t>
             </a:r>
           </a:p>
         </p:txBody>
@@ -14675,7 +12404,7 @@
                 <a:ea typeface="Calibri"/>
                 <a:cs typeface="Calibri"/>
               </a:rPr>
-              <a:t>model errors</a:t>
+              <a:t>P/E succeeds</a:t>
             </a:r>
           </a:p>
         </p:txBody>
@@ -14772,7 +12501,7 @@
                 <a:ea typeface="Calibri"/>
                 <a:cs typeface="Calibri"/>
               </a:rPr>
-              <a:t>second failure</a:t>
+              <a:t>two companies</a:t>
             </a:r>
           </a:p>
         </p:txBody>
@@ -14869,7 +12598,7 @@
                 <a:ea typeface="Calibri"/>
                 <a:cs typeface="Calibri"/>
               </a:rPr>
-              <a:t>STOP</a:t>
+              <a:t>FINISH</a:t>
             </a:r>
           </a:p>
         </p:txBody>
@@ -14931,7 +12660,7 @@
                 <a:ea typeface="Calibri"/>
                 <a:cs typeface="Calibri"/>
               </a:rPr>
-              <a:t>BOUND</a:t>
+              <a:t>COMPLETED</a:t>
             </a:r>
           </a:p>
         </p:txBody>
@@ -14993,7 +12722,7 @@
                 <a:ea typeface="Calibri"/>
                 <a:cs typeface="Calibri"/>
               </a:rPr>
-              <a:t>MAX_TOOL_CALLS = 4</a:t>
+              <a:t>REPEATED FAILURE</a:t>
             </a:r>
           </a:p>
         </p:txBody>
@@ -15090,7 +12819,7 @@
                 <a:ea typeface="Calibri"/>
                 <a:cs typeface="Calibri"/>
               </a:rPr>
-              <a:t>all calls</a:t>
+              <a:t>PE fails</a:t>
             </a:r>
           </a:p>
         </p:txBody>
@@ -15187,7 +12916,7 @@
                 <a:ea typeface="Calibri"/>
                 <a:cs typeface="Calibri"/>
               </a:rPr>
-              <a:t>success + error</a:t>
+              <a:t>PE repeats</a:t>
             </a:r>
           </a:p>
         </p:txBody>
@@ -15284,7 +13013,7 @@
                 <a:ea typeface="Calibri"/>
                 <a:cs typeface="Calibri"/>
               </a:rPr>
-              <a:t>fourth call</a:t>
+              <a:t>retry budget</a:t>
             </a:r>
           </a:p>
         </p:txBody>
@@ -15408,7 +13137,7 @@
                 <a:ea typeface="Calibri"/>
                 <a:cs typeface="Calibri"/>
               </a:rPr>
-              <a:t>FINAL ANSWER</a:t>
+              <a:t>BOUNDARY</a:t>
             </a:r>
           </a:p>
         </p:txBody>
@@ -15505,7 +13234,7 @@
                 <a:ea typeface="Calibri"/>
                 <a:cs typeface="Calibri"/>
               </a:rPr>
-              <a:t>evidence required</a:t>
+              <a:t>MAX_RETRIES = 1</a:t>
             </a:r>
           </a:p>
         </p:txBody>
@@ -15602,7 +13331,7 @@
                 <a:ea typeface="Calibri"/>
                 <a:cs typeface="Calibri"/>
               </a:rPr>
-              <a:t>no successful data</a:t>
+              <a:t>MAX_TOOL_CALLS = 4</a:t>
             </a:r>
           </a:p>
         </p:txBody>
@@ -15664,7 +13393,7 @@
                 <a:ea typeface="Calibri"/>
                 <a:cs typeface="Calibri"/>
               </a:rPr>
-              <a:t>REFUSE</a:t>
+              <a:t>CODE-OWNED</a:t>
             </a:r>
           </a:p>
         </p:txBody>
@@ -16199,7 +13928,7 @@
                 <a:ea typeface="Calibri"/>
                 <a:cs typeface="Calibri"/>
               </a:rPr>
-              <a:t>Self-correction needs feedback, state and limits</a:t>
+              <a:t>Self-correction does not guarantee truth</a:t>
             </a:r>
           </a:p>
         </p:txBody>
@@ -16296,7 +14025,7 @@
                 <a:ea typeface="Calibri"/>
                 <a:cs typeface="Calibri"/>
               </a:rPr>
-              <a:t>PROMPT</a:t>
+              <a:t>FEEDBACK</a:t>
             </a:r>
           </a:p>
         </p:txBody>
@@ -16358,7 +14087,7 @@
                 <a:ea typeface="Calibri"/>
                 <a:cs typeface="Calibri"/>
               </a:rPr>
-              <a:t>reduces</a:t>
+              <a:t>changes</a:t>
             </a:r>
           </a:p>
           <a:p xmlns:a="http://schemas.openxmlformats.org/drawingml/2006/main">
@@ -16385,7 +14114,7 @@
                 <a:ea typeface="Calibri"/>
                 <a:cs typeface="Calibri"/>
               </a:rPr>
-              <a:t>tool errors</a:t>
+              <a:t>the next action</a:t>
             </a:r>
           </a:p>
         </p:txBody>
@@ -16482,19 +14211,7 @@
                 <a:ea typeface="Calibri"/>
                 <a:cs typeface="Calibri"/>
               </a:rPr>
-              <a:t>LANG</a:t>
-            </a:r>
-            <a:br/>
-            <a:r>
-              <a:rPr sz="1800" b="1">
-                <a:solidFill>
-                  <a:srgbClr val="00A2EB"/>
-                </a:solidFill>
-                <a:latin typeface="Calibri"/>
-                <a:ea typeface="Calibri"/>
-                <a:cs typeface="Calibri"/>
-              </a:rPr>
-              <a:t>GRAPH</a:t>
+              <a:t>APPLICATION</a:t>
             </a:r>
           </a:p>
         </p:txBody>
@@ -16556,7 +14273,7 @@
                 <a:ea typeface="Calibri"/>
                 <a:cs typeface="Calibri"/>
               </a:rPr>
-              <a:t>error feedback</a:t>
+              <a:t>typed state</a:t>
             </a:r>
           </a:p>
           <a:p xmlns:a="http://schemas.openxmlformats.org/drawingml/2006/main">
@@ -16583,7 +14300,7 @@
                 <a:ea typeface="Calibri"/>
                 <a:cs typeface="Calibri"/>
               </a:rPr>
-              <a:t>changes next action</a:t>
+              <a:t>budgets</a:t>
             </a:r>
           </a:p>
           <a:p xmlns:a="http://schemas.openxmlformats.org/drawingml/2006/main">
@@ -16610,7 +14327,7 @@
                 <a:ea typeface="Calibri"/>
                 <a:cs typeface="Calibri"/>
               </a:rPr>
-              <a:t>MAX_RETRIES = 1</a:t>
+              <a:t>evidence</a:t>
             </a:r>
           </a:p>
         </p:txBody>
@@ -16672,34 +14389,7 @@
                 <a:ea typeface="Calibri"/>
                 <a:cs typeface="Calibri"/>
               </a:rPr>
-              <a:t>typed state · clear trace</a:t>
-            </a:r>
-          </a:p>
-          <a:p xmlns:a="http://schemas.openxmlformats.org/drawingml/2006/main">
-            <a:pPr algn="ctr">
-              <a:lnSpc>
-                <a:spcPct val="70000"/>
-              </a:lnSpc>
-              <a:buNone/>
-              <a:defRPr sz="1275" b="0">
-                <a:solidFill>
-                  <a:srgbClr val="1F40CB"/>
-                </a:solidFill>
-                <a:latin typeface="Calibri"/>
-                <a:ea typeface="Calibri"/>
-                <a:cs typeface="Calibri"/>
-              </a:defRPr>
-            </a:pPr>
-            <a:r>
-              <a:rPr sz="1800" b="0">
-                <a:solidFill>
-                  <a:srgbClr val="1F40CB"/>
-                </a:solidFill>
-                <a:latin typeface="Calibri"/>
-                <a:ea typeface="Calibri"/>
-                <a:cs typeface="Calibri"/>
-              </a:rPr>
-              <a:t>MAX_TOOL_CALLS = 4</a:t>
+              <a:t>trace · source · date</a:t>
             </a:r>
           </a:p>
         </p:txBody>
@@ -16892,7 +14582,7 @@
       </p:sp>
       <p:cxnSp>
         <p:nvCxnSpPr>
-          <p:cNvPr id="320" name=""/>
+          <p:cNvPr id="348" name=""/>
           <p:cNvCxnSpPr>
             <a:stCxn xmlns:a="http://schemas.openxmlformats.org/drawingml/2006/main" id="3" idx="3"/>
             <a:endCxn xmlns:a="http://schemas.openxmlformats.org/drawingml/2006/main" id="6" idx="1"/>
@@ -16918,7 +14608,7 @@
       </p:cxnSp>
       <p:cxnSp>
         <p:nvCxnSpPr>
-          <p:cNvPr id="321" name=""/>
+          <p:cNvPr id="349" name=""/>
           <p:cNvCxnSpPr>
             <a:stCxn xmlns:a="http://schemas.openxmlformats.org/drawingml/2006/main" id="6" idx="3"/>
             <a:endCxn xmlns:a="http://schemas.openxmlformats.org/drawingml/2006/main" id="10" idx="1"/>
@@ -17096,7 +14786,7 @@
                 <a:ea typeface="Calibri"/>
                 <a:cs typeface="Calibri"/>
               </a:rPr>
-              <a:t>typed errors · bounded retries</a:t>
+              <a:t>external feedback · bounded retries</a:t>
             </a:r>
           </a:p>
         </p:txBody>
@@ -17253,7 +14943,7 @@
                 <a:ea typeface="Calibri"/>
                 <a:cs typeface="Calibri"/>
               </a:rPr>
-              <a:t>self-correction guarantees truth</a:t>
+              <a:t>a corrected action is a correct answer</a:t>
             </a:r>
           </a:p>
         </p:txBody>

</xml_diff>